<commit_message>
Update presentation export and report authors
</commit_message>
<xml_diff>
--- a/presentations/machine-safety-defense-presentation.pptx
+++ b/presentations/machine-safety-defense-presentation.pptx
@@ -2,23 +2,23 @@
 <file path=ppt/presentation.xml><?xml version="1.0" encoding="utf-8"?>
 <p:presentation xmlns:p="http://schemas.openxmlformats.org/presentationml/2006/main">
   <p:sldMasterIdLst>
-    <p:sldMasterId xmlns:r="http://schemas.openxmlformats.org/officeDocument/2006/relationships" id="2147483648" r:id="Rc09469b379c74d2f"/>
+    <p:sldMasterId xmlns:r="http://schemas.openxmlformats.org/officeDocument/2006/relationships" id="2147483648" r:id="Rc17f6e035f724659"/>
   </p:sldMasterIdLst>
   <p:notesMasterIdLst>
-    <p:notesMasterId xmlns:r="http://schemas.openxmlformats.org/officeDocument/2006/relationships" r:id="Rd80ea86dcf8d4b44"/>
+    <p:notesMasterId xmlns:r="http://schemas.openxmlformats.org/officeDocument/2006/relationships" r:id="R5cfb6e2d49ed43d5"/>
   </p:notesMasterIdLst>
   <p:sldIdLst>
-    <p:sldId xmlns:r="http://schemas.openxmlformats.org/officeDocument/2006/relationships" id="256" r:id="R2010b08cd05c4408"/>
-    <p:sldId xmlns:r="http://schemas.openxmlformats.org/officeDocument/2006/relationships" id="257" r:id="R523b951db0864c92"/>
-    <p:sldId xmlns:r="http://schemas.openxmlformats.org/officeDocument/2006/relationships" id="258" r:id="R3bfca3e83f164267"/>
-    <p:sldId xmlns:r="http://schemas.openxmlformats.org/officeDocument/2006/relationships" id="259" r:id="Rab8941320e194c8f"/>
-    <p:sldId xmlns:r="http://schemas.openxmlformats.org/officeDocument/2006/relationships" id="260" r:id="R69bbb8bfce6c4517"/>
-    <p:sldId xmlns:r="http://schemas.openxmlformats.org/officeDocument/2006/relationships" id="261" r:id="Rc308b5b33b3b4d37"/>
-    <p:sldId xmlns:r="http://schemas.openxmlformats.org/officeDocument/2006/relationships" id="262" r:id="R1242a9c837df4497"/>
-    <p:sldId xmlns:r="http://schemas.openxmlformats.org/officeDocument/2006/relationships" id="263" r:id="R6abb52e2a3034834"/>
-    <p:sldId xmlns:r="http://schemas.openxmlformats.org/officeDocument/2006/relationships" id="264" r:id="R154cddaf7ad94e66"/>
-    <p:sldId xmlns:r="http://schemas.openxmlformats.org/officeDocument/2006/relationships" id="265" r:id="Rf7bb5b8524b64328"/>
-    <p:sldId xmlns:r="http://schemas.openxmlformats.org/officeDocument/2006/relationships" id="266" r:id="R34af092d9c3d4c87"/>
+    <p:sldId xmlns:r="http://schemas.openxmlformats.org/officeDocument/2006/relationships" id="256" r:id="Rd5465b491074431f"/>
+    <p:sldId xmlns:r="http://schemas.openxmlformats.org/officeDocument/2006/relationships" id="257" r:id="R39e1bb4a6b79460a"/>
+    <p:sldId xmlns:r="http://schemas.openxmlformats.org/officeDocument/2006/relationships" id="258" r:id="Rdd3c835927a1407b"/>
+    <p:sldId xmlns:r="http://schemas.openxmlformats.org/officeDocument/2006/relationships" id="259" r:id="R2c12be673f4146fb"/>
+    <p:sldId xmlns:r="http://schemas.openxmlformats.org/officeDocument/2006/relationships" id="260" r:id="R13d596b7a60b452a"/>
+    <p:sldId xmlns:r="http://schemas.openxmlformats.org/officeDocument/2006/relationships" id="261" r:id="Raafe2fdc1bd544c9"/>
+    <p:sldId xmlns:r="http://schemas.openxmlformats.org/officeDocument/2006/relationships" id="262" r:id="Rfc3dbb51164e4df0"/>
+    <p:sldId xmlns:r="http://schemas.openxmlformats.org/officeDocument/2006/relationships" id="263" r:id="R3dcdfa12fb2e4cb1"/>
+    <p:sldId xmlns:r="http://schemas.openxmlformats.org/officeDocument/2006/relationships" id="264" r:id="R43e2ce02dd0d4f66"/>
+    <p:sldId xmlns:r="http://schemas.openxmlformats.org/officeDocument/2006/relationships" id="265" r:id="Raeca7f808bc54fcc"/>
+    <p:sldId xmlns:r="http://schemas.openxmlformats.org/officeDocument/2006/relationships" id="266" r:id="R7d94680507ae43fc"/>
   </p:sldIdLst>
   <p:sldSz cx="12192000" cy="6858000"/>
   <p:notesSz cx="6858000" cy="9144000"/>
@@ -1225,7 +1225,7 @@
   </p:cSld>
   <p:clrMap bg1="lt1" tx1="dk1" bg2="lt2" tx2="dk2" accent1="accent1" accent2="accent2" accent3="accent3" accent4="accent4" accent5="accent5" accent6="accent6" hlink="hlink" folHlink="folHlink"/>
   <p:sldLayoutIdLst>
-    <p:sldLayoutId xmlns:r="http://schemas.openxmlformats.org/officeDocument/2006/relationships" id="2147483649" r:id="R6833f4ef49b746a4"/>
+    <p:sldLayoutId xmlns:r="http://schemas.openxmlformats.org/officeDocument/2006/relationships" id="2147483649" r:id="Rd44402fd23ef4c15"/>
   </p:sldLayoutIdLst>
   <p:txStyles>
     <p:titleStyle>
@@ -1524,7 +1524,7 @@
           <p:cNvPr id="1" name="">
             <a:extLst xmlns:a="http://schemas.openxmlformats.org/drawingml/2006/main">
               <a:ext uri="{FF2B5EF4-FFF2-40B4-BE49-F238E27FC236}">
-                <a16:creationId xmlns:a16="http://schemas.microsoft.com/office/drawing/2014/main" id="{9580D6E0-C7FD-4BE3-84EC-6353A7243D07}"/>
+                <a16:creationId xmlns:a16="http://schemas.microsoft.com/office/drawing/2014/main" id="{9AF69E17-D168-410A-BF37-CF1415AA6E40}"/>
               </a:ext>
             </a:extLst>
           </p:cNvPr>
@@ -1559,7 +1559,7 @@
           <p:cNvPr id="2" name="">
             <a:extLst xmlns:a="http://schemas.openxmlformats.org/drawingml/2006/main">
               <a:ext uri="{FF2B5EF4-FFF2-40B4-BE49-F238E27FC236}">
-                <a16:creationId xmlns:a16="http://schemas.microsoft.com/office/drawing/2014/main" id="{FD6EBA79-971F-4F7E-8A06-1DA36816C3D0}"/>
+                <a16:creationId xmlns:a16="http://schemas.microsoft.com/office/drawing/2014/main" id="{0DE5BD6E-06C0-4351-A2A4-38F1ECD24FDE}"/>
               </a:ext>
             </a:extLst>
           </p:cNvPr>
@@ -1594,7 +1594,7 @@
           <p:cNvPr id="3" name="">
             <a:extLst xmlns:a="http://schemas.openxmlformats.org/drawingml/2006/main">
               <a:ext uri="{FF2B5EF4-FFF2-40B4-BE49-F238E27FC236}">
-                <a16:creationId xmlns:a16="http://schemas.microsoft.com/office/drawing/2014/main" id="{FF58A045-5EB4-496E-8BB0-1D24406CB63A}"/>
+                <a16:creationId xmlns:a16="http://schemas.microsoft.com/office/drawing/2014/main" id="{32278438-DA76-4B51-8BA1-87433AF27940}"/>
               </a:ext>
             </a:extLst>
           </p:cNvPr>
@@ -1658,7 +1658,7 @@
           <p:cNvPr id="4" name="">
             <a:extLst xmlns:a="http://schemas.openxmlformats.org/drawingml/2006/main">
               <a:ext uri="{FF2B5EF4-FFF2-40B4-BE49-F238E27FC236}">
-                <a16:creationId xmlns:a16="http://schemas.microsoft.com/office/drawing/2014/main" id="{84090B82-06A9-4DCA-9607-BCBDF07EC8C5}"/>
+                <a16:creationId xmlns:a16="http://schemas.microsoft.com/office/drawing/2014/main" id="{FD247816-30A3-4A07-8119-B35024948074}"/>
               </a:ext>
             </a:extLst>
           </p:cNvPr>
@@ -1745,7 +1745,7 @@
           <p:cNvPr id="5" name="">
             <a:extLst xmlns:a="http://schemas.openxmlformats.org/drawingml/2006/main">
               <a:ext uri="{FF2B5EF4-FFF2-40B4-BE49-F238E27FC236}">
-                <a16:creationId xmlns:a16="http://schemas.microsoft.com/office/drawing/2014/main" id="{DF6657BA-C162-497F-AAB8-4DDC49D17D9F}"/>
+                <a16:creationId xmlns:a16="http://schemas.microsoft.com/office/drawing/2014/main" id="{ED2C8CD0-0604-4797-817E-1DF2815F0755}"/>
               </a:ext>
             </a:extLst>
           </p:cNvPr>
@@ -1804,16 +1804,126 @@
           </a:p>
         </p:txBody>
       </p:sp>
+      <p:sp>
+        <p:nvSpPr>
+          <p:cNvPr id="6" name="">
+            <a:extLst xmlns:a="http://schemas.openxmlformats.org/drawingml/2006/main">
+              <a:ext uri="{FF2B5EF4-FFF2-40B4-BE49-F238E27FC236}">
+                <a16:creationId xmlns:a16="http://schemas.microsoft.com/office/drawing/2014/main" id="{89FE2334-A9CE-48E1-8423-FC4F3F60B5F2}"/>
+              </a:ext>
+            </a:extLst>
+          </p:cNvPr>
+          <p:cNvSpPr>
+            <a:spLocks xmlns:a="http://schemas.openxmlformats.org/drawingml/2006/main" noGrp="1"/>
+          </p:cNvSpPr>
+          <p:nvPr/>
+        </p:nvSpPr>
+        <p:spPr>
+          <a:xfrm xmlns:a="http://schemas.openxmlformats.org/drawingml/2006/main">
+            <a:off x="628650" y="3105150"/>
+            <a:ext cx="4095750" cy="819150"/>
+          </a:xfrm>
+          <a:prstGeom xmlns:a="http://schemas.openxmlformats.org/drawingml/2006/main" prst="rect">
+            <a:avLst/>
+          </a:prstGeom>
+          <a:solidFill xmlns:a="http://schemas.openxmlformats.org/drawingml/2006/main">
+            <a:srgbClr val="000000">
+              <a:alpha val="0"/>
+            </a:srgbClr>
+          </a:solidFill>
+          <a:ln xmlns:a="http://schemas.openxmlformats.org/drawingml/2006/main" w="0">
+            <a:solidFill>
+              <a:srgbClr val="000000">
+                <a:alpha val="0"/>
+              </a:srgbClr>
+            </a:solidFill>
+            <a:prstDash val="solid"/>
+          </a:ln>
+        </p:spPr>
+        <p:txBody>
+          <a:bodyPr xmlns:a="http://schemas.openxmlformats.org/drawingml/2006/main" lIns="0" tIns="0" rIns="0" bIns="0" anchor="t"/>
+          <a:lstStyle xmlns:a="http://schemas.openxmlformats.org/drawingml/2006/main"/>
+          <a:p xmlns:a="http://schemas.openxmlformats.org/drawingml/2006/main">
+            <a:pPr algn="l">
+              <a:defRPr sz="1350" b="0">
+                <a:solidFill>
+                  <a:srgbClr val="718096"/>
+                </a:solidFill>
+                <a:latin typeface="Aptos"/>
+                <a:ea typeface="Aptos"/>
+                <a:cs typeface="Aptos"/>
+              </a:defRPr>
+            </a:pPr>
+            <a:r>
+              <a:rPr sz="1350" b="0">
+                <a:solidFill>
+                  <a:srgbClr val="718096"/>
+                </a:solidFill>
+                <a:latin typeface="Aptos"/>
+                <a:ea typeface="Aptos"/>
+                <a:cs typeface="Aptos"/>
+              </a:rPr>
+              <a:t>El Fahime Mohamed Zayd</a:t>
+            </a:r>
+          </a:p>
+          <a:p xmlns:a="http://schemas.openxmlformats.org/drawingml/2006/main">
+            <a:pPr algn="l">
+              <a:defRPr sz="1350" b="0">
+                <a:solidFill>
+                  <a:srgbClr val="718096"/>
+                </a:solidFill>
+                <a:latin typeface="Aptos"/>
+                <a:ea typeface="Aptos"/>
+                <a:cs typeface="Aptos"/>
+              </a:defRPr>
+            </a:pPr>
+            <a:r>
+              <a:rPr sz="1350" b="0">
+                <a:solidFill>
+                  <a:srgbClr val="718096"/>
+                </a:solidFill>
+                <a:latin typeface="Aptos"/>
+                <a:ea typeface="Aptos"/>
+                <a:cs typeface="Aptos"/>
+              </a:rPr>
+              <a:t>Bensaid Ilyas</a:t>
+            </a:r>
+          </a:p>
+          <a:p xmlns:a="http://schemas.openxmlformats.org/drawingml/2006/main">
+            <a:pPr algn="l">
+              <a:defRPr sz="1350" b="0">
+                <a:solidFill>
+                  <a:srgbClr val="718096"/>
+                </a:solidFill>
+                <a:latin typeface="Aptos"/>
+                <a:ea typeface="Aptos"/>
+                <a:cs typeface="Aptos"/>
+              </a:defRPr>
+            </a:pPr>
+            <a:r>
+              <a:rPr sz="1350" b="0">
+                <a:solidFill>
+                  <a:srgbClr val="718096"/>
+                </a:solidFill>
+                <a:latin typeface="Aptos"/>
+                <a:ea typeface="Aptos"/>
+                <a:cs typeface="Aptos"/>
+              </a:rPr>
+              <a:t>Supervised by: Prof. Tawfik Masrour</a:t>
+            </a:r>
+          </a:p>
+        </p:txBody>
+      </p:sp>
       <p:pic>
         <p:nvPicPr>
-          <p:cNvPr id="6" name=""/>
+          <p:cNvPr id="7" name=""/>
           <p:cNvPicPr>
             <a:picLocks xmlns:a="http://schemas.openxmlformats.org/drawingml/2006/main" noChangeAspect="1"/>
           </p:cNvPicPr>
           <p:nvPr/>
         </p:nvPicPr>
         <p:blipFill>
-          <a:blip xmlns:r="http://schemas.openxmlformats.org/officeDocument/2006/relationships" xmlns:a="http://schemas.openxmlformats.org/drawingml/2006/main" r:embed="R69452ce5e1574d9b"/>
+          <a:blip xmlns:r="http://schemas.openxmlformats.org/officeDocument/2006/relationships" xmlns:a="http://schemas.openxmlformats.org/drawingml/2006/main" r:embed="R9f47af6ca4d54b6b"/>
           <a:srcRect xmlns:a="http://schemas.openxmlformats.org/drawingml/2006/main" l="0" t="9149" r="0" b="9149"/>
           <a:stretch xmlns:a="http://schemas.openxmlformats.org/drawingml/2006/main">
             <a:fillRect l="0" t="0" r="0" b="0"/>
@@ -1831,10 +1941,10 @@
       </p:pic>
       <p:sp>
         <p:nvSpPr>
-          <p:cNvPr id="7" name="">
-            <a:extLst xmlns:a="http://schemas.openxmlformats.org/drawingml/2006/main">
-              <a:ext uri="{FF2B5EF4-FFF2-40B4-BE49-F238E27FC236}">
-                <a16:creationId xmlns:a16="http://schemas.microsoft.com/office/drawing/2014/main" id="{994EAFC9-E5EF-41A0-8E4C-8CD2CFF89F23}"/>
+          <p:cNvPr id="8" name="">
+            <a:extLst xmlns:a="http://schemas.openxmlformats.org/drawingml/2006/main">
+              <a:ext uri="{FF2B5EF4-FFF2-40B4-BE49-F238E27FC236}">
+                <a16:creationId xmlns:a16="http://schemas.microsoft.com/office/drawing/2014/main" id="{DEE398C0-7BE6-4B09-B07B-74C622BAB09B}"/>
               </a:ext>
             </a:extLst>
           </p:cNvPr>
@@ -1866,10 +1976,10 @@
       </p:sp>
       <p:sp>
         <p:nvSpPr>
-          <p:cNvPr id="8" name="">
-            <a:extLst xmlns:a="http://schemas.openxmlformats.org/drawingml/2006/main">
-              <a:ext uri="{FF2B5EF4-FFF2-40B4-BE49-F238E27FC236}">
-                <a16:creationId xmlns:a16="http://schemas.microsoft.com/office/drawing/2014/main" id="{94D7F456-B949-4CAD-B91E-E3415C08A12A}"/>
+          <p:cNvPr id="9" name="">
+            <a:extLst xmlns:a="http://schemas.openxmlformats.org/drawingml/2006/main">
+              <a:ext uri="{FF2B5EF4-FFF2-40B4-BE49-F238E27FC236}">
+                <a16:creationId xmlns:a16="http://schemas.microsoft.com/office/drawing/2014/main" id="{A8CFC15C-3D5B-4EBC-8CB9-B7FFFF3209A7}"/>
               </a:ext>
             </a:extLst>
           </p:cNvPr>
@@ -1930,10 +2040,10 @@
       </p:sp>
       <p:sp>
         <p:nvSpPr>
-          <p:cNvPr id="9" name="">
-            <a:extLst xmlns:a="http://schemas.openxmlformats.org/drawingml/2006/main">
-              <a:ext uri="{FF2B5EF4-FFF2-40B4-BE49-F238E27FC236}">
-                <a16:creationId xmlns:a16="http://schemas.microsoft.com/office/drawing/2014/main" id="{41FE4A28-309F-4133-AF76-60E24E281607}"/>
+          <p:cNvPr id="10" name="">
+            <a:extLst xmlns:a="http://schemas.openxmlformats.org/drawingml/2006/main">
+              <a:ext uri="{FF2B5EF4-FFF2-40B4-BE49-F238E27FC236}">
+                <a16:creationId xmlns:a16="http://schemas.microsoft.com/office/drawing/2014/main" id="{716F89EE-9E07-443C-9F26-7B9F9A6F64F9}"/>
               </a:ext>
             </a:extLst>
           </p:cNvPr>
@@ -1994,10 +2104,10 @@
       </p:sp>
       <p:sp>
         <p:nvSpPr>
-          <p:cNvPr id="10" name="">
-            <a:extLst xmlns:a="http://schemas.openxmlformats.org/drawingml/2006/main">
-              <a:ext uri="{FF2B5EF4-FFF2-40B4-BE49-F238E27FC236}">
-                <a16:creationId xmlns:a16="http://schemas.microsoft.com/office/drawing/2014/main" id="{12400D5C-5360-4508-97F8-52FF67467DA2}"/>
+          <p:cNvPr id="11" name="">
+            <a:extLst xmlns:a="http://schemas.openxmlformats.org/drawingml/2006/main">
+              <a:ext uri="{FF2B5EF4-FFF2-40B4-BE49-F238E27FC236}">
+                <a16:creationId xmlns:a16="http://schemas.microsoft.com/office/drawing/2014/main" id="{49E4809E-7633-4624-9E23-BA2D2F3A65B1}"/>
               </a:ext>
             </a:extLst>
           </p:cNvPr>
@@ -2058,10 +2168,10 @@
       </p:sp>
       <p:sp>
         <p:nvSpPr>
-          <p:cNvPr id="11" name="">
-            <a:extLst xmlns:a="http://schemas.openxmlformats.org/drawingml/2006/main">
-              <a:ext uri="{FF2B5EF4-FFF2-40B4-BE49-F238E27FC236}">
-                <a16:creationId xmlns:a16="http://schemas.microsoft.com/office/drawing/2014/main" id="{9DED84AE-225B-4D3E-BA07-1C81D91DE879}"/>
+          <p:cNvPr id="12" name="">
+            <a:extLst xmlns:a="http://schemas.openxmlformats.org/drawingml/2006/main">
+              <a:ext uri="{FF2B5EF4-FFF2-40B4-BE49-F238E27FC236}">
+                <a16:creationId xmlns:a16="http://schemas.microsoft.com/office/drawing/2014/main" id="{608CFB25-CA6D-44B6-9E9B-26C0293256B2}"/>
               </a:ext>
             </a:extLst>
           </p:cNvPr>
@@ -2122,10 +2232,10 @@
       </p:sp>
       <p:sp>
         <p:nvSpPr>
-          <p:cNvPr id="12" name="">
-            <a:extLst xmlns:a="http://schemas.openxmlformats.org/drawingml/2006/main">
-              <a:ext uri="{FF2B5EF4-FFF2-40B4-BE49-F238E27FC236}">
-                <a16:creationId xmlns:a16="http://schemas.microsoft.com/office/drawing/2014/main" id="{7D5AA6F0-BFD3-4A48-AF89-219CA3755E15}"/>
+          <p:cNvPr id="13" name="">
+            <a:extLst xmlns:a="http://schemas.openxmlformats.org/drawingml/2006/main">
+              <a:ext uri="{FF2B5EF4-FFF2-40B4-BE49-F238E27FC236}">
+                <a16:creationId xmlns:a16="http://schemas.microsoft.com/office/drawing/2014/main" id="{EE1FD8B2-C6A9-4ECD-986B-31FC3F8E90CA}"/>
               </a:ext>
             </a:extLst>
           </p:cNvPr>
@@ -2186,10 +2296,10 @@
       </p:sp>
       <p:sp>
         <p:nvSpPr>
-          <p:cNvPr id="13" name="">
-            <a:extLst xmlns:a="http://schemas.openxmlformats.org/drawingml/2006/main">
-              <a:ext uri="{FF2B5EF4-FFF2-40B4-BE49-F238E27FC236}">
-                <a16:creationId xmlns:a16="http://schemas.microsoft.com/office/drawing/2014/main" id="{28621BED-94A7-47BE-9A19-4D7802B89342}"/>
+          <p:cNvPr id="14" name="">
+            <a:extLst xmlns:a="http://schemas.openxmlformats.org/drawingml/2006/main">
+              <a:ext uri="{FF2B5EF4-FFF2-40B4-BE49-F238E27FC236}">
+                <a16:creationId xmlns:a16="http://schemas.microsoft.com/office/drawing/2014/main" id="{BD66AD45-CEA7-4004-92EF-1D1C067F700B}"/>
               </a:ext>
             </a:extLst>
           </p:cNvPr>
@@ -2250,10 +2360,10 @@
       </p:sp>
       <p:sp>
         <p:nvSpPr>
-          <p:cNvPr id="14" name="">
-            <a:extLst xmlns:a="http://schemas.openxmlformats.org/drawingml/2006/main">
-              <a:ext uri="{FF2B5EF4-FFF2-40B4-BE49-F238E27FC236}">
-                <a16:creationId xmlns:a16="http://schemas.microsoft.com/office/drawing/2014/main" id="{327A0CE5-DF32-4398-ADA9-57ADC1ED7983}"/>
+          <p:cNvPr id="15" name="">
+            <a:extLst xmlns:a="http://schemas.openxmlformats.org/drawingml/2006/main">
+              <a:ext uri="{FF2B5EF4-FFF2-40B4-BE49-F238E27FC236}">
+                <a16:creationId xmlns:a16="http://schemas.microsoft.com/office/drawing/2014/main" id="{6B3F5CF0-CDD4-40FD-A456-DF2B4952A8E6}"/>
               </a:ext>
             </a:extLst>
           </p:cNvPr>
@@ -2315,7 +2425,7 @@
     </p:spTree>
     <p:extLst>
       <p:ext uri="{BB962C8B-B14F-4D97-AF65-F5344CB8AC3E}">
-        <p14:creationId xmlns:p14="http://schemas.microsoft.com/office/powerpoint/2010/main" val="1160333296"/>
+        <p14:creationId xmlns:p14="http://schemas.microsoft.com/office/powerpoint/2010/main" val="1384249637"/>
       </p:ext>
     </p:extLst>
   </p:cSld>
@@ -2339,7 +2449,7 @@
           <p:cNvPr id="1" name="">
             <a:extLst xmlns:a="http://schemas.openxmlformats.org/drawingml/2006/main">
               <a:ext uri="{FF2B5EF4-FFF2-40B4-BE49-F238E27FC236}">
-                <a16:creationId xmlns:a16="http://schemas.microsoft.com/office/drawing/2014/main" id="{95F3EFD7-9D91-4CC5-AD56-1CC13AA98A29}"/>
+                <a16:creationId xmlns:a16="http://schemas.microsoft.com/office/drawing/2014/main" id="{243C2EB8-E539-4FF5-9141-EBE011E2C620}"/>
               </a:ext>
             </a:extLst>
           </p:cNvPr>
@@ -2374,7 +2484,7 @@
           <p:cNvPr id="2" name="">
             <a:extLst xmlns:a="http://schemas.openxmlformats.org/drawingml/2006/main">
               <a:ext uri="{FF2B5EF4-FFF2-40B4-BE49-F238E27FC236}">
-                <a16:creationId xmlns:a16="http://schemas.microsoft.com/office/drawing/2014/main" id="{B84C507F-6CA8-46D2-A4A9-F5C40E3E3124}"/>
+                <a16:creationId xmlns:a16="http://schemas.microsoft.com/office/drawing/2014/main" id="{353A8B35-5975-40DA-B4DD-D863FD847015}"/>
               </a:ext>
             </a:extLst>
           </p:cNvPr>
@@ -2428,7 +2538,7 @@
                 <a:ea typeface="Aptos"/>
                 <a:cs typeface="Aptos"/>
               </a:rPr>
-              <a:t>Artefacts à montrer: exact_entry_reliability.png + timing_budget.png</a:t>
+              <a:t>Artefact � montrer: timing_budget.png</a:t>
             </a:r>
           </a:p>
         </p:txBody>
@@ -2438,7 +2548,7 @@
           <p:cNvPr id="3" name="">
             <a:extLst xmlns:a="http://schemas.openxmlformats.org/drawingml/2006/main">
               <a:ext uri="{FF2B5EF4-FFF2-40B4-BE49-F238E27FC236}">
-                <a16:creationId xmlns:a16="http://schemas.microsoft.com/office/drawing/2014/main" id="{F19F49E4-B7B7-44DC-ADFF-9810314F0D02}"/>
+                <a16:creationId xmlns:a16="http://schemas.microsoft.com/office/drawing/2014/main" id="{ED559F0B-794D-481E-81BA-A057A75BC9F3}"/>
               </a:ext>
             </a:extLst>
           </p:cNvPr>
@@ -2502,7 +2612,7 @@
           <p:cNvPr id="4" name="">
             <a:extLst xmlns:a="http://schemas.openxmlformats.org/drawingml/2006/main">
               <a:ext uri="{FF2B5EF4-FFF2-40B4-BE49-F238E27FC236}">
-                <a16:creationId xmlns:a16="http://schemas.microsoft.com/office/drawing/2014/main" id="{6F7F9CC4-20BB-4A64-B376-548F36993DF5}"/>
+                <a16:creationId xmlns:a16="http://schemas.microsoft.com/office/drawing/2014/main" id="{20B77232-7A2A-44B5-848B-A2E07B72CEE5}"/>
               </a:ext>
             </a:extLst>
           </p:cNvPr>
@@ -2537,7 +2647,7 @@
           <p:cNvPr id="5" name="">
             <a:extLst xmlns:a="http://schemas.openxmlformats.org/drawingml/2006/main">
               <a:ext uri="{FF2B5EF4-FFF2-40B4-BE49-F238E27FC236}">
-                <a16:creationId xmlns:a16="http://schemas.microsoft.com/office/drawing/2014/main" id="{84C23246-0718-4A66-949A-FB365D6A3FAD}"/>
+                <a16:creationId xmlns:a16="http://schemas.microsoft.com/office/drawing/2014/main" id="{8C677A53-2586-42A8-9DED-3224D7EBCEEF}"/>
               </a:ext>
             </a:extLst>
           </p:cNvPr>
@@ -2591,7 +2701,7 @@
                 <a:ea typeface="Aptos"/>
                 <a:cs typeface="Aptos"/>
               </a:rPr>
-              <a:t>PRUDENCE DÉPLOIEMENT</a:t>
+              <a:t>PRUDENCE D�PLOIEMENT</a:t>
             </a:r>
           </a:p>
         </p:txBody>
@@ -2601,7 +2711,7 @@
           <p:cNvPr id="6" name="">
             <a:extLst xmlns:a="http://schemas.openxmlformats.org/drawingml/2006/main">
               <a:ext uri="{FF2B5EF4-FFF2-40B4-BE49-F238E27FC236}">
-                <a16:creationId xmlns:a16="http://schemas.microsoft.com/office/drawing/2014/main" id="{E7828C31-A72B-49DD-8AF2-15BE78E54341}"/>
+                <a16:creationId xmlns:a16="http://schemas.microsoft.com/office/drawing/2014/main" id="{EB407563-3CFF-4F2F-8298-FEF4FD890895}"/>
               </a:ext>
             </a:extLst>
           </p:cNvPr>
@@ -2655,7 +2765,7 @@
                 <a:ea typeface="Aptos Display"/>
                 <a:cs typeface="Aptos Display"/>
               </a:rPr>
-              <a:t>Le signal d'arrêt est prometteur, mais le déploiement demande 3D et validation complète.</a:t>
+              <a:t>Le prototype reste 2D et doit encore prouver toute la cha�ne d'arr�t.</a:t>
             </a:r>
           </a:p>
         </p:txBody>
@@ -2669,92 +2779,70 @@
           <p:nvPr/>
         </p:nvPicPr>
         <p:blipFill>
-          <a:blip xmlns:r="http://schemas.openxmlformats.org/officeDocument/2006/relationships" xmlns:a="http://schemas.openxmlformats.org/drawingml/2006/main" r:embed="Rb751290547bd4257"/>
+          <a:blip xmlns:r="http://schemas.openxmlformats.org/officeDocument/2006/relationships" xmlns:a="http://schemas.openxmlformats.org/drawingml/2006/main" r:embed="Re024a38487094bfe"/>
           <a:stretch xmlns:a="http://schemas.openxmlformats.org/drawingml/2006/main"/>
         </p:blipFill>
         <p:spPr>
           <a:xfrm xmlns:a="http://schemas.openxmlformats.org/drawingml/2006/main">
-            <a:off x="666750" y="1725216"/>
-            <a:ext cx="4476750" cy="2797969"/>
+            <a:off x="6667500" y="1683544"/>
+            <a:ext cx="4762500" cy="2500313"/>
           </a:xfrm>
           <a:prstGeom xmlns:a="http://schemas.openxmlformats.org/drawingml/2006/main" prst="rect">
             <a:avLst/>
           </a:prstGeom>
         </p:spPr>
       </p:pic>
-      <p:pic>
-        <p:nvPicPr>
-          <p:cNvPr id="8" name=""/>
-          <p:cNvPicPr>
-            <a:picLocks xmlns:a="http://schemas.openxmlformats.org/drawingml/2006/main" noChangeAspect="1"/>
-          </p:cNvPicPr>
-          <p:nvPr/>
-        </p:nvPicPr>
-        <p:blipFill>
-          <a:blip xmlns:r="http://schemas.openxmlformats.org/officeDocument/2006/relationships" xmlns:a="http://schemas.openxmlformats.org/drawingml/2006/main" r:embed="Rcc767a3711594dee"/>
-          <a:stretch xmlns:a="http://schemas.openxmlformats.org/drawingml/2006/main"/>
-        </p:blipFill>
-        <p:spPr>
-          <a:xfrm xmlns:a="http://schemas.openxmlformats.org/drawingml/2006/main">
-            <a:off x="5810250" y="1949053"/>
-            <a:ext cx="4476750" cy="2350294"/>
-          </a:xfrm>
-          <a:prstGeom xmlns:a="http://schemas.openxmlformats.org/drawingml/2006/main" prst="rect">
-            <a:avLst/>
-          </a:prstGeom>
-        </p:spPr>
-      </p:pic>
+      <p:sp>
+        <p:nvSpPr>
+          <p:cNvPr id="8" name="">
+            <a:extLst xmlns:a="http://schemas.openxmlformats.org/drawingml/2006/main">
+              <a:ext uri="{FF2B5EF4-FFF2-40B4-BE49-F238E27FC236}">
+                <a16:creationId xmlns:a16="http://schemas.microsoft.com/office/drawing/2014/main" id="{55510492-611A-4A00-97D4-EEC40CEF0A7A}"/>
+              </a:ext>
+            </a:extLst>
+          </p:cNvPr>
+          <p:cNvSpPr>
+            <a:spLocks xmlns:a="http://schemas.openxmlformats.org/drawingml/2006/main" noGrp="1"/>
+          </p:cNvSpPr>
+          <p:nvPr/>
+        </p:nvSpPr>
+        <p:spPr>
+          <a:xfrm xmlns:a="http://schemas.openxmlformats.org/drawingml/2006/main">
+            <a:off x="685800" y="1676400"/>
+            <a:ext cx="5143500" cy="3048000"/>
+          </a:xfrm>
+          <a:prstGeom xmlns:a="http://schemas.openxmlformats.org/drawingml/2006/main" prst="rect">
+            <a:avLst/>
+          </a:prstGeom>
+          <a:solidFill xmlns:a="http://schemas.openxmlformats.org/drawingml/2006/main">
+            <a:srgbClr val="FFFFFF"/>
+          </a:solidFill>
+          <a:ln xmlns:a="http://schemas.openxmlformats.org/drawingml/2006/main" w="19050">
+            <a:solidFill>
+              <a:srgbClr val="B23A48"/>
+            </a:solidFill>
+            <a:prstDash val="solid"/>
+          </a:ln>
+        </p:spPr>
+      </p:sp>
       <p:sp>
         <p:nvSpPr>
           <p:cNvPr id="9" name="">
             <a:extLst xmlns:a="http://schemas.openxmlformats.org/drawingml/2006/main">
               <a:ext uri="{FF2B5EF4-FFF2-40B4-BE49-F238E27FC236}">
-                <a16:creationId xmlns:a16="http://schemas.microsoft.com/office/drawing/2014/main" id="{98E540B9-B127-4BA6-8C77-254E10D2AF41}"/>
-              </a:ext>
-            </a:extLst>
-          </p:cNvPr>
-          <p:cNvSpPr>
-            <a:spLocks xmlns:a="http://schemas.openxmlformats.org/drawingml/2006/main" noGrp="1"/>
-          </p:cNvSpPr>
-          <p:nvPr/>
-        </p:nvSpPr>
-        <p:spPr>
-          <a:xfrm xmlns:a="http://schemas.openxmlformats.org/drawingml/2006/main">
-            <a:off x="990600" y="4953000"/>
-            <a:ext cx="9144000" cy="876300"/>
-          </a:xfrm>
-          <a:prstGeom xmlns:a="http://schemas.openxmlformats.org/drawingml/2006/main" prst="rect">
-            <a:avLst/>
-          </a:prstGeom>
-          <a:solidFill xmlns:a="http://schemas.openxmlformats.org/drawingml/2006/main">
-            <a:srgbClr val="F8E7EA"/>
-          </a:solidFill>
-          <a:ln xmlns:a="http://schemas.openxmlformats.org/drawingml/2006/main" w="9525">
-            <a:solidFill>
-              <a:srgbClr val="B23A48"/>
-            </a:solidFill>
-            <a:prstDash val="solid"/>
-          </a:ln>
-        </p:spPr>
-      </p:sp>
-      <p:sp>
-        <p:nvSpPr>
-          <p:cNvPr id="10" name="">
-            <a:extLst xmlns:a="http://schemas.openxmlformats.org/drawingml/2006/main">
-              <a:ext uri="{FF2B5EF4-FFF2-40B4-BE49-F238E27FC236}">
-                <a16:creationId xmlns:a16="http://schemas.microsoft.com/office/drawing/2014/main" id="{7F5B34D9-E874-4040-96A1-EBD08D121F30}"/>
-              </a:ext>
-            </a:extLst>
-          </p:cNvPr>
-          <p:cNvSpPr>
-            <a:spLocks xmlns:a="http://schemas.openxmlformats.org/drawingml/2006/main" noGrp="1"/>
-          </p:cNvSpPr>
-          <p:nvPr/>
-        </p:nvSpPr>
-        <p:spPr>
-          <a:xfrm xmlns:a="http://schemas.openxmlformats.org/drawingml/2006/main">
-            <a:off x="1162050" y="5086350"/>
-            <a:ext cx="8801100" cy="647700"/>
+                <a16:creationId xmlns:a16="http://schemas.microsoft.com/office/drawing/2014/main" id="{0E8191F9-D1B2-4D25-9CBC-D8C294168BCA}"/>
+              </a:ext>
+            </a:extLst>
+          </p:cNvPr>
+          <p:cNvSpPr>
+            <a:spLocks xmlns:a="http://schemas.openxmlformats.org/drawingml/2006/main" noGrp="1"/>
+          </p:cNvSpPr>
+          <p:nvPr/>
+        </p:nvSpPr>
+        <p:spPr>
+          <a:xfrm xmlns:a="http://schemas.openxmlformats.org/drawingml/2006/main">
+            <a:off x="952500" y="1962150"/>
+            <a:ext cx="3429000" cy="285750"/>
           </a:xfrm>
           <a:prstGeom xmlns:a="http://schemas.openxmlformats.org/drawingml/2006/main" prst="rect">
             <a:avLst/>
@@ -2778,7 +2866,71 @@
           <a:lstStyle xmlns:a="http://schemas.openxmlformats.org/drawingml/2006/main"/>
           <a:p xmlns:a="http://schemas.openxmlformats.org/drawingml/2006/main">
             <a:pPr algn="l">
-              <a:defRPr sz="1350" b="0">
+              <a:defRPr sz="1950" b="1">
+                <a:solidFill>
+                  <a:srgbClr val="B23A48"/>
+                </a:solidFill>
+                <a:latin typeface="Aptos"/>
+                <a:ea typeface="Aptos"/>
+                <a:cs typeface="Aptos"/>
+              </a:defRPr>
+            </a:pPr>
+            <a:r>
+              <a:rPr sz="1950" b="1">
+                <a:solidFill>
+                  <a:srgbClr val="B23A48"/>
+                </a:solidFill>
+                <a:latin typeface="Aptos"/>
+                <a:ea typeface="Aptos"/>
+                <a:cs typeface="Aptos"/>
+              </a:rPr>
+              <a:t>Pourquoi le prototype reste limit�</a:t>
+            </a:r>
+          </a:p>
+        </p:txBody>
+      </p:sp>
+      <p:sp>
+        <p:nvSpPr>
+          <p:cNvPr id="10" name="">
+            <a:extLst xmlns:a="http://schemas.openxmlformats.org/drawingml/2006/main">
+              <a:ext uri="{FF2B5EF4-FFF2-40B4-BE49-F238E27FC236}">
+                <a16:creationId xmlns:a16="http://schemas.microsoft.com/office/drawing/2014/main" id="{3F57F83A-228F-49AB-B9E5-018115396980}"/>
+              </a:ext>
+            </a:extLst>
+          </p:cNvPr>
+          <p:cNvSpPr>
+            <a:spLocks xmlns:a="http://schemas.openxmlformats.org/drawingml/2006/main" noGrp="1"/>
+          </p:cNvSpPr>
+          <p:nvPr/>
+        </p:nvSpPr>
+        <p:spPr>
+          <a:xfrm xmlns:a="http://schemas.openxmlformats.org/drawingml/2006/main">
+            <a:off x="952500" y="2457450"/>
+            <a:ext cx="4000500" cy="1676400"/>
+          </a:xfrm>
+          <a:prstGeom xmlns:a="http://schemas.openxmlformats.org/drawingml/2006/main" prst="rect">
+            <a:avLst/>
+          </a:prstGeom>
+          <a:solidFill xmlns:a="http://schemas.openxmlformats.org/drawingml/2006/main">
+            <a:srgbClr val="000000">
+              <a:alpha val="0"/>
+            </a:srgbClr>
+          </a:solidFill>
+          <a:ln xmlns:a="http://schemas.openxmlformats.org/drawingml/2006/main" w="0">
+            <a:solidFill>
+              <a:srgbClr val="000000">
+                <a:alpha val="0"/>
+              </a:srgbClr>
+            </a:solidFill>
+            <a:prstDash val="solid"/>
+          </a:ln>
+        </p:spPr>
+        <p:txBody>
+          <a:bodyPr xmlns:a="http://schemas.openxmlformats.org/drawingml/2006/main" lIns="0" tIns="0" rIns="0" bIns="0" anchor="t"/>
+          <a:lstStyle xmlns:a="http://schemas.openxmlformats.org/drawingml/2006/main"/>
+          <a:p xmlns:a="http://schemas.openxmlformats.org/drawingml/2006/main">
+            <a:pPr algn="l">
+              <a:defRPr sz="1500" b="0">
                 <a:solidFill>
                   <a:srgbClr val="17202A"/>
                 </a:solidFill>
@@ -2788,7 +2940,7 @@
               </a:defRPr>
             </a:pPr>
             <a:r>
-              <a:rPr sz="1350" b="0">
+              <a:rPr sz="1500" b="0">
                 <a:solidFill>
                   <a:srgbClr val="17202A"/>
                 </a:solidFill>
@@ -2796,7 +2948,173 @@
                 <a:ea typeface="Aptos"/>
                 <a:cs typeface="Aptos"/>
               </a:rPr>
-              <a:t>La projection 2D de la zone est acceptable pour ce prototype à caméra fixe. Elle ne suffit pas pour un déploiement où profondeur, occlusion et angle caméra changent la relation réelle corps-volume.</a:t>
+              <a:t>Zone dangereuse projet�e en 2D</a:t>
+            </a:r>
+          </a:p>
+          <a:p xmlns:a="http://schemas.openxmlformats.org/drawingml/2006/main">
+            <a:pPr algn="l">
+              <a:defRPr sz="1500" b="0">
+                <a:solidFill>
+                  <a:srgbClr val="17202A"/>
+                </a:solidFill>
+                <a:latin typeface="Aptos"/>
+                <a:ea typeface="Aptos"/>
+                <a:cs typeface="Aptos"/>
+              </a:defRPr>
+            </a:pPr>
+            <a:r>
+              <a:rPr sz="1500" b="0">
+                <a:solidFill>
+                  <a:srgbClr val="17202A"/>
+                </a:solidFill>
+                <a:latin typeface="Aptos"/>
+                <a:ea typeface="Aptos"/>
+                <a:cs typeface="Aptos"/>
+              </a:rPr>
+              <a:t>Cam�ra et machine fixes</a:t>
+            </a:r>
+          </a:p>
+          <a:p xmlns:a="http://schemas.openxmlformats.org/drawingml/2006/main">
+            <a:pPr algn="l">
+              <a:defRPr sz="1500" b="0">
+                <a:solidFill>
+                  <a:srgbClr val="17202A"/>
+                </a:solidFill>
+                <a:latin typeface="Aptos"/>
+                <a:ea typeface="Aptos"/>
+                <a:cs typeface="Aptos"/>
+              </a:defRPr>
+            </a:pPr>
+            <a:r>
+              <a:rPr sz="1500" b="0">
+                <a:solidFill>
+                  <a:srgbClr val="17202A"/>
+                </a:solidFill>
+                <a:latin typeface="Aptos"/>
+                <a:ea typeface="Aptos"/>
+                <a:cs typeface="Aptos"/>
+              </a:rPr>
+              <a:t>Deux acteurs seulement</a:t>
+            </a:r>
+          </a:p>
+          <a:p xmlns:a="http://schemas.openxmlformats.org/drawingml/2006/main">
+            <a:pPr algn="l">
+              <a:defRPr sz="1500" b="0">
+                <a:solidFill>
+                  <a:srgbClr val="17202A"/>
+                </a:solidFill>
+                <a:latin typeface="Aptos"/>
+                <a:ea typeface="Aptos"/>
+                <a:cs typeface="Aptos"/>
+              </a:defRPr>
+            </a:pPr>
+            <a:r>
+              <a:rPr sz="1500" b="0">
+                <a:solidFill>
+                  <a:srgbClr val="17202A"/>
+                </a:solidFill>
+                <a:latin typeface="Aptos"/>
+                <a:ea typeface="Aptos"/>
+                <a:cs typeface="Aptos"/>
+              </a:rPr>
+              <a:t>Pas encore de mesure compl�te cam�ra -&gt; arr�t m�canique</a:t>
+            </a:r>
+          </a:p>
+        </p:txBody>
+      </p:sp>
+      <p:sp>
+        <p:nvSpPr>
+          <p:cNvPr id="11" name="">
+            <a:extLst xmlns:a="http://schemas.openxmlformats.org/drawingml/2006/main">
+              <a:ext uri="{FF2B5EF4-FFF2-40B4-BE49-F238E27FC236}">
+                <a16:creationId xmlns:a16="http://schemas.microsoft.com/office/drawing/2014/main" id="{83F97B62-368E-485A-8848-57115E1E52E3}"/>
+              </a:ext>
+            </a:extLst>
+          </p:cNvPr>
+          <p:cNvSpPr>
+            <a:spLocks xmlns:a="http://schemas.openxmlformats.org/drawingml/2006/main" noGrp="1"/>
+          </p:cNvSpPr>
+          <p:nvPr/>
+        </p:nvSpPr>
+        <p:spPr>
+          <a:xfrm xmlns:a="http://schemas.openxmlformats.org/drawingml/2006/main">
+            <a:off x="876300" y="5086350"/>
+            <a:ext cx="10591800" cy="590550"/>
+          </a:xfrm>
+          <a:prstGeom xmlns:a="http://schemas.openxmlformats.org/drawingml/2006/main" prst="rect">
+            <a:avLst/>
+          </a:prstGeom>
+          <a:solidFill xmlns:a="http://schemas.openxmlformats.org/drawingml/2006/main">
+            <a:srgbClr val="F8E7EA"/>
+          </a:solidFill>
+          <a:ln xmlns:a="http://schemas.openxmlformats.org/drawingml/2006/main" w="9525">
+            <a:solidFill>
+              <a:srgbClr val="B23A48"/>
+            </a:solidFill>
+            <a:prstDash val="solid"/>
+          </a:ln>
+        </p:spPr>
+      </p:sp>
+      <p:sp>
+        <p:nvSpPr>
+          <p:cNvPr id="12" name="">
+            <a:extLst xmlns:a="http://schemas.openxmlformats.org/drawingml/2006/main">
+              <a:ext uri="{FF2B5EF4-FFF2-40B4-BE49-F238E27FC236}">
+                <a16:creationId xmlns:a16="http://schemas.microsoft.com/office/drawing/2014/main" id="{D8DA9061-1809-4D39-96B0-50C69A935276}"/>
+              </a:ext>
+            </a:extLst>
+          </p:cNvPr>
+          <p:cNvSpPr>
+            <a:spLocks xmlns:a="http://schemas.openxmlformats.org/drawingml/2006/main" noGrp="1"/>
+          </p:cNvSpPr>
+          <p:nvPr/>
+        </p:nvSpPr>
+        <p:spPr>
+          <a:xfrm xmlns:a="http://schemas.openxmlformats.org/drawingml/2006/main">
+            <a:off x="1047750" y="5219700"/>
+            <a:ext cx="10248900" cy="361950"/>
+          </a:xfrm>
+          <a:prstGeom xmlns:a="http://schemas.openxmlformats.org/drawingml/2006/main" prst="rect">
+            <a:avLst/>
+          </a:prstGeom>
+          <a:solidFill xmlns:a="http://schemas.openxmlformats.org/drawingml/2006/main">
+            <a:srgbClr val="000000">
+              <a:alpha val="0"/>
+            </a:srgbClr>
+          </a:solidFill>
+          <a:ln xmlns:a="http://schemas.openxmlformats.org/drawingml/2006/main" w="0">
+            <a:solidFill>
+              <a:srgbClr val="000000">
+                <a:alpha val="0"/>
+              </a:srgbClr>
+            </a:solidFill>
+            <a:prstDash val="solid"/>
+          </a:ln>
+        </p:spPr>
+        <p:txBody>
+          <a:bodyPr xmlns:a="http://schemas.openxmlformats.org/drawingml/2006/main" lIns="0" tIns="0" rIns="0" bIns="0" anchor="t"/>
+          <a:lstStyle xmlns:a="http://schemas.openxmlformats.org/drawingml/2006/main"/>
+          <a:p xmlns:a="http://schemas.openxmlformats.org/drawingml/2006/main">
+            <a:pPr algn="l">
+              <a:defRPr sz="1275" b="0">
+                <a:solidFill>
+                  <a:srgbClr val="17202A"/>
+                </a:solidFill>
+                <a:latin typeface="Aptos"/>
+                <a:ea typeface="Aptos"/>
+                <a:cs typeface="Aptos"/>
+              </a:defRPr>
+            </a:pPr>
+            <a:r>
+              <a:rPr sz="1275" b="0">
+                <a:solidFill>
+                  <a:srgbClr val="17202A"/>
+                </a:solidFill>
+                <a:latin typeface="Aptos"/>
+                <a:ea typeface="Aptos"/>
+                <a:cs typeface="Aptos"/>
+              </a:rPr>
+              <a:t>La projection 2D est acceptable pour ce prototype � cam�ra fixe. Pour un d�ploiement, il faudra une validation 3D plus robuste, avec multi-angle ou profondeur, plus une mesure compl�te de la latence jusqu'� l'action m�canique.</a:t>
             </a:r>
           </a:p>
         </p:txBody>
@@ -2804,7 +3122,7 @@
     </p:spTree>
     <p:extLst>
       <p:ext uri="{BB962C8B-B14F-4D97-AF65-F5344CB8AC3E}">
-        <p14:creationId xmlns:p14="http://schemas.microsoft.com/office/powerpoint/2010/main" val="1773497417"/>
+        <p14:creationId xmlns:p14="http://schemas.microsoft.com/office/powerpoint/2010/main" val="1482026801"/>
       </p:ext>
     </p:extLst>
   </p:cSld>
@@ -2828,7 +3146,7 @@
           <p:cNvPr id="1" name="">
             <a:extLst xmlns:a="http://schemas.openxmlformats.org/drawingml/2006/main">
               <a:ext uri="{FF2B5EF4-FFF2-40B4-BE49-F238E27FC236}">
-                <a16:creationId xmlns:a16="http://schemas.microsoft.com/office/drawing/2014/main" id="{84107CDD-A142-411A-8159-D64F32F5D042}"/>
+                <a16:creationId xmlns:a16="http://schemas.microsoft.com/office/drawing/2014/main" id="{0DD19B0F-0863-46A9-B095-DBC392CD9210}"/>
               </a:ext>
             </a:extLst>
           </p:cNvPr>
@@ -2863,7 +3181,7 @@
           <p:cNvPr id="2" name="">
             <a:extLst xmlns:a="http://schemas.openxmlformats.org/drawingml/2006/main">
               <a:ext uri="{FF2B5EF4-FFF2-40B4-BE49-F238E27FC236}">
-                <a16:creationId xmlns:a16="http://schemas.microsoft.com/office/drawing/2014/main" id="{A605454F-C0B8-4B6F-8646-2850EF89238B}"/>
+                <a16:creationId xmlns:a16="http://schemas.microsoft.com/office/drawing/2014/main" id="{4C102FAB-E8B2-469A-B0BA-1EEBFF37A7C9}"/>
               </a:ext>
             </a:extLst>
           </p:cNvPr>
@@ -2927,7 +3245,7 @@
           <p:cNvPr id="3" name="">
             <a:extLst xmlns:a="http://schemas.openxmlformats.org/drawingml/2006/main">
               <a:ext uri="{FF2B5EF4-FFF2-40B4-BE49-F238E27FC236}">
-                <a16:creationId xmlns:a16="http://schemas.microsoft.com/office/drawing/2014/main" id="{BA64BADE-25F4-417D-9045-1A804127C49C}"/>
+                <a16:creationId xmlns:a16="http://schemas.microsoft.com/office/drawing/2014/main" id="{CB41C107-FD66-4769-8AA1-E5515B7EFA27}"/>
               </a:ext>
             </a:extLst>
           </p:cNvPr>
@@ -2991,7 +3309,7 @@
           <p:cNvPr id="4" name="">
             <a:extLst xmlns:a="http://schemas.openxmlformats.org/drawingml/2006/main">
               <a:ext uri="{FF2B5EF4-FFF2-40B4-BE49-F238E27FC236}">
-                <a16:creationId xmlns:a16="http://schemas.microsoft.com/office/drawing/2014/main" id="{0F4C9029-5202-450D-A941-E146FA8BBF6C}"/>
+                <a16:creationId xmlns:a16="http://schemas.microsoft.com/office/drawing/2014/main" id="{EBBEA227-F304-436B-B6DD-467AFF522A6A}"/>
               </a:ext>
             </a:extLst>
           </p:cNvPr>
@@ -3026,7 +3344,7 @@
           <p:cNvPr id="5" name="">
             <a:extLst xmlns:a="http://schemas.openxmlformats.org/drawingml/2006/main">
               <a:ext uri="{FF2B5EF4-FFF2-40B4-BE49-F238E27FC236}">
-                <a16:creationId xmlns:a16="http://schemas.microsoft.com/office/drawing/2014/main" id="{79AC4664-ED57-4FD3-AC5C-35EE2FB01470}"/>
+                <a16:creationId xmlns:a16="http://schemas.microsoft.com/office/drawing/2014/main" id="{0AC7D879-D6EA-4D3A-A383-C73CF141CB1E}"/>
               </a:ext>
             </a:extLst>
           </p:cNvPr>
@@ -3090,7 +3408,7 @@
           <p:cNvPr id="6" name="">
             <a:extLst xmlns:a="http://schemas.openxmlformats.org/drawingml/2006/main">
               <a:ext uri="{FF2B5EF4-FFF2-40B4-BE49-F238E27FC236}">
-                <a16:creationId xmlns:a16="http://schemas.microsoft.com/office/drawing/2014/main" id="{03184165-4915-4A61-A58E-8D06211EF6FD}"/>
+                <a16:creationId xmlns:a16="http://schemas.microsoft.com/office/drawing/2014/main" id="{159FB82B-C8B6-41D3-BA2A-46C127B2738C}"/>
               </a:ext>
             </a:extLst>
           </p:cNvPr>
@@ -3144,7 +3462,7 @@
                 <a:ea typeface="Aptos Display"/>
                 <a:cs typeface="Aptos Display"/>
               </a:rPr>
-              <a:t>Le gain: une chaîne causale complète, pas seulement un classifieur.</a:t>
+              <a:t>Le gain: une cha�ne causale compl�te, pas seulement un classifieur.</a:t>
             </a:r>
           </a:p>
         </p:txBody>
@@ -3154,7 +3472,7 @@
           <p:cNvPr id="7" name="">
             <a:extLst xmlns:a="http://schemas.openxmlformats.org/drawingml/2006/main">
               <a:ext uri="{FF2B5EF4-FFF2-40B4-BE49-F238E27FC236}">
-                <a16:creationId xmlns:a16="http://schemas.microsoft.com/office/drawing/2014/main" id="{F716F766-7BCF-4434-9C7B-250B725216FF}"/>
+                <a16:creationId xmlns:a16="http://schemas.microsoft.com/office/drawing/2014/main" id="{2614EBBE-C113-434C-9BC5-4DA0A34E58DC}"/>
               </a:ext>
             </a:extLst>
           </p:cNvPr>
@@ -3187,7 +3505,7 @@
           <p:cNvPr id="8" name="">
             <a:extLst xmlns:a="http://schemas.openxmlformats.org/drawingml/2006/main">
               <a:ext uri="{FF2B5EF4-FFF2-40B4-BE49-F238E27FC236}">
-                <a16:creationId xmlns:a16="http://schemas.microsoft.com/office/drawing/2014/main" id="{5D14881B-7A98-49BC-B266-B717A6E5C3B0}"/>
+                <a16:creationId xmlns:a16="http://schemas.microsoft.com/office/drawing/2014/main" id="{0AC8F5A6-06CF-45EF-9C98-BD8960400799}"/>
               </a:ext>
             </a:extLst>
           </p:cNvPr>
@@ -3251,7 +3569,7 @@
           <p:cNvPr id="9" name="">
             <a:extLst xmlns:a="http://schemas.openxmlformats.org/drawingml/2006/main">
               <a:ext uri="{FF2B5EF4-FFF2-40B4-BE49-F238E27FC236}">
-                <a16:creationId xmlns:a16="http://schemas.microsoft.com/office/drawing/2014/main" id="{57A92C4E-32A9-4D97-809B-D4251398F4BF}"/>
+                <a16:creationId xmlns:a16="http://schemas.microsoft.com/office/drawing/2014/main" id="{0ED01B86-4C5D-4BEC-82B9-12C653DA28E3}"/>
               </a:ext>
             </a:extLst>
           </p:cNvPr>
@@ -3286,7 +3604,7 @@
           <p:cNvPr id="10" name="">
             <a:extLst xmlns:a="http://schemas.openxmlformats.org/drawingml/2006/main">
               <a:ext uri="{FF2B5EF4-FFF2-40B4-BE49-F238E27FC236}">
-                <a16:creationId xmlns:a16="http://schemas.microsoft.com/office/drawing/2014/main" id="{F95F5AEB-8117-4EDF-94FF-61E5A1DAB9AE}"/>
+                <a16:creationId xmlns:a16="http://schemas.microsoft.com/office/drawing/2014/main" id="{3808D2C1-77B4-4F67-8DC5-DE2C92197E0A}"/>
               </a:ext>
             </a:extLst>
           </p:cNvPr>
@@ -3340,7 +3658,7 @@
                 <a:ea typeface="Aptos"/>
                 <a:cs typeface="Aptos"/>
               </a:rPr>
-              <a:t>Annotation dédiée: entrée physique et début du risque</a:t>
+              <a:t>Annotation d�di�e: entr�e physique et d�but du risque</a:t>
             </a:r>
           </a:p>
         </p:txBody>
@@ -3350,7 +3668,7 @@
           <p:cNvPr id="11" name="">
             <a:extLst xmlns:a="http://schemas.openxmlformats.org/drawingml/2006/main">
               <a:ext uri="{FF2B5EF4-FFF2-40B4-BE49-F238E27FC236}">
-                <a16:creationId xmlns:a16="http://schemas.microsoft.com/office/drawing/2014/main" id="{795261DE-CE78-4C7C-85BF-1A58376A7584}"/>
+                <a16:creationId xmlns:a16="http://schemas.microsoft.com/office/drawing/2014/main" id="{6822D2CD-5C0D-4A84-9975-A0D4722B399E}"/>
               </a:ext>
             </a:extLst>
           </p:cNvPr>
@@ -3385,7 +3703,7 @@
           <p:cNvPr id="12" name="">
             <a:extLst xmlns:a="http://schemas.openxmlformats.org/drawingml/2006/main">
               <a:ext uri="{FF2B5EF4-FFF2-40B4-BE49-F238E27FC236}">
-                <a16:creationId xmlns:a16="http://schemas.microsoft.com/office/drawing/2014/main" id="{76280189-DB23-41F0-9089-EBD598B612E3}"/>
+                <a16:creationId xmlns:a16="http://schemas.microsoft.com/office/drawing/2014/main" id="{86149E2F-3886-4BA0-A371-23CD045E681E}"/>
               </a:ext>
             </a:extLst>
           </p:cNvPr>
@@ -3439,7 +3757,7 @@
                 <a:ea typeface="Aptos"/>
                 <a:cs typeface="Aptos"/>
               </a:rPr>
-              <a:t>Variables pose-zone avec fenêtres causales</a:t>
+              <a:t>Variables pose-zone avec fen�tres causales</a:t>
             </a:r>
           </a:p>
         </p:txBody>
@@ -3449,7 +3767,7 @@
           <p:cNvPr id="13" name="">
             <a:extLst xmlns:a="http://schemas.openxmlformats.org/drawingml/2006/main">
               <a:ext uri="{FF2B5EF4-FFF2-40B4-BE49-F238E27FC236}">
-                <a16:creationId xmlns:a16="http://schemas.microsoft.com/office/drawing/2014/main" id="{244F8EDC-0CFE-4B33-ADE7-4C5660F3242E}"/>
+                <a16:creationId xmlns:a16="http://schemas.microsoft.com/office/drawing/2014/main" id="{0B40478A-1A94-410F-9D6E-30451584E4B0}"/>
               </a:ext>
             </a:extLst>
           </p:cNvPr>
@@ -3484,7 +3802,7 @@
           <p:cNvPr id="14" name="">
             <a:extLst xmlns:a="http://schemas.openxmlformats.org/drawingml/2006/main">
               <a:ext uri="{FF2B5EF4-FFF2-40B4-BE49-F238E27FC236}">
-                <a16:creationId xmlns:a16="http://schemas.microsoft.com/office/drawing/2014/main" id="{14AA923C-3ABE-4FD9-AC52-1664D2033D31}"/>
+                <a16:creationId xmlns:a16="http://schemas.microsoft.com/office/drawing/2014/main" id="{13ECCACD-9F4A-4952-9D3A-5F324DF75DF7}"/>
               </a:ext>
             </a:extLst>
           </p:cNvPr>
@@ -3538,7 +3856,7 @@
                 <a:ea typeface="Aptos"/>
                 <a:cs typeface="Aptos"/>
               </a:rPr>
-              <a:t>Signal TCN d'alerte et signal GRU d'entrée exacte</a:t>
+              <a:t>Signal TCN d'alerte continue et GRU de stop imminent</a:t>
             </a:r>
           </a:p>
         </p:txBody>
@@ -3548,7 +3866,7 @@
           <p:cNvPr id="15" name="">
             <a:extLst xmlns:a="http://schemas.openxmlformats.org/drawingml/2006/main">
               <a:ext uri="{FF2B5EF4-FFF2-40B4-BE49-F238E27FC236}">
-                <a16:creationId xmlns:a16="http://schemas.microsoft.com/office/drawing/2014/main" id="{E6A9FDE7-2CA5-478D-B75D-3A91FA6F7846}"/>
+                <a16:creationId xmlns:a16="http://schemas.microsoft.com/office/drawing/2014/main" id="{831120E2-8F60-461D-9347-DB58E1DE7AAB}"/>
               </a:ext>
             </a:extLst>
           </p:cNvPr>
@@ -3583,7 +3901,7 @@
           <p:cNvPr id="16" name="">
             <a:extLst xmlns:a="http://schemas.openxmlformats.org/drawingml/2006/main">
               <a:ext uri="{FF2B5EF4-FFF2-40B4-BE49-F238E27FC236}">
-                <a16:creationId xmlns:a16="http://schemas.microsoft.com/office/drawing/2014/main" id="{AA2F9F94-A8B7-4BBB-BEE7-D66D259B5DF9}"/>
+                <a16:creationId xmlns:a16="http://schemas.microsoft.com/office/drawing/2014/main" id="{1200571F-C9B1-4398-9264-519B69FA4405}"/>
               </a:ext>
             </a:extLst>
           </p:cNvPr>
@@ -3647,7 +3965,7 @@
           <p:cNvPr id="17" name="">
             <a:extLst xmlns:a="http://schemas.openxmlformats.org/drawingml/2006/main">
               <a:ext uri="{FF2B5EF4-FFF2-40B4-BE49-F238E27FC236}">
-                <a16:creationId xmlns:a16="http://schemas.microsoft.com/office/drawing/2014/main" id="{17A19CA6-5B44-4F8F-B8E6-36DD01344B43}"/>
+                <a16:creationId xmlns:a16="http://schemas.microsoft.com/office/drawing/2014/main" id="{32C49359-F13B-4D8A-9544-137A4078E7B3}"/>
               </a:ext>
             </a:extLst>
           </p:cNvPr>
@@ -3680,7 +3998,7 @@
           <p:cNvPr id="18" name="">
             <a:extLst xmlns:a="http://schemas.openxmlformats.org/drawingml/2006/main">
               <a:ext uri="{FF2B5EF4-FFF2-40B4-BE49-F238E27FC236}">
-                <a16:creationId xmlns:a16="http://schemas.microsoft.com/office/drawing/2014/main" id="{0066BFFE-C750-42AA-B1FB-C93BB03AC72F}"/>
+                <a16:creationId xmlns:a16="http://schemas.microsoft.com/office/drawing/2014/main" id="{7D2A97B2-160B-48BC-B6D7-3F51F24AEB93}"/>
               </a:ext>
             </a:extLst>
           </p:cNvPr>
@@ -3734,7 +4052,7 @@
                 <a:ea typeface="Aptos"/>
                 <a:cs typeface="Aptos"/>
               </a:rPr>
-              <a:t>Prochaines étapes</a:t>
+              <a:t>Prochaines �tapes</a:t>
             </a:r>
           </a:p>
         </p:txBody>
@@ -3744,7 +4062,7 @@
           <p:cNvPr id="19" name="">
             <a:extLst xmlns:a="http://schemas.openxmlformats.org/drawingml/2006/main">
               <a:ext uri="{FF2B5EF4-FFF2-40B4-BE49-F238E27FC236}">
-                <a16:creationId xmlns:a16="http://schemas.microsoft.com/office/drawing/2014/main" id="{CADD7681-1805-4F4E-B7DE-E51996159977}"/>
+                <a16:creationId xmlns:a16="http://schemas.microsoft.com/office/drawing/2014/main" id="{C39B960A-C153-4E07-ADAC-BAB68C338C88}"/>
               </a:ext>
             </a:extLst>
           </p:cNvPr>
@@ -3779,7 +4097,7 @@
           <p:cNvPr id="20" name="">
             <a:extLst xmlns:a="http://schemas.openxmlformats.org/drawingml/2006/main">
               <a:ext uri="{FF2B5EF4-FFF2-40B4-BE49-F238E27FC236}">
-                <a16:creationId xmlns:a16="http://schemas.microsoft.com/office/drawing/2014/main" id="{49F60582-EC4F-432F-AB00-D62647F2E210}"/>
+                <a16:creationId xmlns:a16="http://schemas.microsoft.com/office/drawing/2014/main" id="{57BE6285-C4BA-4AE0-8867-4CACC943B09F}"/>
               </a:ext>
             </a:extLst>
           </p:cNvPr>
@@ -3833,7 +4151,7 @@
                 <a:ea typeface="Aptos"/>
                 <a:cs typeface="Aptos"/>
               </a:rPr>
-              <a:t>Plus d'acteurs, vrais négatifs, machines et angles</a:t>
+              <a:t>Plus d'acteurs, vrais n�gatifs, machines et angles</a:t>
             </a:r>
           </a:p>
         </p:txBody>
@@ -3843,7 +4161,7 @@
           <p:cNvPr id="21" name="">
             <a:extLst xmlns:a="http://schemas.openxmlformats.org/drawingml/2006/main">
               <a:ext uri="{FF2B5EF4-FFF2-40B4-BE49-F238E27FC236}">
-                <a16:creationId xmlns:a16="http://schemas.microsoft.com/office/drawing/2014/main" id="{DE9697C5-585F-412A-B9B4-286CD2052CA4}"/>
+                <a16:creationId xmlns:a16="http://schemas.microsoft.com/office/drawing/2014/main" id="{18F2A6A0-8CD8-4F53-BEB0-5278E65CF43F}"/>
               </a:ext>
             </a:extLst>
           </p:cNvPr>
@@ -3878,7 +4196,7 @@
           <p:cNvPr id="22" name="">
             <a:extLst xmlns:a="http://schemas.openxmlformats.org/drawingml/2006/main">
               <a:ext uri="{FF2B5EF4-FFF2-40B4-BE49-F238E27FC236}">
-                <a16:creationId xmlns:a16="http://schemas.microsoft.com/office/drawing/2014/main" id="{99BE76DB-5016-4D5D-A2AF-8554C612DAD6}"/>
+                <a16:creationId xmlns:a16="http://schemas.microsoft.com/office/drawing/2014/main" id="{A27BDE0C-7EBA-4E31-B108-50DBC6A919D2}"/>
               </a:ext>
             </a:extLst>
           </p:cNvPr>
@@ -3942,7 +4260,7 @@
           <p:cNvPr id="23" name="">
             <a:extLst xmlns:a="http://schemas.openxmlformats.org/drawingml/2006/main">
               <a:ext uri="{FF2B5EF4-FFF2-40B4-BE49-F238E27FC236}">
-                <a16:creationId xmlns:a16="http://schemas.microsoft.com/office/drawing/2014/main" id="{84FCBD95-97A1-463E-A403-472B41F92ECA}"/>
+                <a16:creationId xmlns:a16="http://schemas.microsoft.com/office/drawing/2014/main" id="{B0C4E881-57D4-4260-BC61-4C55C83EB841}"/>
               </a:ext>
             </a:extLst>
           </p:cNvPr>
@@ -3977,7 +4295,7 @@
           <p:cNvPr id="24" name="">
             <a:extLst xmlns:a="http://schemas.openxmlformats.org/drawingml/2006/main">
               <a:ext uri="{FF2B5EF4-FFF2-40B4-BE49-F238E27FC236}">
-                <a16:creationId xmlns:a16="http://schemas.microsoft.com/office/drawing/2014/main" id="{E166A268-E098-4C3E-8976-0FEFA8F9736D}"/>
+                <a16:creationId xmlns:a16="http://schemas.microsoft.com/office/drawing/2014/main" id="{B708C2AB-BFCF-4EC7-80B5-42E85E1F568B}"/>
               </a:ext>
             </a:extLst>
           </p:cNvPr>
@@ -4031,7 +4349,7 @@
                 <a:ea typeface="Aptos"/>
                 <a:cs typeface="Aptos"/>
               </a:rPr>
-              <a:t>Latence complète: caméra jusqu'à mécanique</a:t>
+              <a:t>Latence compl�te: cam�ra jusqu'� m�canique</a:t>
             </a:r>
           </a:p>
         </p:txBody>
@@ -4041,7 +4359,7 @@
           <p:cNvPr id="25" name="">
             <a:extLst xmlns:a="http://schemas.openxmlformats.org/drawingml/2006/main">
               <a:ext uri="{FF2B5EF4-FFF2-40B4-BE49-F238E27FC236}">
-                <a16:creationId xmlns:a16="http://schemas.microsoft.com/office/drawing/2014/main" id="{8807AA37-911F-46A0-8950-0C14F7527CD8}"/>
+                <a16:creationId xmlns:a16="http://schemas.microsoft.com/office/drawing/2014/main" id="{0B1BFD9C-F120-4A36-A87B-E56BDFCAC7E2}"/>
               </a:ext>
             </a:extLst>
           </p:cNvPr>
@@ -4076,7 +4394,7 @@
           <p:cNvPr id="26" name="">
             <a:extLst xmlns:a="http://schemas.openxmlformats.org/drawingml/2006/main">
               <a:ext uri="{FF2B5EF4-FFF2-40B4-BE49-F238E27FC236}">
-                <a16:creationId xmlns:a16="http://schemas.microsoft.com/office/drawing/2014/main" id="{A1B68E4B-F7CA-4BB3-B37A-EF77C745E37A}"/>
+                <a16:creationId xmlns:a16="http://schemas.microsoft.com/office/drawing/2014/main" id="{C7F6A9A6-0798-450D-8A0E-B2C9DC9A44B1}"/>
               </a:ext>
             </a:extLst>
           </p:cNvPr>
@@ -4130,7 +4448,7 @@
                 <a:ea typeface="Aptos"/>
                 <a:cs typeface="Aptos"/>
               </a:rPr>
-              <a:t>Évaluation de sûreté au-delà de la classification</a:t>
+              <a:t>�valuation de s�ret� au-del� de la classification</a:t>
             </a:r>
           </a:p>
         </p:txBody>
@@ -4140,7 +4458,7 @@
           <p:cNvPr id="27" name="">
             <a:extLst xmlns:a="http://schemas.openxmlformats.org/drawingml/2006/main">
               <a:ext uri="{FF2B5EF4-FFF2-40B4-BE49-F238E27FC236}">
-                <a16:creationId xmlns:a16="http://schemas.microsoft.com/office/drawing/2014/main" id="{8678A619-277E-4337-AA2E-F1ED8100CD29}"/>
+                <a16:creationId xmlns:a16="http://schemas.microsoft.com/office/drawing/2014/main" id="{3A2B60A8-4604-4201-9E73-FFCADE2904B9}"/>
               </a:ext>
             </a:extLst>
           </p:cNvPr>
@@ -4194,7 +4512,7 @@
                 <a:ea typeface="Aptos"/>
                 <a:cs typeface="Aptos"/>
               </a:rPr>
-              <a:t>Phrase finale: c'est un prototype contrôlé avec un signal de sécurité utile; la suite est de prouver la robustesse hors scénario.</a:t>
+              <a:t>Phrase finale: c'est un prototype contr�l� avec un signal de s�curit� utile; la suite est de prouver la robustesse hors sc�nario.</a:t>
             </a:r>
           </a:p>
         </p:txBody>
@@ -4202,7 +4520,7 @@
     </p:spTree>
     <p:extLst>
       <p:ext uri="{BB962C8B-B14F-4D97-AF65-F5344CB8AC3E}">
-        <p14:creationId xmlns:p14="http://schemas.microsoft.com/office/powerpoint/2010/main" val="1775261320"/>
+        <p14:creationId xmlns:p14="http://schemas.microsoft.com/office/powerpoint/2010/main" val="547037448"/>
       </p:ext>
     </p:extLst>
   </p:cSld>
@@ -4226,7 +4544,7 @@
           <p:cNvPr id="1" name="">
             <a:extLst xmlns:a="http://schemas.openxmlformats.org/drawingml/2006/main">
               <a:ext uri="{FF2B5EF4-FFF2-40B4-BE49-F238E27FC236}">
-                <a16:creationId xmlns:a16="http://schemas.microsoft.com/office/drawing/2014/main" id="{B2AAA3BB-A7D6-41E5-9469-7DB04A8D6BF5}"/>
+                <a16:creationId xmlns:a16="http://schemas.microsoft.com/office/drawing/2014/main" id="{536DEC21-237C-46DC-A84D-FA2E740BC19C}"/>
               </a:ext>
             </a:extLst>
           </p:cNvPr>
@@ -4261,7 +4579,7 @@
           <p:cNvPr id="2" name="">
             <a:extLst xmlns:a="http://schemas.openxmlformats.org/drawingml/2006/main">
               <a:ext uri="{FF2B5EF4-FFF2-40B4-BE49-F238E27FC236}">
-                <a16:creationId xmlns:a16="http://schemas.microsoft.com/office/drawing/2014/main" id="{F6024745-DD07-4F0B-B748-17473F535A0B}"/>
+                <a16:creationId xmlns:a16="http://schemas.microsoft.com/office/drawing/2014/main" id="{A1A612A0-109D-42EF-89FF-C840AE0E409E}"/>
               </a:ext>
             </a:extLst>
           </p:cNvPr>
@@ -4315,7 +4633,7 @@
                 <a:ea typeface="Aptos"/>
                 <a:cs typeface="Aptos"/>
               </a:rPr>
-              <a:t>Artefact à montrer: timing_budget.png</a:t>
+              <a:t>Soutenance s�curit� machine</a:t>
             </a:r>
           </a:p>
         </p:txBody>
@@ -4325,7 +4643,7 @@
           <p:cNvPr id="3" name="">
             <a:extLst xmlns:a="http://schemas.openxmlformats.org/drawingml/2006/main">
               <a:ext uri="{FF2B5EF4-FFF2-40B4-BE49-F238E27FC236}">
-                <a16:creationId xmlns:a16="http://schemas.microsoft.com/office/drawing/2014/main" id="{5C4AF07C-F23A-4875-A6D7-D2EFF302A6EE}"/>
+                <a16:creationId xmlns:a16="http://schemas.microsoft.com/office/drawing/2014/main" id="{03E794EE-DC5C-4F77-9C27-678BDA39AE25}"/>
               </a:ext>
             </a:extLst>
           </p:cNvPr>
@@ -4389,7 +4707,7 @@
           <p:cNvPr id="4" name="">
             <a:extLst xmlns:a="http://schemas.openxmlformats.org/drawingml/2006/main">
               <a:ext uri="{FF2B5EF4-FFF2-40B4-BE49-F238E27FC236}">
-                <a16:creationId xmlns:a16="http://schemas.microsoft.com/office/drawing/2014/main" id="{EE8610F9-19C8-443D-B33F-BB92EEDCFFCA}"/>
+                <a16:creationId xmlns:a16="http://schemas.microsoft.com/office/drawing/2014/main" id="{FE93C6B8-347F-4043-9CCF-DEAA7FB8EA1A}"/>
               </a:ext>
             </a:extLst>
           </p:cNvPr>
@@ -4424,7 +4742,7 @@
           <p:cNvPr id="5" name="">
             <a:extLst xmlns:a="http://schemas.openxmlformats.org/drawingml/2006/main">
               <a:ext uri="{FF2B5EF4-FFF2-40B4-BE49-F238E27FC236}">
-                <a16:creationId xmlns:a16="http://schemas.microsoft.com/office/drawing/2014/main" id="{44AC36AE-F9C0-4562-B5D3-2312C66A968E}"/>
+                <a16:creationId xmlns:a16="http://schemas.microsoft.com/office/drawing/2014/main" id="{1633C301-52DF-47B5-B89B-75CAA17ADE85}"/>
               </a:ext>
             </a:extLst>
           </p:cNvPr>
@@ -4478,7 +4796,7 @@
                 <a:ea typeface="Aptos"/>
                 <a:cs typeface="Aptos"/>
               </a:rPr>
-              <a:t>CIBLE OPÉRATIONNELLE</a:t>
+              <a:t>CIBLE OP�RATIONNELLE</a:t>
             </a:r>
           </a:p>
         </p:txBody>
@@ -4488,7 +4806,7 @@
           <p:cNvPr id="6" name="">
             <a:extLst xmlns:a="http://schemas.openxmlformats.org/drawingml/2006/main">
               <a:ext uri="{FF2B5EF4-FFF2-40B4-BE49-F238E27FC236}">
-                <a16:creationId xmlns:a16="http://schemas.microsoft.com/office/drawing/2014/main" id="{C4CDA26F-1126-46DD-A37D-0F7656DE5766}"/>
+                <a16:creationId xmlns:a16="http://schemas.microsoft.com/office/drawing/2014/main" id="{145E2E32-351D-4762-9190-979C8AC4F0A1}"/>
               </a:ext>
             </a:extLst>
           </p:cNvPr>
@@ -4542,7 +4860,7 @@
                 <a:ea typeface="Aptos Display"/>
                 <a:cs typeface="Aptos Display"/>
               </a:rPr>
-              <a:t>Le système est utile seulement s'il gagne du temps avant l'entrée.</a:t>
+              <a:t>Le syst�me est utile seulement s'il gagne du temps avant l'entr�e.</a:t>
             </a:r>
           </a:p>
         </p:txBody>
@@ -4556,7 +4874,7 @@
           <p:nvPr/>
         </p:nvPicPr>
         <p:blipFill>
-          <a:blip xmlns:r="http://schemas.openxmlformats.org/officeDocument/2006/relationships" xmlns:a="http://schemas.openxmlformats.org/drawingml/2006/main" r:embed="R284aed35f5fa4e16"/>
+          <a:blip xmlns:r="http://schemas.openxmlformats.org/officeDocument/2006/relationships" xmlns:a="http://schemas.openxmlformats.org/drawingml/2006/main" r:embed="R0bde15ac566e4276"/>
           <a:stretch xmlns:a="http://schemas.openxmlformats.org/drawingml/2006/main"/>
         </p:blipFill>
         <p:spPr>
@@ -4574,7 +4892,7 @@
           <p:cNvPr id="8" name="">
             <a:extLst xmlns:a="http://schemas.openxmlformats.org/drawingml/2006/main">
               <a:ext uri="{FF2B5EF4-FFF2-40B4-BE49-F238E27FC236}">
-                <a16:creationId xmlns:a16="http://schemas.microsoft.com/office/drawing/2014/main" id="{20A0AA69-EE28-4A6A-8CC3-D53A1798F406}"/>
+                <a16:creationId xmlns:a16="http://schemas.microsoft.com/office/drawing/2014/main" id="{C4942970-C5E4-4AA5-BC16-4327EE44C510}"/>
               </a:ext>
             </a:extLst>
           </p:cNvPr>
@@ -4607,7 +4925,7 @@
           <p:cNvPr id="9" name="">
             <a:extLst xmlns:a="http://schemas.openxmlformats.org/drawingml/2006/main">
               <a:ext uri="{FF2B5EF4-FFF2-40B4-BE49-F238E27FC236}">
-                <a16:creationId xmlns:a16="http://schemas.microsoft.com/office/drawing/2014/main" id="{7C9829E2-B2F3-4E82-BC45-550A7F80B3AD}"/>
+                <a16:creationId xmlns:a16="http://schemas.microsoft.com/office/drawing/2014/main" id="{76E69BF3-3358-4D6B-A7DF-DFB393C583AE}"/>
               </a:ext>
             </a:extLst>
           </p:cNvPr>
@@ -4661,7 +4979,7 @@
                 <a:ea typeface="Aptos"/>
                 <a:cs typeface="Aptos"/>
               </a:rPr>
-              <a:t>Alerte humaine</a:t>
+              <a:t>Alerte op�rateur</a:t>
             </a:r>
           </a:p>
         </p:txBody>
@@ -4671,7 +4989,7 @@
           <p:cNvPr id="10" name="">
             <a:extLst xmlns:a="http://schemas.openxmlformats.org/drawingml/2006/main">
               <a:ext uri="{FF2B5EF4-FFF2-40B4-BE49-F238E27FC236}">
-                <a16:creationId xmlns:a16="http://schemas.microsoft.com/office/drawing/2014/main" id="{7D74252C-BB5B-49ED-BC06-DD7A183CF901}"/>
+                <a16:creationId xmlns:a16="http://schemas.microsoft.com/office/drawing/2014/main" id="{F5D803DD-7D53-4174-B5C4-CC77DDBB17EE}"/>
               </a:ext>
             </a:extLst>
           </p:cNvPr>
@@ -4725,7 +5043,7 @@
                 <a:ea typeface="Aptos"/>
                 <a:cs typeface="Aptos"/>
               </a:rPr>
-              <a:t>Plus précoce, plus tolérante aux faux positifs</a:t>
+              <a:t>TCN risk_present_now, plus pr�coce et plus tol�rante aux faux positifs</a:t>
             </a:r>
           </a:p>
         </p:txBody>
@@ -4735,7 +5053,7 @@
           <p:cNvPr id="11" name="">
             <a:extLst xmlns:a="http://schemas.openxmlformats.org/drawingml/2006/main">
               <a:ext uri="{FF2B5EF4-FFF2-40B4-BE49-F238E27FC236}">
-                <a16:creationId xmlns:a16="http://schemas.microsoft.com/office/drawing/2014/main" id="{45684A9F-CF08-49BC-B457-843F50E9EEF1}"/>
+                <a16:creationId xmlns:a16="http://schemas.microsoft.com/office/drawing/2014/main" id="{8925C5C2-8A4B-4143-BF77-91A7C294621B}"/>
               </a:ext>
             </a:extLst>
           </p:cNvPr>
@@ -4768,7 +5086,7 @@
           <p:cNvPr id="12" name="">
             <a:extLst xmlns:a="http://schemas.openxmlformats.org/drawingml/2006/main">
               <a:ext uri="{FF2B5EF4-FFF2-40B4-BE49-F238E27FC236}">
-                <a16:creationId xmlns:a16="http://schemas.microsoft.com/office/drawing/2014/main" id="{244F6649-F672-4A16-BE41-5CE572CB7D40}"/>
+                <a16:creationId xmlns:a16="http://schemas.microsoft.com/office/drawing/2014/main" id="{676BB7E6-DBC4-47BE-851D-F3B0B4B2CF7A}"/>
               </a:ext>
             </a:extLst>
           </p:cNvPr>
@@ -4822,7 +5140,7 @@
                 <a:ea typeface="Aptos"/>
                 <a:cs typeface="Aptos"/>
               </a:rPr>
-              <a:t>Signal physique</a:t>
+              <a:t>Entr�e physique</a:t>
             </a:r>
           </a:p>
         </p:txBody>
@@ -4832,7 +5150,7 @@
           <p:cNvPr id="13" name="">
             <a:extLst xmlns:a="http://schemas.openxmlformats.org/drawingml/2006/main">
               <a:ext uri="{FF2B5EF4-FFF2-40B4-BE49-F238E27FC236}">
-                <a16:creationId xmlns:a16="http://schemas.microsoft.com/office/drawing/2014/main" id="{2BF174D6-BA8D-4262-9E12-26D5B4610392}"/>
+                <a16:creationId xmlns:a16="http://schemas.microsoft.com/office/drawing/2014/main" id="{BF810083-0030-45C5-8565-A445EE60F560}"/>
               </a:ext>
             </a:extLst>
           </p:cNvPr>
@@ -4886,7 +5204,7 @@
                 <a:ea typeface="Aptos"/>
                 <a:cs typeface="Aptos"/>
               </a:rPr>
-              <a:t>Score causal de séquence pose-zone</a:t>
+              <a:t>�v�nement objectif mesur� sur la zone dangereuse</a:t>
             </a:r>
           </a:p>
         </p:txBody>
@@ -4896,7 +5214,7 @@
           <p:cNvPr id="14" name="">
             <a:extLst xmlns:a="http://schemas.openxmlformats.org/drawingml/2006/main">
               <a:ext uri="{FF2B5EF4-FFF2-40B4-BE49-F238E27FC236}">
-                <a16:creationId xmlns:a16="http://schemas.microsoft.com/office/drawing/2014/main" id="{544A85BF-052F-48BA-A9D5-A3F7F57FCA93}"/>
+                <a16:creationId xmlns:a16="http://schemas.microsoft.com/office/drawing/2014/main" id="{2132F88B-9FDC-4FD5-B422-AB2B18FD0461}"/>
               </a:ext>
             </a:extLst>
           </p:cNvPr>
@@ -4929,7 +5247,7 @@
           <p:cNvPr id="15" name="">
             <a:extLst xmlns:a="http://schemas.openxmlformats.org/drawingml/2006/main">
               <a:ext uri="{FF2B5EF4-FFF2-40B4-BE49-F238E27FC236}">
-                <a16:creationId xmlns:a16="http://schemas.microsoft.com/office/drawing/2014/main" id="{175F79CF-52D0-46F1-9B00-2C94351BCA2E}"/>
+                <a16:creationId xmlns:a16="http://schemas.microsoft.com/office/drawing/2014/main" id="{55BF3DEB-1008-43AF-8A26-C8880CC02313}"/>
               </a:ext>
             </a:extLst>
           </p:cNvPr>
@@ -4983,7 +5301,7 @@
                 <a:ea typeface="Aptos"/>
                 <a:cs typeface="Aptos"/>
               </a:rPr>
-              <a:t>Arrêt auto</a:t>
+              <a:t>Arr�t auto</a:t>
             </a:r>
           </a:p>
         </p:txBody>
@@ -4993,7 +5311,7 @@
           <p:cNvPr id="16" name="">
             <a:extLst xmlns:a="http://schemas.openxmlformats.org/drawingml/2006/main">
               <a:ext uri="{FF2B5EF4-FFF2-40B4-BE49-F238E27FC236}">
-                <a16:creationId xmlns:a16="http://schemas.microsoft.com/office/drawing/2014/main" id="{E1271933-825D-409E-9C69-52EBF675670B}"/>
+                <a16:creationId xmlns:a16="http://schemas.microsoft.com/office/drawing/2014/main" id="{0F86E6AD-1A16-4E46-A2C1-63B5648FE97C}"/>
               </a:ext>
             </a:extLst>
           </p:cNvPr>
@@ -5047,7 +5365,7 @@
                 <a:ea typeface="Aptos"/>
                 <a:cs typeface="Aptos"/>
               </a:rPr>
-              <a:t>Court horizon, confiance élevée seulement</a:t>
+              <a:t>GRU exact-entry, court horizon et confiance �lev�e seulement</a:t>
             </a:r>
           </a:p>
         </p:txBody>
@@ -5057,7 +5375,7 @@
           <p:cNvPr id="17" name="">
             <a:extLst xmlns:a="http://schemas.openxmlformats.org/drawingml/2006/main">
               <a:ext uri="{FF2B5EF4-FFF2-40B4-BE49-F238E27FC236}">
-                <a16:creationId xmlns:a16="http://schemas.microsoft.com/office/drawing/2014/main" id="{33210540-F83A-4087-AD47-3667C1E64961}"/>
+                <a16:creationId xmlns:a16="http://schemas.microsoft.com/office/drawing/2014/main" id="{D0F9F5B5-A005-454C-ACCD-44505C260C11}"/>
               </a:ext>
             </a:extLst>
           </p:cNvPr>
@@ -5090,7 +5408,7 @@
           <p:cNvPr id="18" name="">
             <a:extLst xmlns:a="http://schemas.openxmlformats.org/drawingml/2006/main">
               <a:ext uri="{FF2B5EF4-FFF2-40B4-BE49-F238E27FC236}">
-                <a16:creationId xmlns:a16="http://schemas.microsoft.com/office/drawing/2014/main" id="{1D83FA90-9662-4019-8E86-9D7CAC83668B}"/>
+                <a16:creationId xmlns:a16="http://schemas.microsoft.com/office/drawing/2014/main" id="{9EBC059F-E66D-41AF-B914-90A4DEC8DC3C}"/>
               </a:ext>
             </a:extLst>
           </p:cNvPr>
@@ -5144,7 +5462,7 @@
                 <a:ea typeface="Aptos"/>
                 <a:cs typeface="Aptos"/>
               </a:rPr>
-              <a:t>Message oral: séparer l'alerte de l'arrêt automatique. La même famille de modèles peut aider les deux, mais le seuil opérationnel n'est pas le même.</a:t>
+              <a:t>Le TCN sert l'alerte op�rateur continue. Le GRU exact-entry sert l'imminence d'arr�t quand l'entr�e physique devient cr�dible � 0,2-0,3 s.</a:t>
             </a:r>
           </a:p>
         </p:txBody>
@@ -5152,7 +5470,7 @@
     </p:spTree>
     <p:extLst>
       <p:ext uri="{BB962C8B-B14F-4D97-AF65-F5344CB8AC3E}">
-        <p14:creationId xmlns:p14="http://schemas.microsoft.com/office/powerpoint/2010/main" val="585873144"/>
+        <p14:creationId xmlns:p14="http://schemas.microsoft.com/office/powerpoint/2010/main" val="1798774334"/>
       </p:ext>
     </p:extLst>
   </p:cSld>
@@ -5176,7 +5494,7 @@
           <p:cNvPr id="1" name="">
             <a:extLst xmlns:a="http://schemas.openxmlformats.org/drawingml/2006/main">
               <a:ext uri="{FF2B5EF4-FFF2-40B4-BE49-F238E27FC236}">
-                <a16:creationId xmlns:a16="http://schemas.microsoft.com/office/drawing/2014/main" id="{F920AB23-1345-4A78-9F2D-D8063FFBB9B0}"/>
+                <a16:creationId xmlns:a16="http://schemas.microsoft.com/office/drawing/2014/main" id="{5089D4CE-306C-4781-8283-E8B9EE7913D1}"/>
               </a:ext>
             </a:extLst>
           </p:cNvPr>
@@ -5211,7 +5529,7 @@
           <p:cNvPr id="2" name="">
             <a:extLst xmlns:a="http://schemas.openxmlformats.org/drawingml/2006/main">
               <a:ext uri="{FF2B5EF4-FFF2-40B4-BE49-F238E27FC236}">
-                <a16:creationId xmlns:a16="http://schemas.microsoft.com/office/drawing/2014/main" id="{FAA89A43-6808-4039-B1D9-4F3E731CB259}"/>
+                <a16:creationId xmlns:a16="http://schemas.microsoft.com/office/drawing/2014/main" id="{3209C919-951B-400F-B413-91F7E2363375}"/>
               </a:ext>
             </a:extLst>
           </p:cNvPr>
@@ -5265,7 +5583,7 @@
                 <a:ea typeface="Aptos"/>
                 <a:cs typeface="Aptos"/>
               </a:rPr>
-              <a:t>Artefact à montrer: dataset_event_distribution.png</a:t>
+              <a:t>Soutenance s�curit� machine</a:t>
             </a:r>
           </a:p>
         </p:txBody>
@@ -5275,7 +5593,7 @@
           <p:cNvPr id="3" name="">
             <a:extLst xmlns:a="http://schemas.openxmlformats.org/drawingml/2006/main">
               <a:ext uri="{FF2B5EF4-FFF2-40B4-BE49-F238E27FC236}">
-                <a16:creationId xmlns:a16="http://schemas.microsoft.com/office/drawing/2014/main" id="{9C53D3B2-45D3-45AF-9E87-08AFCA345EDF}"/>
+                <a16:creationId xmlns:a16="http://schemas.microsoft.com/office/drawing/2014/main" id="{371A7585-1E81-44F9-816A-2CE655EE260B}"/>
               </a:ext>
             </a:extLst>
           </p:cNvPr>
@@ -5339,7 +5657,7 @@
           <p:cNvPr id="4" name="">
             <a:extLst xmlns:a="http://schemas.openxmlformats.org/drawingml/2006/main">
               <a:ext uri="{FF2B5EF4-FFF2-40B4-BE49-F238E27FC236}">
-                <a16:creationId xmlns:a16="http://schemas.microsoft.com/office/drawing/2014/main" id="{4AA9567D-1F8F-4DAF-8BB1-9B60DD6E9CF2}"/>
+                <a16:creationId xmlns:a16="http://schemas.microsoft.com/office/drawing/2014/main" id="{99E941E9-4A61-46E5-82FB-8B17B19388A8}"/>
               </a:ext>
             </a:extLst>
           </p:cNvPr>
@@ -5374,7 +5692,7 @@
           <p:cNvPr id="5" name="">
             <a:extLst xmlns:a="http://schemas.openxmlformats.org/drawingml/2006/main">
               <a:ext uri="{FF2B5EF4-FFF2-40B4-BE49-F238E27FC236}">
-                <a16:creationId xmlns:a16="http://schemas.microsoft.com/office/drawing/2014/main" id="{B7B022D0-12DF-4843-86CC-0451D711BCE7}"/>
+                <a16:creationId xmlns:a16="http://schemas.microsoft.com/office/drawing/2014/main" id="{228B8936-AFC5-4AF2-8DE6-26D7DB0D3247}"/>
               </a:ext>
             </a:extLst>
           </p:cNvPr>
@@ -5428,7 +5746,7 @@
                 <a:ea typeface="Aptos"/>
                 <a:cs typeface="Aptos"/>
               </a:rPr>
-              <a:t>RÉALITÉ DU DATASET</a:t>
+              <a:t>R�ALIT� DU DATASET</a:t>
             </a:r>
           </a:p>
         </p:txBody>
@@ -5438,7 +5756,7 @@
           <p:cNvPr id="6" name="">
             <a:extLst xmlns:a="http://schemas.openxmlformats.org/drawingml/2006/main">
               <a:ext uri="{FF2B5EF4-FFF2-40B4-BE49-F238E27FC236}">
-                <a16:creationId xmlns:a16="http://schemas.microsoft.com/office/drawing/2014/main" id="{9A97ED80-BE92-4A89-BAD6-58A653492076}"/>
+                <a16:creationId xmlns:a16="http://schemas.microsoft.com/office/drawing/2014/main" id="{A5AF4AE5-9623-4087-A3BA-BE8154B46644}"/>
               </a:ext>
             </a:extLst>
           </p:cNvPr>
@@ -5492,7 +5810,7 @@
                 <a:ea typeface="Aptos Display"/>
                 <a:cs typeface="Aptos Display"/>
               </a:rPr>
-              <a:t>Le dataset est petit, mais centré sur l'événement rare à apprendre.</a:t>
+              <a:t>Le dataset est petit, mais centr� sur l'�v�nement rare � apprendre.</a:t>
             </a:r>
           </a:p>
         </p:txBody>
@@ -5506,7 +5824,7 @@
           <p:nvPr/>
         </p:nvPicPr>
         <p:blipFill>
-          <a:blip xmlns:r="http://schemas.openxmlformats.org/officeDocument/2006/relationships" xmlns:a="http://schemas.openxmlformats.org/drawingml/2006/main" r:embed="R771626fe2f744787"/>
+          <a:blip xmlns:r="http://schemas.openxmlformats.org/officeDocument/2006/relationships" xmlns:a="http://schemas.openxmlformats.org/drawingml/2006/main" r:embed="Rf3ab545c721348ce"/>
           <a:stretch xmlns:a="http://schemas.openxmlformats.org/drawingml/2006/main"/>
         </p:blipFill>
         <p:spPr>
@@ -5524,7 +5842,7 @@
           <p:cNvPr id="8" name="">
             <a:extLst xmlns:a="http://schemas.openxmlformats.org/drawingml/2006/main">
               <a:ext uri="{FF2B5EF4-FFF2-40B4-BE49-F238E27FC236}">
-                <a16:creationId xmlns:a16="http://schemas.microsoft.com/office/drawing/2014/main" id="{405D1927-B7C5-4889-9006-9499A9A4D816}"/>
+                <a16:creationId xmlns:a16="http://schemas.microsoft.com/office/drawing/2014/main" id="{18663738-067A-4C2D-9245-198A62EE29B3}"/>
               </a:ext>
             </a:extLst>
           </p:cNvPr>
@@ -5559,7 +5877,7 @@
           <p:cNvPr id="9" name="">
             <a:extLst xmlns:a="http://schemas.openxmlformats.org/drawingml/2006/main">
               <a:ext uri="{FF2B5EF4-FFF2-40B4-BE49-F238E27FC236}">
-                <a16:creationId xmlns:a16="http://schemas.microsoft.com/office/drawing/2014/main" id="{449E55B9-01D4-4689-83D3-EF88B1D03E4D}"/>
+                <a16:creationId xmlns:a16="http://schemas.microsoft.com/office/drawing/2014/main" id="{B17D1937-FDE5-4B3C-AFE3-167ABC299215}"/>
               </a:ext>
             </a:extLst>
           </p:cNvPr>
@@ -5623,7 +5941,7 @@
           <p:cNvPr id="10" name="">
             <a:extLst xmlns:a="http://schemas.openxmlformats.org/drawingml/2006/main">
               <a:ext uri="{FF2B5EF4-FFF2-40B4-BE49-F238E27FC236}">
-                <a16:creationId xmlns:a16="http://schemas.microsoft.com/office/drawing/2014/main" id="{0E28AD8D-03C6-49A1-9A99-465777F18E56}"/>
+                <a16:creationId xmlns:a16="http://schemas.microsoft.com/office/drawing/2014/main" id="{2D0265C2-6D27-4F66-B101-3B33D0B60CE4}"/>
               </a:ext>
             </a:extLst>
           </p:cNvPr>
@@ -5677,7 +5995,7 @@
                 <a:ea typeface="Aptos"/>
                 <a:cs typeface="Aptos"/>
               </a:rPr>
-              <a:t>fenêtres sans danger</a:t>
+              <a:t>fen�tres sans danger</a:t>
             </a:r>
           </a:p>
         </p:txBody>
@@ -5687,7 +6005,7 @@
           <p:cNvPr id="11" name="">
             <a:extLst xmlns:a="http://schemas.openxmlformats.org/drawingml/2006/main">
               <a:ext uri="{FF2B5EF4-FFF2-40B4-BE49-F238E27FC236}">
-                <a16:creationId xmlns:a16="http://schemas.microsoft.com/office/drawing/2014/main" id="{B2A50A2B-E28A-43ED-9969-0BC18718F60B}"/>
+                <a16:creationId xmlns:a16="http://schemas.microsoft.com/office/drawing/2014/main" id="{760B0A0E-424D-4E67-B4C8-0416EFD243B9}"/>
               </a:ext>
             </a:extLst>
           </p:cNvPr>
@@ -5751,7 +6069,7 @@
           <p:cNvPr id="12" name="">
             <a:extLst xmlns:a="http://schemas.openxmlformats.org/drawingml/2006/main">
               <a:ext uri="{FF2B5EF4-FFF2-40B4-BE49-F238E27FC236}">
-                <a16:creationId xmlns:a16="http://schemas.microsoft.com/office/drawing/2014/main" id="{24BDFC1C-7993-4340-9D30-B9A855D0DF6C}"/>
+                <a16:creationId xmlns:a16="http://schemas.microsoft.com/office/drawing/2014/main" id="{92588819-B7D4-4BE0-B376-333ABD6CE1C6}"/>
               </a:ext>
             </a:extLst>
           </p:cNvPr>
@@ -5805,7 +6123,7 @@
                 <a:ea typeface="Aptos"/>
                 <a:cs typeface="Aptos"/>
               </a:rPr>
-              <a:t>fenêtres d'entrée</a:t>
+              <a:t>fen�tres d'entr�e</a:t>
             </a:r>
           </a:p>
         </p:txBody>
@@ -5815,7 +6133,7 @@
           <p:cNvPr id="13" name="">
             <a:extLst xmlns:a="http://schemas.openxmlformats.org/drawingml/2006/main">
               <a:ext uri="{FF2B5EF4-FFF2-40B4-BE49-F238E27FC236}">
-                <a16:creationId xmlns:a16="http://schemas.microsoft.com/office/drawing/2014/main" id="{E4D6A47D-50D9-45CC-B81B-E32D6B97BD75}"/>
+                <a16:creationId xmlns:a16="http://schemas.microsoft.com/office/drawing/2014/main" id="{6EFF93E8-34B1-4FA9-B47E-BFA06FB4D90B}"/>
               </a:ext>
             </a:extLst>
           </p:cNvPr>
@@ -5879,7 +6197,7 @@
           <p:cNvPr id="14" name="">
             <a:extLst xmlns:a="http://schemas.openxmlformats.org/drawingml/2006/main">
               <a:ext uri="{FF2B5EF4-FFF2-40B4-BE49-F238E27FC236}">
-                <a16:creationId xmlns:a16="http://schemas.microsoft.com/office/drawing/2014/main" id="{390A85B6-C0D3-44DB-BB1F-660278BEB487}"/>
+                <a16:creationId xmlns:a16="http://schemas.microsoft.com/office/drawing/2014/main" id="{B7DBD9A7-81B1-4730-B9E4-305CA7BA86E7}"/>
               </a:ext>
             </a:extLst>
           </p:cNvPr>
@@ -5933,7 +6251,7 @@
                 <a:ea typeface="Aptos"/>
                 <a:cs typeface="Aptos"/>
               </a:rPr>
-              <a:t>positif vs négatif pour la cible 1,0 s</a:t>
+              <a:t>positif vs n�gatif pour la cible 1,0 s</a:t>
             </a:r>
           </a:p>
         </p:txBody>
@@ -5943,7 +6261,7 @@
           <p:cNvPr id="15" name="">
             <a:extLst xmlns:a="http://schemas.openxmlformats.org/drawingml/2006/main">
               <a:ext uri="{FF2B5EF4-FFF2-40B4-BE49-F238E27FC236}">
-                <a16:creationId xmlns:a16="http://schemas.microsoft.com/office/drawing/2014/main" id="{04636229-4F1E-4E1A-A4C3-D8C6A2E25F28}"/>
+                <a16:creationId xmlns:a16="http://schemas.microsoft.com/office/drawing/2014/main" id="{CECB6CC3-0692-4E09-8588-E71CE0F72AFD}"/>
               </a:ext>
             </a:extLst>
           </p:cNvPr>
@@ -5997,7 +6315,7 @@
                 <a:ea typeface="Aptos"/>
                 <a:cs typeface="Aptos"/>
               </a:rPr>
-              <a:t>Point clé: le graphique de gauche compte les épisodes vidéo, pas tout le temps d'entraînement. Au niveau des fenêtres, le temps sans danger est beaucoup plus grand.</a:t>
+              <a:t>Point cl�: le graphique de gauche compte les �pisodes vid�o, pas tout le temps d'entra�nement. Au niveau des fen�tres, le temps sans danger est beaucoup plus grand.</a:t>
             </a:r>
           </a:p>
         </p:txBody>
@@ -6005,7 +6323,7 @@
     </p:spTree>
     <p:extLst>
       <p:ext uri="{BB962C8B-B14F-4D97-AF65-F5344CB8AC3E}">
-        <p14:creationId xmlns:p14="http://schemas.microsoft.com/office/powerpoint/2010/main" val="1990748961"/>
+        <p14:creationId xmlns:p14="http://schemas.microsoft.com/office/powerpoint/2010/main" val="1757595554"/>
       </p:ext>
     </p:extLst>
   </p:cSld>
@@ -6029,7 +6347,7 @@
           <p:cNvPr id="1" name="">
             <a:extLst xmlns:a="http://schemas.openxmlformats.org/drawingml/2006/main">
               <a:ext uri="{FF2B5EF4-FFF2-40B4-BE49-F238E27FC236}">
-                <a16:creationId xmlns:a16="http://schemas.microsoft.com/office/drawing/2014/main" id="{79C24E0A-3D64-4D5B-A869-3B5B6231EC20}"/>
+                <a16:creationId xmlns:a16="http://schemas.microsoft.com/office/drawing/2014/main" id="{E383B76F-3A5D-49BC-90A6-B67615878C58}"/>
               </a:ext>
             </a:extLst>
           </p:cNvPr>
@@ -6064,7 +6382,7 @@
           <p:cNvPr id="2" name="">
             <a:extLst xmlns:a="http://schemas.openxmlformats.org/drawingml/2006/main">
               <a:ext uri="{FF2B5EF4-FFF2-40B4-BE49-F238E27FC236}">
-                <a16:creationId xmlns:a16="http://schemas.microsoft.com/office/drawing/2014/main" id="{30329DDF-A3E9-4826-8150-25F280D92DCF}"/>
+                <a16:creationId xmlns:a16="http://schemas.microsoft.com/office/drawing/2014/main" id="{931E2730-8CEF-4A71-B616-D2DDFCF36A87}"/>
               </a:ext>
             </a:extLst>
           </p:cNvPr>
@@ -6118,7 +6436,7 @@
                 <a:ea typeface="Aptos"/>
                 <a:cs typeface="Aptos"/>
               </a:rPr>
-              <a:t>Artefact à montrer en direct: file d'annotation + édition de zone</a:t>
+              <a:t>Soutenance s�curit� machine</a:t>
             </a:r>
           </a:p>
         </p:txBody>
@@ -6128,7 +6446,7 @@
           <p:cNvPr id="3" name="">
             <a:extLst xmlns:a="http://schemas.openxmlformats.org/drawingml/2006/main">
               <a:ext uri="{FF2B5EF4-FFF2-40B4-BE49-F238E27FC236}">
-                <a16:creationId xmlns:a16="http://schemas.microsoft.com/office/drawing/2014/main" id="{73CA4B93-C4CF-40B5-A420-E0F50D07DF98}"/>
+                <a16:creationId xmlns:a16="http://schemas.microsoft.com/office/drawing/2014/main" id="{6B39FFFC-0915-479B-B8FC-7174DB8DB1E9}"/>
               </a:ext>
             </a:extLst>
           </p:cNvPr>
@@ -6192,7 +6510,7 @@
           <p:cNvPr id="4" name="">
             <a:extLst xmlns:a="http://schemas.openxmlformats.org/drawingml/2006/main">
               <a:ext uri="{FF2B5EF4-FFF2-40B4-BE49-F238E27FC236}">
-                <a16:creationId xmlns:a16="http://schemas.microsoft.com/office/drawing/2014/main" id="{7B2BD041-029B-41CD-AEE3-2BE898FCC17B}"/>
+                <a16:creationId xmlns:a16="http://schemas.microsoft.com/office/drawing/2014/main" id="{2EBE8248-BA57-4EDC-8BAD-228080ACADBF}"/>
               </a:ext>
             </a:extLst>
           </p:cNvPr>
@@ -6227,7 +6545,7 @@
           <p:cNvPr id="5" name="">
             <a:extLst xmlns:a="http://schemas.openxmlformats.org/drawingml/2006/main">
               <a:ext uri="{FF2B5EF4-FFF2-40B4-BE49-F238E27FC236}">
-                <a16:creationId xmlns:a16="http://schemas.microsoft.com/office/drawing/2014/main" id="{05C69BBB-6C03-49E9-A47F-203E2DF21F8F}"/>
+                <a16:creationId xmlns:a16="http://schemas.microsoft.com/office/drawing/2014/main" id="{E3BD624B-1DA4-4A8B-A44F-EE9EF18173FC}"/>
               </a:ext>
             </a:extLst>
           </p:cNvPr>
@@ -6281,7 +6599,7 @@
                 <a:ea typeface="Aptos"/>
                 <a:cs typeface="Aptos"/>
               </a:rPr>
-              <a:t>ANNOTATION COMME MÉTHODE</a:t>
+              <a:t>ANNOTATION COMME M�THODE</a:t>
             </a:r>
           </a:p>
         </p:txBody>
@@ -6291,7 +6609,7 @@
           <p:cNvPr id="6" name="">
             <a:extLst xmlns:a="http://schemas.openxmlformats.org/drawingml/2006/main">
               <a:ext uri="{FF2B5EF4-FFF2-40B4-BE49-F238E27FC236}">
-                <a16:creationId xmlns:a16="http://schemas.microsoft.com/office/drawing/2014/main" id="{1A86FB3C-3245-414B-9435-BCD6CE275EE5}"/>
+                <a16:creationId xmlns:a16="http://schemas.microsoft.com/office/drawing/2014/main" id="{F6745F75-14F4-44F0-A8BF-0E952579E576}"/>
               </a:ext>
             </a:extLst>
           </p:cNvPr>
@@ -6345,7 +6663,7 @@
                 <a:ea typeface="Aptos Display"/>
                 <a:cs typeface="Aptos Display"/>
               </a:rPr>
-              <a:t>Nous avons créé l'outil d'annotation car la cible est temporelle.</a:t>
+              <a:t>Nous avons cr�� l'outil d'annotation car la cible est temporelle.</a:t>
             </a:r>
           </a:p>
         </p:txBody>
@@ -6359,7 +6677,7 @@
           <p:nvPr/>
         </p:nvPicPr>
         <p:blipFill>
-          <a:blip xmlns:r="http://schemas.openxmlformats.org/officeDocument/2006/relationships" xmlns:a="http://schemas.openxmlformats.org/drawingml/2006/main" r:embed="R8537598550744ada"/>
+          <a:blip xmlns:r="http://schemas.openxmlformats.org/officeDocument/2006/relationships" xmlns:a="http://schemas.openxmlformats.org/drawingml/2006/main" r:embed="R43fa10e353ef4365"/>
           <a:stretch xmlns:a="http://schemas.openxmlformats.org/drawingml/2006/main"/>
         </p:blipFill>
         <p:spPr>
@@ -6377,7 +6695,7 @@
           <p:cNvPr id="8" name="">
             <a:extLst xmlns:a="http://schemas.openxmlformats.org/drawingml/2006/main">
               <a:ext uri="{FF2B5EF4-FFF2-40B4-BE49-F238E27FC236}">
-                <a16:creationId xmlns:a16="http://schemas.microsoft.com/office/drawing/2014/main" id="{C355EFA2-09FA-41E1-95C6-82F5ADFAD858}"/>
+                <a16:creationId xmlns:a16="http://schemas.microsoft.com/office/drawing/2014/main" id="{893E2785-A7EF-4ADD-B2FE-1F596A456DC0}"/>
               </a:ext>
             </a:extLst>
           </p:cNvPr>
@@ -6410,7 +6728,7 @@
           <p:cNvPr id="9" name="">
             <a:extLst xmlns:a="http://schemas.openxmlformats.org/drawingml/2006/main">
               <a:ext uri="{FF2B5EF4-FFF2-40B4-BE49-F238E27FC236}">
-                <a16:creationId xmlns:a16="http://schemas.microsoft.com/office/drawing/2014/main" id="{6B7EA55D-38A6-4D23-A834-7C09898C63EC}"/>
+                <a16:creationId xmlns:a16="http://schemas.microsoft.com/office/drawing/2014/main" id="{843DD8BE-962D-4DCD-A7BB-E1DF4A7C4D59}"/>
               </a:ext>
             </a:extLst>
           </p:cNvPr>
@@ -6510,7 +6828,7 @@
                 <a:ea typeface="Aptos"/>
                 <a:cs typeface="Aptos"/>
               </a:rPr>
-              <a:t>- marqueurs risque et entrée physique</a:t>
+              <a:t>- marqueurs risque et entr�e physique</a:t>
             </a:r>
           </a:p>
           <a:p xmlns:a="http://schemas.openxmlformats.org/drawingml/2006/main">
@@ -6566,7 +6884,7 @@
           <p:cNvPr id="10" name="">
             <a:extLst xmlns:a="http://schemas.openxmlformats.org/drawingml/2006/main">
               <a:ext uri="{FF2B5EF4-FFF2-40B4-BE49-F238E27FC236}">
-                <a16:creationId xmlns:a16="http://schemas.microsoft.com/office/drawing/2014/main" id="{081D096A-791E-4214-80A0-7E248A141566}"/>
+                <a16:creationId xmlns:a16="http://schemas.microsoft.com/office/drawing/2014/main" id="{D4F4FC2C-9BDF-40AF-8020-A71123BD24DD}"/>
               </a:ext>
             </a:extLst>
           </p:cNvPr>
@@ -6599,7 +6917,7 @@
           <p:cNvPr id="11" name="">
             <a:extLst xmlns:a="http://schemas.openxmlformats.org/drawingml/2006/main">
               <a:ext uri="{FF2B5EF4-FFF2-40B4-BE49-F238E27FC236}">
-                <a16:creationId xmlns:a16="http://schemas.microsoft.com/office/drawing/2014/main" id="{EA85F8E0-20D7-429B-B5BE-588560EC7F87}"/>
+                <a16:creationId xmlns:a16="http://schemas.microsoft.com/office/drawing/2014/main" id="{3B3FCB29-1188-402F-9238-1B0D9BA347CC}"/>
               </a:ext>
             </a:extLst>
           </p:cNvPr>
@@ -6653,7 +6971,7 @@
                 <a:ea typeface="Aptos"/>
                 <a:cs typeface="Aptos"/>
               </a:rPr>
-              <a:t>Pourquoi c'est important: l'entrée physique reste la cible objective; le début du risque devient le repère humain d'anticipation attendue.</a:t>
+              <a:t>Pourquoi c'est important: l'entr�e physique reste la cible objective; le d�but du risque devient le rep�re humain d'anticipation attendue.</a:t>
             </a:r>
           </a:p>
         </p:txBody>
@@ -6661,7 +6979,7 @@
     </p:spTree>
     <p:extLst>
       <p:ext uri="{BB962C8B-B14F-4D97-AF65-F5344CB8AC3E}">
-        <p14:creationId xmlns:p14="http://schemas.microsoft.com/office/powerpoint/2010/main" val="365507458"/>
+        <p14:creationId xmlns:p14="http://schemas.microsoft.com/office/powerpoint/2010/main" val="1782198226"/>
       </p:ext>
     </p:extLst>
   </p:cSld>
@@ -6685,7 +7003,7 @@
           <p:cNvPr id="1" name="">
             <a:extLst xmlns:a="http://schemas.openxmlformats.org/drawingml/2006/main">
               <a:ext uri="{FF2B5EF4-FFF2-40B4-BE49-F238E27FC236}">
-                <a16:creationId xmlns:a16="http://schemas.microsoft.com/office/drawing/2014/main" id="{D5C96843-198F-4328-A59E-71BC578A4F04}"/>
+                <a16:creationId xmlns:a16="http://schemas.microsoft.com/office/drawing/2014/main" id="{C2EF85A2-B365-4E5B-AABB-90159452852A}"/>
               </a:ext>
             </a:extLst>
           </p:cNvPr>
@@ -6720,7 +7038,7 @@
           <p:cNvPr id="2" name="">
             <a:extLst xmlns:a="http://schemas.openxmlformats.org/drawingml/2006/main">
               <a:ext uri="{FF2B5EF4-FFF2-40B4-BE49-F238E27FC236}">
-                <a16:creationId xmlns:a16="http://schemas.microsoft.com/office/drawing/2014/main" id="{1DE6BF2A-9A95-4613-8258-42CEE779B561}"/>
+                <a16:creationId xmlns:a16="http://schemas.microsoft.com/office/drawing/2014/main" id="{30A890FC-2786-4CE7-9706-6F62DD6E190E}"/>
               </a:ext>
             </a:extLst>
           </p:cNvPr>
@@ -6774,7 +7092,7 @@
                 <a:ea typeface="Aptos"/>
                 <a:cs typeface="Aptos"/>
               </a:rPr>
-              <a:t>Artefact à montrer: pipeline_policy_diagram.png</a:t>
+              <a:t>Soutenance s�curit� machine</a:t>
             </a:r>
           </a:p>
         </p:txBody>
@@ -6784,7 +7102,7 @@
           <p:cNvPr id="3" name="">
             <a:extLst xmlns:a="http://schemas.openxmlformats.org/drawingml/2006/main">
               <a:ext uri="{FF2B5EF4-FFF2-40B4-BE49-F238E27FC236}">
-                <a16:creationId xmlns:a16="http://schemas.microsoft.com/office/drawing/2014/main" id="{CFA8FA83-67DA-468F-8EA4-87055E861334}"/>
+                <a16:creationId xmlns:a16="http://schemas.microsoft.com/office/drawing/2014/main" id="{8643B114-CF27-4438-918C-D21A42682256}"/>
               </a:ext>
             </a:extLst>
           </p:cNvPr>
@@ -6848,7 +7166,7 @@
           <p:cNvPr id="4" name="">
             <a:extLst xmlns:a="http://schemas.openxmlformats.org/drawingml/2006/main">
               <a:ext uri="{FF2B5EF4-FFF2-40B4-BE49-F238E27FC236}">
-                <a16:creationId xmlns:a16="http://schemas.microsoft.com/office/drawing/2014/main" id="{35BCE753-9079-4DFE-9698-D907BA265BD4}"/>
+                <a16:creationId xmlns:a16="http://schemas.microsoft.com/office/drawing/2014/main" id="{53E75B8F-364E-4A80-B9B7-032FD08B0417}"/>
               </a:ext>
             </a:extLst>
           </p:cNvPr>
@@ -6883,7 +7201,7 @@
           <p:cNvPr id="5" name="">
             <a:extLst xmlns:a="http://schemas.openxmlformats.org/drawingml/2006/main">
               <a:ext uri="{FF2B5EF4-FFF2-40B4-BE49-F238E27FC236}">
-                <a16:creationId xmlns:a16="http://schemas.microsoft.com/office/drawing/2014/main" id="{837C5118-EF82-4993-AB97-8DFFFD26BD8E}"/>
+                <a16:creationId xmlns:a16="http://schemas.microsoft.com/office/drawing/2014/main" id="{1034B0BC-8AB6-41FF-84EA-E8572ECD215D}"/>
               </a:ext>
             </a:extLst>
           </p:cNvPr>
@@ -6937,7 +7255,7 @@
                 <a:ea typeface="Aptos"/>
                 <a:cs typeface="Aptos"/>
               </a:rPr>
-              <a:t>INGÉNIERIE DES VARIABLES</a:t>
+              <a:t>ING�NIERIE DES VARIABLES</a:t>
             </a:r>
           </a:p>
         </p:txBody>
@@ -6947,7 +7265,7 @@
           <p:cNvPr id="6" name="">
             <a:extLst xmlns:a="http://schemas.openxmlformats.org/drawingml/2006/main">
               <a:ext uri="{FF2B5EF4-FFF2-40B4-BE49-F238E27FC236}">
-                <a16:creationId xmlns:a16="http://schemas.microsoft.com/office/drawing/2014/main" id="{62024187-49F9-4577-81F3-21AC448FB53A}"/>
+                <a16:creationId xmlns:a16="http://schemas.microsoft.com/office/drawing/2014/main" id="{895DC6EC-72E2-40D9-984B-667B295E738B}"/>
               </a:ext>
             </a:extLst>
           </p:cNvPr>
@@ -7001,7 +7319,7 @@
                 <a:ea typeface="Aptos Display"/>
                 <a:cs typeface="Aptos Display"/>
               </a:rPr>
-              <a:t>Le modèle ne voit pas d'abord les pixels bruts; il voit des signaux pose-zone causaux.</a:t>
+              <a:t>Le mod�le ne voit pas d'abord les pixels bruts; il voit des signaux pose-zone causaux.</a:t>
             </a:r>
           </a:p>
         </p:txBody>
@@ -7015,7 +7333,7 @@
           <p:nvPr/>
         </p:nvPicPr>
         <p:blipFill>
-          <a:blip xmlns:r="http://schemas.openxmlformats.org/officeDocument/2006/relationships" xmlns:a="http://schemas.openxmlformats.org/drawingml/2006/main" r:embed="R21887a6c4b0148fc"/>
+          <a:blip xmlns:r="http://schemas.openxmlformats.org/officeDocument/2006/relationships" xmlns:a="http://schemas.openxmlformats.org/drawingml/2006/main" r:embed="R92689b8e93bd40a9"/>
           <a:stretch xmlns:a="http://schemas.openxmlformats.org/drawingml/2006/main"/>
         </p:blipFill>
         <p:spPr>
@@ -7033,7 +7351,7 @@
           <p:cNvPr id="8" name="">
             <a:extLst xmlns:a="http://schemas.openxmlformats.org/drawingml/2006/main">
               <a:ext uri="{FF2B5EF4-FFF2-40B4-BE49-F238E27FC236}">
-                <a16:creationId xmlns:a16="http://schemas.microsoft.com/office/drawing/2014/main" id="{A8B8E2EF-0BE2-4B46-9BE1-EA8ECAA803C8}"/>
+                <a16:creationId xmlns:a16="http://schemas.microsoft.com/office/drawing/2014/main" id="{B85AC55A-2A14-4370-9F8B-1746DFBD29B3}"/>
               </a:ext>
             </a:extLst>
           </p:cNvPr>
@@ -7066,7 +7384,7 @@
           <p:cNvPr id="9" name="">
             <a:extLst xmlns:a="http://schemas.openxmlformats.org/drawingml/2006/main">
               <a:ext uri="{FF2B5EF4-FFF2-40B4-BE49-F238E27FC236}">
-                <a16:creationId xmlns:a16="http://schemas.microsoft.com/office/drawing/2014/main" id="{B454C8C5-7587-4134-9EEF-92B130A87082}"/>
+                <a16:creationId xmlns:a16="http://schemas.microsoft.com/office/drawing/2014/main" id="{2E91C5AC-60E5-455F-82A1-BA8807C06B35}"/>
               </a:ext>
             </a:extLst>
           </p:cNvPr>
@@ -7120,7 +7438,7 @@
                 <a:ea typeface="Aptos"/>
                 <a:cs typeface="Aptos"/>
               </a:rPr>
-              <a:t>Entrée structurée:</a:t>
+              <a:t>Entr�e structur�e:</a:t>
             </a:r>
           </a:p>
           <a:p xmlns:a="http://schemas.openxmlformats.org/drawingml/2006/main">
@@ -7143,7 +7461,7 @@
                 <a:ea typeface="Aptos"/>
                 <a:cs typeface="Aptos"/>
               </a:rPr>
-              <a:t>- poignets, coudes, tête, torse</a:t>
+              <a:t>- poignets, coudes, t�te, torse</a:t>
             </a:r>
           </a:p>
           <a:p xmlns:a="http://schemas.openxmlformats.org/drawingml/2006/main">
@@ -7235,7 +7553,7 @@
                 <a:ea typeface="Aptos"/>
                 <a:cs typeface="Aptos"/>
               </a:rPr>
-              <a:t>- vitesse et accélération</a:t>
+              <a:t>- vitesse et acc�l�ration</a:t>
             </a:r>
           </a:p>
         </p:txBody>
@@ -7245,7 +7563,7 @@
           <p:cNvPr id="10" name="">
             <a:extLst xmlns:a="http://schemas.openxmlformats.org/drawingml/2006/main">
               <a:ext uri="{FF2B5EF4-FFF2-40B4-BE49-F238E27FC236}">
-                <a16:creationId xmlns:a16="http://schemas.microsoft.com/office/drawing/2014/main" id="{D0590636-9F6C-4721-A587-3E19CEC101A0}"/>
+                <a16:creationId xmlns:a16="http://schemas.microsoft.com/office/drawing/2014/main" id="{5713021C-CEE0-4CD7-96F9-AB2B94FCFFD6}"/>
               </a:ext>
             </a:extLst>
           </p:cNvPr>
@@ -7299,7 +7617,7 @@
                 <a:ea typeface="Aptos"/>
                 <a:cs typeface="Aptos"/>
               </a:rPr>
-              <a:t>Cela force le modèle à apprendre le mouvement vers la zone dangereuse, pas l'identité de l'acteur ni la texture du fond.</a:t>
+              <a:t>Cela force le mod�le � apprendre le mouvement vers la zone dangereuse, pas l'identit� de l'acteur ni la texture du fond.</a:t>
             </a:r>
           </a:p>
         </p:txBody>
@@ -7307,7 +7625,7 @@
     </p:spTree>
     <p:extLst>
       <p:ext uri="{BB962C8B-B14F-4D97-AF65-F5344CB8AC3E}">
-        <p14:creationId xmlns:p14="http://schemas.microsoft.com/office/powerpoint/2010/main" val="44566467"/>
+        <p14:creationId xmlns:p14="http://schemas.microsoft.com/office/powerpoint/2010/main" val="1871356634"/>
       </p:ext>
     </p:extLst>
   </p:cSld>
@@ -7331,7 +7649,7 @@
           <p:cNvPr id="1" name="">
             <a:extLst xmlns:a="http://schemas.openxmlformats.org/drawingml/2006/main">
               <a:ext uri="{FF2B5EF4-FFF2-40B4-BE49-F238E27FC236}">
-                <a16:creationId xmlns:a16="http://schemas.microsoft.com/office/drawing/2014/main" id="{7D5A451A-278C-43C7-8DB8-101A2325F8BA}"/>
+                <a16:creationId xmlns:a16="http://schemas.microsoft.com/office/drawing/2014/main" id="{7768C41D-5481-4242-BEBE-F5AC5EA68CC6}"/>
               </a:ext>
             </a:extLst>
           </p:cNvPr>
@@ -7366,7 +7684,7 @@
           <p:cNvPr id="2" name="">
             <a:extLst xmlns:a="http://schemas.openxmlformats.org/drawingml/2006/main">
               <a:ext uri="{FF2B5EF4-FFF2-40B4-BE49-F238E27FC236}">
-                <a16:creationId xmlns:a16="http://schemas.microsoft.com/office/drawing/2014/main" id="{7232D2B3-DC62-4808-9DD2-EDF36F75994A}"/>
+                <a16:creationId xmlns:a16="http://schemas.microsoft.com/office/drawing/2014/main" id="{67E47B7F-4E25-49B7-8A00-A41DE68AAC8A}"/>
               </a:ext>
             </a:extLst>
           </p:cNvPr>
@@ -7420,7 +7738,7 @@
                 <a:ea typeface="Aptos"/>
                 <a:cs typeface="Aptos"/>
               </a:rPr>
-              <a:t>Expliquer d'abord le TCN, puis le GRU comme spécialiste de l'entrée exacte</a:t>
+              <a:t>Soutenance sécurité machine</a:t>
             </a:r>
           </a:p>
         </p:txBody>
@@ -7430,7 +7748,7 @@
           <p:cNvPr id="3" name="">
             <a:extLst xmlns:a="http://schemas.openxmlformats.org/drawingml/2006/main">
               <a:ext uri="{FF2B5EF4-FFF2-40B4-BE49-F238E27FC236}">
-                <a16:creationId xmlns:a16="http://schemas.microsoft.com/office/drawing/2014/main" id="{EBD0FDE8-D3D8-462E-929A-79508AC06409}"/>
+                <a16:creationId xmlns:a16="http://schemas.microsoft.com/office/drawing/2014/main" id="{90DDB0EF-22AC-4F39-827D-9E8BA06E48D2}"/>
               </a:ext>
             </a:extLst>
           </p:cNvPr>
@@ -7494,7 +7812,7 @@
           <p:cNvPr id="4" name="">
             <a:extLst xmlns:a="http://schemas.openxmlformats.org/drawingml/2006/main">
               <a:ext uri="{FF2B5EF4-FFF2-40B4-BE49-F238E27FC236}">
-                <a16:creationId xmlns:a16="http://schemas.microsoft.com/office/drawing/2014/main" id="{B1A5B721-86AA-420F-B008-D2B839D34427}"/>
+                <a16:creationId xmlns:a16="http://schemas.microsoft.com/office/drawing/2014/main" id="{77015560-2BB5-4DE7-AA8E-3E04E9B42E17}"/>
               </a:ext>
             </a:extLst>
           </p:cNvPr>
@@ -7529,7 +7847,7 @@
           <p:cNvPr id="5" name="">
             <a:extLst xmlns:a="http://schemas.openxmlformats.org/drawingml/2006/main">
               <a:ext uri="{FF2B5EF4-FFF2-40B4-BE49-F238E27FC236}">
-                <a16:creationId xmlns:a16="http://schemas.microsoft.com/office/drawing/2014/main" id="{D027B372-DA8B-4D40-A1C2-E7A338963C1B}"/>
+                <a16:creationId xmlns:a16="http://schemas.microsoft.com/office/drawing/2014/main" id="{3B3FB48F-7323-4192-A848-4A408A0B02F7}"/>
               </a:ext>
             </a:extLst>
           </p:cNvPr>
@@ -7593,7 +7911,7 @@
           <p:cNvPr id="6" name="">
             <a:extLst xmlns:a="http://schemas.openxmlformats.org/drawingml/2006/main">
               <a:ext uri="{FF2B5EF4-FFF2-40B4-BE49-F238E27FC236}">
-                <a16:creationId xmlns:a16="http://schemas.microsoft.com/office/drawing/2014/main" id="{393DE46D-7B5A-4A6A-8259-B466E3B81E71}"/>
+                <a16:creationId xmlns:a16="http://schemas.microsoft.com/office/drawing/2014/main" id="{D8D7317F-65F7-403B-A382-9A8E67834B76}"/>
               </a:ext>
             </a:extLst>
           </p:cNvPr>
@@ -7605,7 +7923,7 @@
         <p:spPr>
           <a:xfrm xmlns:a="http://schemas.openxmlformats.org/drawingml/2006/main">
             <a:off x="609600" y="666750"/>
-            <a:ext cx="8572500" cy="914400"/>
+            <a:ext cx="9334500" cy="914400"/>
           </a:xfrm>
           <a:prstGeom xmlns:a="http://schemas.openxmlformats.org/drawingml/2006/main" prst="rect">
             <a:avLst/>
@@ -7647,7 +7965,7 @@
                 <a:ea typeface="Aptos Display"/>
                 <a:cs typeface="Aptos Display"/>
               </a:rPr>
-              <a:t>Le TCN lit le danger général; le GRU lit l'entrée court horizon.</a:t>
+              <a:t>Le pipeline final confie l'alerte au TCN et l'imminence d'arrêt au GRU.</a:t>
             </a:r>
           </a:p>
         </p:txBody>
@@ -7657,7 +7975,7 @@
           <p:cNvPr id="7" name="">
             <a:extLst xmlns:a="http://schemas.openxmlformats.org/drawingml/2006/main">
               <a:ext uri="{FF2B5EF4-FFF2-40B4-BE49-F238E27FC236}">
-                <a16:creationId xmlns:a16="http://schemas.microsoft.com/office/drawing/2014/main" id="{E79238DB-479A-4C72-8318-4D250295D955}"/>
+                <a16:creationId xmlns:a16="http://schemas.microsoft.com/office/drawing/2014/main" id="{B825B4B9-F986-4A05-83CC-7DE0436290E1}"/>
               </a:ext>
             </a:extLst>
           </p:cNvPr>
@@ -7690,7 +8008,7 @@
           <p:cNvPr id="8" name="">
             <a:extLst xmlns:a="http://schemas.openxmlformats.org/drawingml/2006/main">
               <a:ext uri="{FF2B5EF4-FFF2-40B4-BE49-F238E27FC236}">
-                <a16:creationId xmlns:a16="http://schemas.microsoft.com/office/drawing/2014/main" id="{81636C66-2CA8-45C8-A23C-6F86FEDAA85F}"/>
+                <a16:creationId xmlns:a16="http://schemas.microsoft.com/office/drawing/2014/main" id="{0573B962-4687-4470-AAB2-0882DA2B20C0}"/>
               </a:ext>
             </a:extLst>
           </p:cNvPr>
@@ -7744,7 +8062,7 @@
                 <a:ea typeface="Aptos"/>
                 <a:cs typeface="Aptos"/>
               </a:rPr>
-              <a:t>TCN sequence-only</a:t>
+              <a:t>TCN warning / risk_present_now</a:t>
             </a:r>
           </a:p>
         </p:txBody>
@@ -7754,7 +8072,7 @@
           <p:cNvPr id="9" name="">
             <a:extLst xmlns:a="http://schemas.openxmlformats.org/drawingml/2006/main">
               <a:ext uri="{FF2B5EF4-FFF2-40B4-BE49-F238E27FC236}">
-                <a16:creationId xmlns:a16="http://schemas.microsoft.com/office/drawing/2014/main" id="{8341EA9B-EA54-49FD-B862-97CB80D6F96F}"/>
+                <a16:creationId xmlns:a16="http://schemas.microsoft.com/office/drawing/2014/main" id="{B77C4863-E6C8-40E1-85D3-67327AC4DBD7}"/>
               </a:ext>
             </a:extLst>
           </p:cNvPr>
@@ -7923,7 +8241,30 @@
                 <a:ea typeface="Aptos Mono"/>
                 <a:cs typeface="Aptos Mono"/>
               </a:rPr>
-              <a:t>Sorties: danger dans 0,5/1,0/1,5/2,0 s</a:t>
+              <a:t>MLP 192 -&gt; 96 -&gt; 1</a:t>
+            </a:r>
+          </a:p>
+          <a:p xmlns:a="http://schemas.openxmlformats.org/drawingml/2006/main">
+            <a:pPr algn="l">
+              <a:defRPr sz="1425" b="0">
+                <a:solidFill>
+                  <a:srgbClr val="17202A"/>
+                </a:solidFill>
+                <a:latin typeface="Aptos Mono"/>
+                <a:ea typeface="Aptos Mono"/>
+                <a:cs typeface="Aptos Mono"/>
+              </a:defRPr>
+            </a:pPr>
+            <a:r>
+              <a:rPr sz="1425" b="0">
+                <a:solidFill>
+                  <a:srgbClr val="17202A"/>
+                </a:solidFill>
+                <a:latin typeface="Aptos Mono"/>
+                <a:ea typeface="Aptos Mono"/>
+                <a:cs typeface="Aptos Mono"/>
+              </a:rPr>
+              <a:t>Sortie unique: risk_present_now</a:t>
             </a:r>
           </a:p>
         </p:txBody>
@@ -7933,7 +8274,7 @@
           <p:cNvPr id="10" name="">
             <a:extLst xmlns:a="http://schemas.openxmlformats.org/drawingml/2006/main">
               <a:ext uri="{FF2B5EF4-FFF2-40B4-BE49-F238E27FC236}">
-                <a16:creationId xmlns:a16="http://schemas.microsoft.com/office/drawing/2014/main" id="{24FBEB18-A2D7-437D-936C-42ECB4F33611}"/>
+                <a16:creationId xmlns:a16="http://schemas.microsoft.com/office/drawing/2014/main" id="{55D723D5-CD1F-4C02-AAC0-707E9BE46F74}"/>
               </a:ext>
             </a:extLst>
           </p:cNvPr>
@@ -7966,7 +8307,7 @@
           <p:cNvPr id="11" name="">
             <a:extLst xmlns:a="http://schemas.openxmlformats.org/drawingml/2006/main">
               <a:ext uri="{FF2B5EF4-FFF2-40B4-BE49-F238E27FC236}">
-                <a16:creationId xmlns:a16="http://schemas.microsoft.com/office/drawing/2014/main" id="{6E624B23-6FE4-497C-8E3D-88EEA0AE3666}"/>
+                <a16:creationId xmlns:a16="http://schemas.microsoft.com/office/drawing/2014/main" id="{6CEA75C9-2C41-4A6A-A20B-61FDDF4AFD62}"/>
               </a:ext>
             </a:extLst>
           </p:cNvPr>
@@ -8020,7 +8361,7 @@
                 <a:ea typeface="Aptos"/>
                 <a:cs typeface="Aptos"/>
               </a:rPr>
-              <a:t>GRU entrée exacte</a:t>
+              <a:t>GRU exact-entry / score_by_02</a:t>
             </a:r>
           </a:p>
         </p:txBody>
@@ -8030,7 +8371,7 @@
           <p:cNvPr id="12" name="">
             <a:extLst xmlns:a="http://schemas.openxmlformats.org/drawingml/2006/main">
               <a:ext uri="{FF2B5EF4-FFF2-40B4-BE49-F238E27FC236}">
-                <a16:creationId xmlns:a16="http://schemas.microsoft.com/office/drawing/2014/main" id="{CF61493D-C44B-4EED-89CE-630852703009}"/>
+                <a16:creationId xmlns:a16="http://schemas.microsoft.com/office/drawing/2014/main" id="{39425454-CECF-4661-9B68-1C29162A4E63}"/>
               </a:ext>
             </a:extLst>
           </p:cNvPr>
@@ -8176,7 +8517,7 @@
                 <a:ea typeface="Aptos Mono"/>
                 <a:cs typeface="Aptos Mono"/>
               </a:rPr>
-              <a:t>Têtes survival: &lt;=0,2/0,3/0,5/1,0 s</a:t>
+              <a:t>Score: score_by_02</a:t>
             </a:r>
           </a:p>
           <a:p xmlns:a="http://schemas.openxmlformats.org/drawingml/2006/main">
@@ -8199,7 +8540,7 @@
                 <a:ea typeface="Aptos Mono"/>
                 <a:cs typeface="Aptos Mono"/>
               </a:rPr>
-              <a:t>Variante multi-bin temps-vers-entrée</a:t>
+              <a:t>Lecture stop à 0,2 s et 0,3 s</a:t>
             </a:r>
           </a:p>
         </p:txBody>
@@ -8209,7 +8550,7 @@
           <p:cNvPr id="13" name="">
             <a:extLst xmlns:a="http://schemas.openxmlformats.org/drawingml/2006/main">
               <a:ext uri="{FF2B5EF4-FFF2-40B4-BE49-F238E27FC236}">
-                <a16:creationId xmlns:a16="http://schemas.microsoft.com/office/drawing/2014/main" id="{45367D82-50BD-4225-B139-1CC8769CF5AE}"/>
+                <a16:creationId xmlns:a16="http://schemas.microsoft.com/office/drawing/2014/main" id="{9A846519-A939-4FD2-9E5E-FFC0D2746FFB}"/>
               </a:ext>
             </a:extLst>
           </p:cNvPr>
@@ -8263,7 +8604,7 @@
                 <a:ea typeface="Aptos"/>
                 <a:cs typeface="Aptos"/>
               </a:rPr>
-              <a:t>Message au jury: nous séparons l'alerte précoce de l'entrée physique exacte au lieu de forcer un seul modèle à tout faire.</a:t>
+              <a:t>Les deux modèles lisent les mêmes features causales et interviennent à deux niveaux de la décision de sécurité.</a:t>
             </a:r>
           </a:p>
         </p:txBody>
@@ -8271,7 +8612,7 @@
     </p:spTree>
     <p:extLst>
       <p:ext uri="{BB962C8B-B14F-4D97-AF65-F5344CB8AC3E}">
-        <p14:creationId xmlns:p14="http://schemas.microsoft.com/office/powerpoint/2010/main" val="1545177494"/>
+        <p14:creationId xmlns:p14="http://schemas.microsoft.com/office/powerpoint/2010/main" val="658429252"/>
       </p:ext>
     </p:extLst>
   </p:cSld>
@@ -8295,7 +8636,7 @@
           <p:cNvPr id="1" name="">
             <a:extLst xmlns:a="http://schemas.openxmlformats.org/drawingml/2006/main">
               <a:ext uri="{FF2B5EF4-FFF2-40B4-BE49-F238E27FC236}">
-                <a16:creationId xmlns:a16="http://schemas.microsoft.com/office/drawing/2014/main" id="{5537C06D-D5E9-4879-9459-A43BA473B8FA}"/>
+                <a16:creationId xmlns:a16="http://schemas.microsoft.com/office/drawing/2014/main" id="{D15642A6-42AB-4363-B57D-E8531B121FA8}"/>
               </a:ext>
             </a:extLst>
           </p:cNvPr>
@@ -8330,7 +8671,7 @@
           <p:cNvPr id="2" name="">
             <a:extLst xmlns:a="http://schemas.openxmlformats.org/drawingml/2006/main">
               <a:ext uri="{FF2B5EF4-FFF2-40B4-BE49-F238E27FC236}">
-                <a16:creationId xmlns:a16="http://schemas.microsoft.com/office/drawing/2014/main" id="{413F7555-E521-4D6F-8BE2-587F7B48A8C5}"/>
+                <a16:creationId xmlns:a16="http://schemas.microsoft.com/office/drawing/2014/main" id="{388EF6C7-335D-4E99-8D3A-E89469227D84}"/>
               </a:ext>
             </a:extLst>
           </p:cNvPr>
@@ -8384,7 +8725,7 @@
                 <a:ea typeface="Aptos"/>
                 <a:cs typeface="Aptos"/>
               </a:rPr>
-              <a:t>Petit dataset: splits répétés par vidéo parente</a:t>
+              <a:t>Petit dataset: splits r�p�t�s par vid�o parente</a:t>
             </a:r>
           </a:p>
         </p:txBody>
@@ -8394,7 +8735,7 @@
           <p:cNvPr id="3" name="">
             <a:extLst xmlns:a="http://schemas.openxmlformats.org/drawingml/2006/main">
               <a:ext uri="{FF2B5EF4-FFF2-40B4-BE49-F238E27FC236}">
-                <a16:creationId xmlns:a16="http://schemas.microsoft.com/office/drawing/2014/main" id="{5E24C742-570C-4966-878E-CB430BCAA4BE}"/>
+                <a16:creationId xmlns:a16="http://schemas.microsoft.com/office/drawing/2014/main" id="{55F2B439-4A69-4176-BBEA-D0113BE23066}"/>
               </a:ext>
             </a:extLst>
           </p:cNvPr>
@@ -8458,7 +8799,7 @@
           <p:cNvPr id="4" name="">
             <a:extLst xmlns:a="http://schemas.openxmlformats.org/drawingml/2006/main">
               <a:ext uri="{FF2B5EF4-FFF2-40B4-BE49-F238E27FC236}">
-                <a16:creationId xmlns:a16="http://schemas.microsoft.com/office/drawing/2014/main" id="{B737D717-3763-47F9-93CA-29F636DD3516}"/>
+                <a16:creationId xmlns:a16="http://schemas.microsoft.com/office/drawing/2014/main" id="{44268407-EBC7-4EA5-8FED-4122B32717A7}"/>
               </a:ext>
             </a:extLst>
           </p:cNvPr>
@@ -8493,7 +8834,7 @@
           <p:cNvPr id="5" name="">
             <a:extLst xmlns:a="http://schemas.openxmlformats.org/drawingml/2006/main">
               <a:ext uri="{FF2B5EF4-FFF2-40B4-BE49-F238E27FC236}">
-                <a16:creationId xmlns:a16="http://schemas.microsoft.com/office/drawing/2014/main" id="{F1E01BEE-A499-410B-A549-767F8D432F7A}"/>
+                <a16:creationId xmlns:a16="http://schemas.microsoft.com/office/drawing/2014/main" id="{9D60502C-5E55-4B07-99D3-72DC2214A1E2}"/>
               </a:ext>
             </a:extLst>
           </p:cNvPr>
@@ -8547,7 +8888,7 @@
                 <a:ea typeface="Aptos"/>
                 <a:cs typeface="Aptos"/>
               </a:rPr>
-              <a:t>ROBUSTESSE DE L'ÉVALUATION</a:t>
+              <a:t>ROBUSTESSE DE L'�VALUATION</a:t>
             </a:r>
           </a:p>
         </p:txBody>
@@ -8557,7 +8898,7 @@
           <p:cNvPr id="6" name="">
             <a:extLst xmlns:a="http://schemas.openxmlformats.org/drawingml/2006/main">
               <a:ext uri="{FF2B5EF4-FFF2-40B4-BE49-F238E27FC236}">
-                <a16:creationId xmlns:a16="http://schemas.microsoft.com/office/drawing/2014/main" id="{730128B6-8D55-4AEE-8566-F9E0069E4D09}"/>
+                <a16:creationId xmlns:a16="http://schemas.microsoft.com/office/drawing/2014/main" id="{84F8679B-5310-48ED-890E-D4176632B7EF}"/>
               </a:ext>
             </a:extLst>
           </p:cNvPr>
@@ -8611,7 +8952,7 @@
                 <a:ea typeface="Aptos Display"/>
                 <a:cs typeface="Aptos Display"/>
               </a:rPr>
-              <a:t>Les splits répétés évitent de raconter un split chanceux.</a:t>
+              <a:t>Les splits r�p�t�s �vitent de raconter un split chanceux.</a:t>
             </a:r>
           </a:p>
         </p:txBody>
@@ -8621,7 +8962,7 @@
           <p:cNvPr id="7" name="">
             <a:extLst xmlns:a="http://schemas.openxmlformats.org/drawingml/2006/main">
               <a:ext uri="{FF2B5EF4-FFF2-40B4-BE49-F238E27FC236}">
-                <a16:creationId xmlns:a16="http://schemas.microsoft.com/office/drawing/2014/main" id="{EADFD049-7C11-427E-B7A9-6F2481D4D5CD}"/>
+                <a16:creationId xmlns:a16="http://schemas.microsoft.com/office/drawing/2014/main" id="{E0574B16-8512-4873-879E-AB3A0FADF61B}"/>
               </a:ext>
             </a:extLst>
           </p:cNvPr>
@@ -8654,7 +8995,7 @@
           <p:cNvPr id="8" name="">
             <a:extLst xmlns:a="http://schemas.openxmlformats.org/drawingml/2006/main">
               <a:ext uri="{FF2B5EF4-FFF2-40B4-BE49-F238E27FC236}">
-                <a16:creationId xmlns:a16="http://schemas.microsoft.com/office/drawing/2014/main" id="{613B0D03-1017-4CE7-95A0-C45023B9C1AC}"/>
+                <a16:creationId xmlns:a16="http://schemas.microsoft.com/office/drawing/2014/main" id="{E929C530-ABA3-464D-B738-7E3EDAD3C79D}"/>
               </a:ext>
             </a:extLst>
           </p:cNvPr>
@@ -8718,7 +9059,7 @@
           <p:cNvPr id="9" name="">
             <a:extLst xmlns:a="http://schemas.openxmlformats.org/drawingml/2006/main">
               <a:ext uri="{FF2B5EF4-FFF2-40B4-BE49-F238E27FC236}">
-                <a16:creationId xmlns:a16="http://schemas.microsoft.com/office/drawing/2014/main" id="{048590E8-9F67-4FEC-AC3F-8B7F55F80AEA}"/>
+                <a16:creationId xmlns:a16="http://schemas.microsoft.com/office/drawing/2014/main" id="{2C212965-1E95-4B0F-B237-81DF9C2B848E}"/>
               </a:ext>
             </a:extLst>
           </p:cNvPr>
@@ -8753,7 +9094,7 @@
           <p:cNvPr id="10" name="">
             <a:extLst xmlns:a="http://schemas.openxmlformats.org/drawingml/2006/main">
               <a:ext uri="{FF2B5EF4-FFF2-40B4-BE49-F238E27FC236}">
-                <a16:creationId xmlns:a16="http://schemas.microsoft.com/office/drawing/2014/main" id="{82ED9183-1EFC-437F-A894-A407B793464F}"/>
+                <a16:creationId xmlns:a16="http://schemas.microsoft.com/office/drawing/2014/main" id="{78A21DC0-D3CD-4B04-9B6B-AB8027E8ADF7}"/>
               </a:ext>
             </a:extLst>
           </p:cNvPr>
@@ -8788,7 +9129,7 @@
           <p:cNvPr id="11" name="">
             <a:extLst xmlns:a="http://schemas.openxmlformats.org/drawingml/2006/main">
               <a:ext uri="{FF2B5EF4-FFF2-40B4-BE49-F238E27FC236}">
-                <a16:creationId xmlns:a16="http://schemas.microsoft.com/office/drawing/2014/main" id="{9F3DB6B7-5DAE-4A02-BF28-1DBDACE0FBE2}"/>
+                <a16:creationId xmlns:a16="http://schemas.microsoft.com/office/drawing/2014/main" id="{6E31157B-DEE9-4B3C-AA89-FD3BFB2E852B}"/>
               </a:ext>
             </a:extLst>
           </p:cNvPr>
@@ -8823,7 +9164,7 @@
           <p:cNvPr id="12" name="">
             <a:extLst xmlns:a="http://schemas.openxmlformats.org/drawingml/2006/main">
               <a:ext uri="{FF2B5EF4-FFF2-40B4-BE49-F238E27FC236}">
-                <a16:creationId xmlns:a16="http://schemas.microsoft.com/office/drawing/2014/main" id="{B7698340-3FB6-4999-ACC6-D22F0AC7EBD2}"/>
+                <a16:creationId xmlns:a16="http://schemas.microsoft.com/office/drawing/2014/main" id="{5631FE24-1A7E-45A5-A768-9D26B20C50B6}"/>
               </a:ext>
             </a:extLst>
           </p:cNvPr>
@@ -8887,7 +9228,7 @@
           <p:cNvPr id="13" name="">
             <a:extLst xmlns:a="http://schemas.openxmlformats.org/drawingml/2006/main">
               <a:ext uri="{FF2B5EF4-FFF2-40B4-BE49-F238E27FC236}">
-                <a16:creationId xmlns:a16="http://schemas.microsoft.com/office/drawing/2014/main" id="{D79158CE-AA5F-4977-9D13-856D04CF932A}"/>
+                <a16:creationId xmlns:a16="http://schemas.microsoft.com/office/drawing/2014/main" id="{B4881ECC-C930-4B20-BC02-EFA3AC0B08E3}"/>
               </a:ext>
             </a:extLst>
           </p:cNvPr>
@@ -8951,7 +9292,7 @@
           <p:cNvPr id="14" name="">
             <a:extLst xmlns:a="http://schemas.openxmlformats.org/drawingml/2006/main">
               <a:ext uri="{FF2B5EF4-FFF2-40B4-BE49-F238E27FC236}">
-                <a16:creationId xmlns:a16="http://schemas.microsoft.com/office/drawing/2014/main" id="{11BC5AF9-BA4E-4A19-9444-6F0C2BE5320F}"/>
+                <a16:creationId xmlns:a16="http://schemas.microsoft.com/office/drawing/2014/main" id="{45077409-B8D3-42F8-AE64-954876BE93E4}"/>
               </a:ext>
             </a:extLst>
           </p:cNvPr>
@@ -9015,7 +9356,7 @@
           <p:cNvPr id="15" name="">
             <a:extLst xmlns:a="http://schemas.openxmlformats.org/drawingml/2006/main">
               <a:ext uri="{FF2B5EF4-FFF2-40B4-BE49-F238E27FC236}">
-                <a16:creationId xmlns:a16="http://schemas.microsoft.com/office/drawing/2014/main" id="{03F7872C-140E-4E18-8FA1-5760D297F5E1}"/>
+                <a16:creationId xmlns:a16="http://schemas.microsoft.com/office/drawing/2014/main" id="{7CAB60B2-802E-4DD2-9E61-E2192FB031D2}"/>
               </a:ext>
             </a:extLst>
           </p:cNvPr>
@@ -9048,7 +9389,7 @@
           <p:cNvPr id="16" name="">
             <a:extLst xmlns:a="http://schemas.openxmlformats.org/drawingml/2006/main">
               <a:ext uri="{FF2B5EF4-FFF2-40B4-BE49-F238E27FC236}">
-                <a16:creationId xmlns:a16="http://schemas.microsoft.com/office/drawing/2014/main" id="{F5CBE982-1BE5-4CEC-9A61-091017307DAD}"/>
+                <a16:creationId xmlns:a16="http://schemas.microsoft.com/office/drawing/2014/main" id="{6DC315E7-164E-4081-A23F-90AFF39181AA}"/>
               </a:ext>
             </a:extLst>
           </p:cNvPr>
@@ -9112,7 +9453,7 @@
           <p:cNvPr id="17" name="">
             <a:extLst xmlns:a="http://schemas.openxmlformats.org/drawingml/2006/main">
               <a:ext uri="{FF2B5EF4-FFF2-40B4-BE49-F238E27FC236}">
-                <a16:creationId xmlns:a16="http://schemas.microsoft.com/office/drawing/2014/main" id="{393F1175-D58A-430D-8FD1-30F02410E08C}"/>
+                <a16:creationId xmlns:a16="http://schemas.microsoft.com/office/drawing/2014/main" id="{D3C59BBA-6B67-4076-8589-658F9616EAA0}"/>
               </a:ext>
             </a:extLst>
           </p:cNvPr>
@@ -9147,7 +9488,7 @@
           <p:cNvPr id="18" name="">
             <a:extLst xmlns:a="http://schemas.openxmlformats.org/drawingml/2006/main">
               <a:ext uri="{FF2B5EF4-FFF2-40B4-BE49-F238E27FC236}">
-                <a16:creationId xmlns:a16="http://schemas.microsoft.com/office/drawing/2014/main" id="{433F6F01-4165-454C-9B56-8CDD16D5BBB3}"/>
+                <a16:creationId xmlns:a16="http://schemas.microsoft.com/office/drawing/2014/main" id="{AF03AE23-31B6-4367-A72D-7677EB9D33A1}"/>
               </a:ext>
             </a:extLst>
           </p:cNvPr>
@@ -9182,7 +9523,7 @@
           <p:cNvPr id="19" name="">
             <a:extLst xmlns:a="http://schemas.openxmlformats.org/drawingml/2006/main">
               <a:ext uri="{FF2B5EF4-FFF2-40B4-BE49-F238E27FC236}">
-                <a16:creationId xmlns:a16="http://schemas.microsoft.com/office/drawing/2014/main" id="{F9FC0B52-47BD-474E-A9B3-E3FFFF12A76E}"/>
+                <a16:creationId xmlns:a16="http://schemas.microsoft.com/office/drawing/2014/main" id="{D9A47E9F-85F6-4220-82BA-8130B812FD3A}"/>
               </a:ext>
             </a:extLst>
           </p:cNvPr>
@@ -9217,7 +9558,7 @@
           <p:cNvPr id="20" name="">
             <a:extLst xmlns:a="http://schemas.openxmlformats.org/drawingml/2006/main">
               <a:ext uri="{FF2B5EF4-FFF2-40B4-BE49-F238E27FC236}">
-                <a16:creationId xmlns:a16="http://schemas.microsoft.com/office/drawing/2014/main" id="{6523C883-C064-47F5-B6BC-084AD93DF669}"/>
+                <a16:creationId xmlns:a16="http://schemas.microsoft.com/office/drawing/2014/main" id="{E22F908F-2556-424D-B69C-9E61E3FAC08F}"/>
               </a:ext>
             </a:extLst>
           </p:cNvPr>
@@ -9281,7 +9622,7 @@
           <p:cNvPr id="21" name="">
             <a:extLst xmlns:a="http://schemas.openxmlformats.org/drawingml/2006/main">
               <a:ext uri="{FF2B5EF4-FFF2-40B4-BE49-F238E27FC236}">
-                <a16:creationId xmlns:a16="http://schemas.microsoft.com/office/drawing/2014/main" id="{4F4D5533-F649-4364-9058-FCE043421E82}"/>
+                <a16:creationId xmlns:a16="http://schemas.microsoft.com/office/drawing/2014/main" id="{E726C698-D441-422E-85D5-BE8FABAB61C8}"/>
               </a:ext>
             </a:extLst>
           </p:cNvPr>
@@ -9345,7 +9686,7 @@
           <p:cNvPr id="22" name="">
             <a:extLst xmlns:a="http://schemas.openxmlformats.org/drawingml/2006/main">
               <a:ext uri="{FF2B5EF4-FFF2-40B4-BE49-F238E27FC236}">
-                <a16:creationId xmlns:a16="http://schemas.microsoft.com/office/drawing/2014/main" id="{DE2F7516-D5C5-4054-9680-BDCB4920C781}"/>
+                <a16:creationId xmlns:a16="http://schemas.microsoft.com/office/drawing/2014/main" id="{CBCC45BD-47B8-4DCD-8066-3D1920D03920}"/>
               </a:ext>
             </a:extLst>
           </p:cNvPr>
@@ -9409,7 +9750,7 @@
           <p:cNvPr id="23" name="">
             <a:extLst xmlns:a="http://schemas.openxmlformats.org/drawingml/2006/main">
               <a:ext uri="{FF2B5EF4-FFF2-40B4-BE49-F238E27FC236}">
-                <a16:creationId xmlns:a16="http://schemas.microsoft.com/office/drawing/2014/main" id="{93B90723-9CAF-4183-8D79-7803D6792323}"/>
+                <a16:creationId xmlns:a16="http://schemas.microsoft.com/office/drawing/2014/main" id="{A1D94A86-7F24-408C-80BC-3BAB316F25EA}"/>
               </a:ext>
             </a:extLst>
           </p:cNvPr>
@@ -9442,7 +9783,7 @@
           <p:cNvPr id="24" name="">
             <a:extLst xmlns:a="http://schemas.openxmlformats.org/drawingml/2006/main">
               <a:ext uri="{FF2B5EF4-FFF2-40B4-BE49-F238E27FC236}">
-                <a16:creationId xmlns:a16="http://schemas.microsoft.com/office/drawing/2014/main" id="{9C3DCD18-E95F-4D70-AC19-48DA33CE7E04}"/>
+                <a16:creationId xmlns:a16="http://schemas.microsoft.com/office/drawing/2014/main" id="{69B7645E-EAF3-44B5-8705-DAF56219C59C}"/>
               </a:ext>
             </a:extLst>
           </p:cNvPr>
@@ -9506,7 +9847,7 @@
           <p:cNvPr id="25" name="">
             <a:extLst xmlns:a="http://schemas.openxmlformats.org/drawingml/2006/main">
               <a:ext uri="{FF2B5EF4-FFF2-40B4-BE49-F238E27FC236}">
-                <a16:creationId xmlns:a16="http://schemas.microsoft.com/office/drawing/2014/main" id="{232D3B79-C8FB-48A9-A561-795BDA370671}"/>
+                <a16:creationId xmlns:a16="http://schemas.microsoft.com/office/drawing/2014/main" id="{D0DE84D1-DB65-48C2-AB34-17198B073B82}"/>
               </a:ext>
             </a:extLst>
           </p:cNvPr>
@@ -9541,7 +9882,7 @@
           <p:cNvPr id="26" name="">
             <a:extLst xmlns:a="http://schemas.openxmlformats.org/drawingml/2006/main">
               <a:ext uri="{FF2B5EF4-FFF2-40B4-BE49-F238E27FC236}">
-                <a16:creationId xmlns:a16="http://schemas.microsoft.com/office/drawing/2014/main" id="{6F3ED843-8731-46E6-B303-398BEC1F51FD}"/>
+                <a16:creationId xmlns:a16="http://schemas.microsoft.com/office/drawing/2014/main" id="{74A6F4AC-7A01-4F14-9EEF-C76B8C0AB8F9}"/>
               </a:ext>
             </a:extLst>
           </p:cNvPr>
@@ -9576,7 +9917,7 @@
           <p:cNvPr id="27" name="">
             <a:extLst xmlns:a="http://schemas.openxmlformats.org/drawingml/2006/main">
               <a:ext uri="{FF2B5EF4-FFF2-40B4-BE49-F238E27FC236}">
-                <a16:creationId xmlns:a16="http://schemas.microsoft.com/office/drawing/2014/main" id="{A8BE8B5D-FF4F-44BA-A9EC-FD9D0774C009}"/>
+                <a16:creationId xmlns:a16="http://schemas.microsoft.com/office/drawing/2014/main" id="{A3F03356-3CAE-4F55-8DAB-E173487FA697}"/>
               </a:ext>
             </a:extLst>
           </p:cNvPr>
@@ -9611,7 +9952,7 @@
           <p:cNvPr id="28" name="">
             <a:extLst xmlns:a="http://schemas.openxmlformats.org/drawingml/2006/main">
               <a:ext uri="{FF2B5EF4-FFF2-40B4-BE49-F238E27FC236}">
-                <a16:creationId xmlns:a16="http://schemas.microsoft.com/office/drawing/2014/main" id="{0F7BB84E-1811-4B0D-9F9A-5370EAC7690F}"/>
+                <a16:creationId xmlns:a16="http://schemas.microsoft.com/office/drawing/2014/main" id="{AC9FCAEE-E372-4DF9-94D3-E3D1BBC46D08}"/>
               </a:ext>
             </a:extLst>
           </p:cNvPr>
@@ -9675,7 +10016,7 @@
           <p:cNvPr id="29" name="">
             <a:extLst xmlns:a="http://schemas.openxmlformats.org/drawingml/2006/main">
               <a:ext uri="{FF2B5EF4-FFF2-40B4-BE49-F238E27FC236}">
-                <a16:creationId xmlns:a16="http://schemas.microsoft.com/office/drawing/2014/main" id="{AEC07857-FD98-41A0-95E7-9DD156D0C6BC}"/>
+                <a16:creationId xmlns:a16="http://schemas.microsoft.com/office/drawing/2014/main" id="{642A99F0-B7CC-4F3B-A961-3D27DFA007B3}"/>
               </a:ext>
             </a:extLst>
           </p:cNvPr>
@@ -9739,7 +10080,7 @@
           <p:cNvPr id="30" name="">
             <a:extLst xmlns:a="http://schemas.openxmlformats.org/drawingml/2006/main">
               <a:ext uri="{FF2B5EF4-FFF2-40B4-BE49-F238E27FC236}">
-                <a16:creationId xmlns:a16="http://schemas.microsoft.com/office/drawing/2014/main" id="{27922023-BBFF-4989-9834-879CE80A78D1}"/>
+                <a16:creationId xmlns:a16="http://schemas.microsoft.com/office/drawing/2014/main" id="{4D8E5286-87EF-4D58-A227-9F7C00FBA461}"/>
               </a:ext>
             </a:extLst>
           </p:cNvPr>
@@ -9803,7 +10144,7 @@
           <p:cNvPr id="31" name="">
             <a:extLst xmlns:a="http://schemas.openxmlformats.org/drawingml/2006/main">
               <a:ext uri="{FF2B5EF4-FFF2-40B4-BE49-F238E27FC236}">
-                <a16:creationId xmlns:a16="http://schemas.microsoft.com/office/drawing/2014/main" id="{65B57A59-6F8D-42A5-9696-8FBC700DEB9B}"/>
+                <a16:creationId xmlns:a16="http://schemas.microsoft.com/office/drawing/2014/main" id="{09861568-5D0D-4ECB-B8DA-964501BB0E5B}"/>
               </a:ext>
             </a:extLst>
           </p:cNvPr>
@@ -9836,7 +10177,7 @@
           <p:cNvPr id="32" name="">
             <a:extLst xmlns:a="http://schemas.openxmlformats.org/drawingml/2006/main">
               <a:ext uri="{FF2B5EF4-FFF2-40B4-BE49-F238E27FC236}">
-                <a16:creationId xmlns:a16="http://schemas.microsoft.com/office/drawing/2014/main" id="{7CF59B40-15E6-4C2E-9419-BBCAE42363BB}"/>
+                <a16:creationId xmlns:a16="http://schemas.microsoft.com/office/drawing/2014/main" id="{10AD9931-751A-48AA-AED4-47C11E64B1AE}"/>
               </a:ext>
             </a:extLst>
           </p:cNvPr>
@@ -9900,7 +10241,7 @@
           <p:cNvPr id="33" name="">
             <a:extLst xmlns:a="http://schemas.openxmlformats.org/drawingml/2006/main">
               <a:ext uri="{FF2B5EF4-FFF2-40B4-BE49-F238E27FC236}">
-                <a16:creationId xmlns:a16="http://schemas.microsoft.com/office/drawing/2014/main" id="{B4B31857-3F41-4498-930E-AEE6A4A1FA86}"/>
+                <a16:creationId xmlns:a16="http://schemas.microsoft.com/office/drawing/2014/main" id="{E3146A30-B29B-491F-AEC4-4E2A56B18267}"/>
               </a:ext>
             </a:extLst>
           </p:cNvPr>
@@ -9935,7 +10276,7 @@
           <p:cNvPr id="34" name="">
             <a:extLst xmlns:a="http://schemas.openxmlformats.org/drawingml/2006/main">
               <a:ext uri="{FF2B5EF4-FFF2-40B4-BE49-F238E27FC236}">
-                <a16:creationId xmlns:a16="http://schemas.microsoft.com/office/drawing/2014/main" id="{437B9B9E-910D-4ED4-B85F-411763DB4929}"/>
+                <a16:creationId xmlns:a16="http://schemas.microsoft.com/office/drawing/2014/main" id="{8BE208D2-F1DA-474A-A37C-B844587321E1}"/>
               </a:ext>
             </a:extLst>
           </p:cNvPr>
@@ -9970,7 +10311,7 @@
           <p:cNvPr id="35" name="">
             <a:extLst xmlns:a="http://schemas.openxmlformats.org/drawingml/2006/main">
               <a:ext uri="{FF2B5EF4-FFF2-40B4-BE49-F238E27FC236}">
-                <a16:creationId xmlns:a16="http://schemas.microsoft.com/office/drawing/2014/main" id="{56BDFC32-0A60-4DC1-BECF-424BEB159399}"/>
+                <a16:creationId xmlns:a16="http://schemas.microsoft.com/office/drawing/2014/main" id="{7D0288AD-30CD-4C6E-9ABB-E6A7D64BD24F}"/>
               </a:ext>
             </a:extLst>
           </p:cNvPr>
@@ -10005,7 +10346,7 @@
           <p:cNvPr id="36" name="">
             <a:extLst xmlns:a="http://schemas.openxmlformats.org/drawingml/2006/main">
               <a:ext uri="{FF2B5EF4-FFF2-40B4-BE49-F238E27FC236}">
-                <a16:creationId xmlns:a16="http://schemas.microsoft.com/office/drawing/2014/main" id="{EFEACBF4-F225-41E4-92B8-D9798ABC7F29}"/>
+                <a16:creationId xmlns:a16="http://schemas.microsoft.com/office/drawing/2014/main" id="{D4C92124-B917-4271-903B-7886B3CE0A25}"/>
               </a:ext>
             </a:extLst>
           </p:cNvPr>
@@ -10069,7 +10410,7 @@
           <p:cNvPr id="37" name="">
             <a:extLst xmlns:a="http://schemas.openxmlformats.org/drawingml/2006/main">
               <a:ext uri="{FF2B5EF4-FFF2-40B4-BE49-F238E27FC236}">
-                <a16:creationId xmlns:a16="http://schemas.microsoft.com/office/drawing/2014/main" id="{6D002374-A625-49D9-8F8E-6D6BFEE12968}"/>
+                <a16:creationId xmlns:a16="http://schemas.microsoft.com/office/drawing/2014/main" id="{DBB86FEE-A5B3-4596-A3C1-3C5FBE473608}"/>
               </a:ext>
             </a:extLst>
           </p:cNvPr>
@@ -10133,7 +10474,7 @@
           <p:cNvPr id="38" name="">
             <a:extLst xmlns:a="http://schemas.openxmlformats.org/drawingml/2006/main">
               <a:ext uri="{FF2B5EF4-FFF2-40B4-BE49-F238E27FC236}">
-                <a16:creationId xmlns:a16="http://schemas.microsoft.com/office/drawing/2014/main" id="{7B48BDDF-C08C-4294-9F8E-4EFE2D93CE1B}"/>
+                <a16:creationId xmlns:a16="http://schemas.microsoft.com/office/drawing/2014/main" id="{309B19FF-25B4-4B1D-8C4A-943AA46400B4}"/>
               </a:ext>
             </a:extLst>
           </p:cNvPr>
@@ -10197,7 +10538,7 @@
           <p:cNvPr id="39" name="">
             <a:extLst xmlns:a="http://schemas.openxmlformats.org/drawingml/2006/main">
               <a:ext uri="{FF2B5EF4-FFF2-40B4-BE49-F238E27FC236}">
-                <a16:creationId xmlns:a16="http://schemas.microsoft.com/office/drawing/2014/main" id="{801127E6-DCC7-4B67-94CF-FD94F660C8B6}"/>
+                <a16:creationId xmlns:a16="http://schemas.microsoft.com/office/drawing/2014/main" id="{02B66F72-D6EF-4D9F-A5C2-16287F83BB58}"/>
               </a:ext>
             </a:extLst>
           </p:cNvPr>
@@ -10230,7 +10571,7 @@
           <p:cNvPr id="40" name="">
             <a:extLst xmlns:a="http://schemas.openxmlformats.org/drawingml/2006/main">
               <a:ext uri="{FF2B5EF4-FFF2-40B4-BE49-F238E27FC236}">
-                <a16:creationId xmlns:a16="http://schemas.microsoft.com/office/drawing/2014/main" id="{59A01BBD-784F-4490-A2D6-947F52B58FB9}"/>
+                <a16:creationId xmlns:a16="http://schemas.microsoft.com/office/drawing/2014/main" id="{3CDE5677-D58E-4F2E-8B6D-392E1E4062F7}"/>
               </a:ext>
             </a:extLst>
           </p:cNvPr>
@@ -10284,7 +10625,7 @@
                 <a:ea typeface="Aptos"/>
                 <a:cs typeface="Aptos"/>
               </a:rPr>
-              <a:t>Règle: chaque split est fait par vidéo parente, donc les fenêtres voisines d'une même vidéo ne fuient pas entre train et test.</a:t>
+              <a:t>R�gle: chaque split est fait par vid�o parente, donc les fen�tres voisines d'une m�me vid�o ne fuient pas entre train et test.</a:t>
             </a:r>
           </a:p>
         </p:txBody>
@@ -10294,7 +10635,7 @@
           <p:cNvPr id="41" name="">
             <a:extLst xmlns:a="http://schemas.openxmlformats.org/drawingml/2006/main">
               <a:ext uri="{FF2B5EF4-FFF2-40B4-BE49-F238E27FC236}">
-                <a16:creationId xmlns:a16="http://schemas.microsoft.com/office/drawing/2014/main" id="{66643D9E-333F-4678-9692-832369F6FA75}"/>
+                <a16:creationId xmlns:a16="http://schemas.microsoft.com/office/drawing/2014/main" id="{99270424-051B-4BD8-8741-E2372481B8A3}"/>
               </a:ext>
             </a:extLst>
           </p:cNvPr>
@@ -10327,7 +10668,7 @@
           <p:cNvPr id="42" name="">
             <a:extLst xmlns:a="http://schemas.openxmlformats.org/drawingml/2006/main">
               <a:ext uri="{FF2B5EF4-FFF2-40B4-BE49-F238E27FC236}">
-                <a16:creationId xmlns:a16="http://schemas.microsoft.com/office/drawing/2014/main" id="{4165D47D-6698-4EF3-B316-A9039A81963E}"/>
+                <a16:creationId xmlns:a16="http://schemas.microsoft.com/office/drawing/2014/main" id="{F226A160-81F7-4975-B087-592663D3F026}"/>
               </a:ext>
             </a:extLst>
           </p:cNvPr>
@@ -10381,7 +10722,7 @@
                 <a:ea typeface="Aptos"/>
                 <a:cs typeface="Aptos"/>
               </a:rPr>
-              <a:t>Interprétation: les graines répétées ne remplacent pas un grand dataset, mais elles réduisent la dépendance à une seule séparation favorable ou défavorable.</a:t>
+              <a:t>Interpr�tation: les graines r�p�t�es ne remplacent pas un grand dataset, mais elles r�duisent la d�pendance � une seule s�paration favorable ou d�favorable.</a:t>
             </a:r>
           </a:p>
         </p:txBody>
@@ -10389,7 +10730,7 @@
     </p:spTree>
     <p:extLst>
       <p:ext uri="{BB962C8B-B14F-4D97-AF65-F5344CB8AC3E}">
-        <p14:creationId xmlns:p14="http://schemas.microsoft.com/office/powerpoint/2010/main" val="1153715764"/>
+        <p14:creationId xmlns:p14="http://schemas.microsoft.com/office/powerpoint/2010/main" val="1483819808"/>
       </p:ext>
     </p:extLst>
   </p:cSld>
@@ -10413,7 +10754,7 @@
           <p:cNvPr id="1" name="">
             <a:extLst xmlns:a="http://schemas.openxmlformats.org/drawingml/2006/main">
               <a:ext uri="{FF2B5EF4-FFF2-40B4-BE49-F238E27FC236}">
-                <a16:creationId xmlns:a16="http://schemas.microsoft.com/office/drawing/2014/main" id="{33DBE330-9D56-4D9B-90A0-515982FEDBBA}"/>
+                <a16:creationId xmlns:a16="http://schemas.microsoft.com/office/drawing/2014/main" id="{B65F7631-CCD6-4A65-A650-35AD700C87D0}"/>
               </a:ext>
             </a:extLst>
           </p:cNvPr>
@@ -10448,7 +10789,7 @@
           <p:cNvPr id="2" name="">
             <a:extLst xmlns:a="http://schemas.openxmlformats.org/drawingml/2006/main">
               <a:ext uri="{FF2B5EF4-FFF2-40B4-BE49-F238E27FC236}">
-                <a16:creationId xmlns:a16="http://schemas.microsoft.com/office/drawing/2014/main" id="{06C2F5D9-547E-43EF-9F43-9EC994239882}"/>
+                <a16:creationId xmlns:a16="http://schemas.microsoft.com/office/drawing/2014/main" id="{F421CAEA-CDE4-4FFF-A600-55B8840596A2}"/>
               </a:ext>
             </a:extLst>
           </p:cNvPr>
@@ -10502,7 +10843,7 @@
                 <a:ea typeface="Aptos"/>
                 <a:cs typeface="Aptos"/>
               </a:rPr>
-              <a:t>Artefact à montrer: policy_results_comparison.png</a:t>
+              <a:t>Résultats: compromis d'alerte TCN et compromis de stop GRU</a:t>
             </a:r>
           </a:p>
         </p:txBody>
@@ -10512,7 +10853,7 @@
           <p:cNvPr id="3" name="">
             <a:extLst xmlns:a="http://schemas.openxmlformats.org/drawingml/2006/main">
               <a:ext uri="{FF2B5EF4-FFF2-40B4-BE49-F238E27FC236}">
-                <a16:creationId xmlns:a16="http://schemas.microsoft.com/office/drawing/2014/main" id="{50EF9EED-19AE-4581-821F-2BF77053A76E}"/>
+                <a16:creationId xmlns:a16="http://schemas.microsoft.com/office/drawing/2014/main" id="{E5B23766-B0B9-4EBD-8851-1F5B9700EA6C}"/>
               </a:ext>
             </a:extLst>
           </p:cNvPr>
@@ -10576,7 +10917,7 @@
           <p:cNvPr id="4" name="">
             <a:extLst xmlns:a="http://schemas.openxmlformats.org/drawingml/2006/main">
               <a:ext uri="{FF2B5EF4-FFF2-40B4-BE49-F238E27FC236}">
-                <a16:creationId xmlns:a16="http://schemas.microsoft.com/office/drawing/2014/main" id="{9D6370BB-46AD-4E27-839D-7BB7D72A40BD}"/>
+                <a16:creationId xmlns:a16="http://schemas.microsoft.com/office/drawing/2014/main" id="{7D6335E2-9D59-4324-898C-DC3E5F56E0C7}"/>
               </a:ext>
             </a:extLst>
           </p:cNvPr>
@@ -10611,7 +10952,7 @@
           <p:cNvPr id="5" name="">
             <a:extLst xmlns:a="http://schemas.openxmlformats.org/drawingml/2006/main">
               <a:ext uri="{FF2B5EF4-FFF2-40B4-BE49-F238E27FC236}">
-                <a16:creationId xmlns:a16="http://schemas.microsoft.com/office/drawing/2014/main" id="{BA602028-D5E3-4273-9BD5-C1C62E956753}"/>
+                <a16:creationId xmlns:a16="http://schemas.microsoft.com/office/drawing/2014/main" id="{7448F7F4-F0F6-4760-8B2A-42140C11CDD5}"/>
               </a:ext>
             </a:extLst>
           </p:cNvPr>
@@ -10675,7 +11016,7 @@
           <p:cNvPr id="6" name="">
             <a:extLst xmlns:a="http://schemas.openxmlformats.org/drawingml/2006/main">
               <a:ext uri="{FF2B5EF4-FFF2-40B4-BE49-F238E27FC236}">
-                <a16:creationId xmlns:a16="http://schemas.microsoft.com/office/drawing/2014/main" id="{90F061FD-D157-4180-B3BF-44397107CC71}"/>
+                <a16:creationId xmlns:a16="http://schemas.microsoft.com/office/drawing/2014/main" id="{0636B68F-E91A-4F40-A1F4-E70F2E3670AF}"/>
               </a:ext>
             </a:extLst>
           </p:cNvPr>
@@ -10687,7 +11028,7 @@
         <p:spPr>
           <a:xfrm xmlns:a="http://schemas.openxmlformats.org/drawingml/2006/main">
             <a:off x="609600" y="666750"/>
-            <a:ext cx="8572500" cy="914400"/>
+            <a:ext cx="9334500" cy="914400"/>
           </a:xfrm>
           <a:prstGeom xmlns:a="http://schemas.openxmlformats.org/drawingml/2006/main" prst="rect">
             <a:avLst/>
@@ -10729,51 +11070,62 @@
                 <a:ea typeface="Aptos Display"/>
                 <a:cs typeface="Aptos Display"/>
               </a:rPr>
-              <a:t>Le résultat fort n'est pas un score unique; ce sont trois modes d'usage.</a:t>
-            </a:r>
-          </a:p>
-        </p:txBody>
-      </p:sp>
-      <p:pic>
-        <p:nvPicPr>
-          <p:cNvPr id="7" name=""/>
-          <p:cNvPicPr>
-            <a:picLocks xmlns:a="http://schemas.openxmlformats.org/drawingml/2006/main" noChangeAspect="1"/>
-          </p:cNvPicPr>
-          <p:nvPr/>
-        </p:nvPicPr>
-        <p:blipFill>
-          <a:blip xmlns:r="http://schemas.openxmlformats.org/officeDocument/2006/relationships" xmlns:a="http://schemas.openxmlformats.org/drawingml/2006/main" r:embed="Raceb21d55ea04025"/>
-          <a:stretch xmlns:a="http://schemas.openxmlformats.org/drawingml/2006/main"/>
-        </p:blipFill>
-        <p:spPr>
-          <a:xfrm xmlns:a="http://schemas.openxmlformats.org/drawingml/2006/main">
-            <a:off x="666750" y="1843088"/>
-            <a:ext cx="5334000" cy="3000375"/>
-          </a:xfrm>
-          <a:prstGeom xmlns:a="http://schemas.openxmlformats.org/drawingml/2006/main" prst="rect">
-            <a:avLst/>
-          </a:prstGeom>
-        </p:spPr>
-      </p:pic>
+              <a:t>Alerte opérateur et stop court horizon se lisent avec des métriques différentes.</a:t>
+            </a:r>
+          </a:p>
+        </p:txBody>
+      </p:sp>
+      <p:sp>
+        <p:nvSpPr>
+          <p:cNvPr id="7" name="">
+            <a:extLst xmlns:a="http://schemas.openxmlformats.org/drawingml/2006/main">
+              <a:ext uri="{FF2B5EF4-FFF2-40B4-BE49-F238E27FC236}">
+                <a16:creationId xmlns:a16="http://schemas.microsoft.com/office/drawing/2014/main" id="{18EDE2B6-123A-4B8D-96FF-19C3DE803F26}"/>
+              </a:ext>
+            </a:extLst>
+          </p:cNvPr>
+          <p:cNvSpPr>
+            <a:spLocks xmlns:a="http://schemas.openxmlformats.org/drawingml/2006/main" noGrp="1"/>
+          </p:cNvSpPr>
+          <p:nvPr/>
+        </p:nvSpPr>
+        <p:spPr>
+          <a:xfrm xmlns:a="http://schemas.openxmlformats.org/drawingml/2006/main">
+            <a:off x="609600" y="1695450"/>
+            <a:ext cx="5219700" cy="3638550"/>
+          </a:xfrm>
+          <a:prstGeom xmlns:a="http://schemas.openxmlformats.org/drawingml/2006/main" prst="rect">
+            <a:avLst/>
+          </a:prstGeom>
+          <a:solidFill xmlns:a="http://schemas.openxmlformats.org/drawingml/2006/main">
+            <a:srgbClr val="FFFFFF"/>
+          </a:solidFill>
+          <a:ln xmlns:a="http://schemas.openxmlformats.org/drawingml/2006/main" w="19050">
+            <a:solidFill>
+              <a:srgbClr val="1F4E79"/>
+            </a:solidFill>
+            <a:prstDash val="solid"/>
+          </a:ln>
+        </p:spPr>
+      </p:sp>
       <p:sp>
         <p:nvSpPr>
           <p:cNvPr id="8" name="">
             <a:extLst xmlns:a="http://schemas.openxmlformats.org/drawingml/2006/main">
               <a:ext uri="{FF2B5EF4-FFF2-40B4-BE49-F238E27FC236}">
-                <a16:creationId xmlns:a16="http://schemas.microsoft.com/office/drawing/2014/main" id="{F150A9BA-C8A8-49E5-9EAC-221524ED4E86}"/>
-              </a:ext>
-            </a:extLst>
-          </p:cNvPr>
-          <p:cNvSpPr>
-            <a:spLocks xmlns:a="http://schemas.openxmlformats.org/drawingml/2006/main" noGrp="1"/>
-          </p:cNvSpPr>
-          <p:nvPr/>
-        </p:nvSpPr>
-        <p:spPr>
-          <a:xfrm xmlns:a="http://schemas.openxmlformats.org/drawingml/2006/main">
-            <a:off x="6724650" y="1790700"/>
-            <a:ext cx="2000250" cy="438150"/>
+                <a16:creationId xmlns:a16="http://schemas.microsoft.com/office/drawing/2014/main" id="{FCCD27DE-87EE-40F5-A140-232E9F18F4CA}"/>
+              </a:ext>
+            </a:extLst>
+          </p:cNvPr>
+          <p:cNvSpPr>
+            <a:spLocks xmlns:a="http://schemas.openxmlformats.org/drawingml/2006/main" noGrp="1"/>
+          </p:cNvSpPr>
+          <p:nvPr/>
+        </p:nvSpPr>
+        <p:spPr>
+          <a:xfrm xmlns:a="http://schemas.openxmlformats.org/drawingml/2006/main">
+            <a:off x="876300" y="1943100"/>
+            <a:ext cx="2476500" cy="323850"/>
           </a:xfrm>
           <a:prstGeom xmlns:a="http://schemas.openxmlformats.org/drawingml/2006/main" prst="rect">
             <a:avLst/>
@@ -10797,25 +11149,25 @@
           <a:lstStyle xmlns:a="http://schemas.openxmlformats.org/drawingml/2006/main"/>
           <a:p xmlns:a="http://schemas.openxmlformats.org/drawingml/2006/main">
             <a:pPr algn="l">
-              <a:defRPr sz="2550" b="1">
+              <a:defRPr sz="2100" b="1">
                 <a:solidFill>
                   <a:srgbClr val="1F4E79"/>
                 </a:solidFill>
-                <a:latin typeface="Aptos Display"/>
-                <a:ea typeface="Aptos Display"/>
-                <a:cs typeface="Aptos Display"/>
-              </a:defRPr>
-            </a:pPr>
-            <a:r>
-              <a:rPr sz="2550" b="1">
+                <a:latin typeface="Aptos"/>
+                <a:ea typeface="Aptos"/>
+                <a:cs typeface="Aptos"/>
+              </a:defRPr>
+            </a:pPr>
+            <a:r>
+              <a:rPr sz="2100" b="1">
                 <a:solidFill>
                   <a:srgbClr val="1F4E79"/>
                 </a:solidFill>
-                <a:latin typeface="Aptos Display"/>
-                <a:ea typeface="Aptos Display"/>
-                <a:cs typeface="Aptos Display"/>
-              </a:rPr>
-              <a:t>0.683</a:t>
+                <a:latin typeface="Aptos"/>
+                <a:ea typeface="Aptos"/>
+                <a:cs typeface="Aptos"/>
+              </a:rPr>
+              <a:t>Alerte opérateur TCN</a:t>
             </a:r>
           </a:p>
         </p:txBody>
@@ -10825,19 +11177,19 @@
           <p:cNvPr id="9" name="">
             <a:extLst xmlns:a="http://schemas.openxmlformats.org/drawingml/2006/main">
               <a:ext uri="{FF2B5EF4-FFF2-40B4-BE49-F238E27FC236}">
-                <a16:creationId xmlns:a16="http://schemas.microsoft.com/office/drawing/2014/main" id="{51E778FA-FDD5-43E0-B9E9-F379E47F3B0F}"/>
-              </a:ext>
-            </a:extLst>
-          </p:cNvPr>
-          <p:cNvSpPr>
-            <a:spLocks xmlns:a="http://schemas.openxmlformats.org/drawingml/2006/main" noGrp="1"/>
-          </p:cNvSpPr>
-          <p:nvPr/>
-        </p:nvSpPr>
-        <p:spPr>
-          <a:xfrm xmlns:a="http://schemas.openxmlformats.org/drawingml/2006/main">
-            <a:off x="6724650" y="2343150"/>
-            <a:ext cx="2000250" cy="419100"/>
+                <a16:creationId xmlns:a16="http://schemas.microsoft.com/office/drawing/2014/main" id="{9392E99C-EF64-4784-8E0C-08931EB68C06}"/>
+              </a:ext>
+            </a:extLst>
+          </p:cNvPr>
+          <p:cNvSpPr>
+            <a:spLocks xmlns:a="http://schemas.openxmlformats.org/drawingml/2006/main" noGrp="1"/>
+          </p:cNvSpPr>
+          <p:nvPr/>
+        </p:nvSpPr>
+        <p:spPr>
+          <a:xfrm xmlns:a="http://schemas.openxmlformats.org/drawingml/2006/main">
+            <a:off x="876300" y="2324100"/>
+            <a:ext cx="2857500" cy="228600"/>
           </a:xfrm>
           <a:prstGeom xmlns:a="http://schemas.openxmlformats.org/drawingml/2006/main" prst="rect">
             <a:avLst/>
@@ -10861,25 +11213,25 @@
           <a:lstStyle xmlns:a="http://schemas.openxmlformats.org/drawingml/2006/main"/>
           <a:p xmlns:a="http://schemas.openxmlformats.org/drawingml/2006/main">
             <a:pPr algn="l">
-              <a:defRPr sz="1050" b="0">
+              <a:defRPr sz="1200" b="0">
                 <a:solidFill>
                   <a:srgbClr val="718096"/>
                 </a:solidFill>
-                <a:latin typeface="Aptos"/>
-                <a:ea typeface="Aptos"/>
-                <a:cs typeface="Aptos"/>
-              </a:defRPr>
-            </a:pPr>
-            <a:r>
-              <a:rPr sz="1050" b="0">
+                <a:latin typeface="Aptos Mono"/>
+                <a:ea typeface="Aptos Mono"/>
+                <a:cs typeface="Aptos Mono"/>
+              </a:defRPr>
+            </a:pPr>
+            <a:r>
+              <a:rPr sz="1200" b="0">
                 <a:solidFill>
                   <a:srgbClr val="718096"/>
                 </a:solidFill>
-                <a:latin typeface="Aptos"/>
-                <a:ea typeface="Aptos"/>
-                <a:cs typeface="Aptos"/>
-              </a:rPr>
-              <a:t>détection alerte conservatrice</a:t>
+                <a:latin typeface="Aptos Mono"/>
+                <a:ea typeface="Aptos Mono"/>
+                <a:cs typeface="Aptos Mono"/>
+              </a:rPr>
+              <a:t>Sortie unique: risk_present_now</a:t>
             </a:r>
           </a:p>
         </p:txBody>
@@ -10889,19 +11241,19 @@
           <p:cNvPr id="10" name="">
             <a:extLst xmlns:a="http://schemas.openxmlformats.org/drawingml/2006/main">
               <a:ext uri="{FF2B5EF4-FFF2-40B4-BE49-F238E27FC236}">
-                <a16:creationId xmlns:a16="http://schemas.microsoft.com/office/drawing/2014/main" id="{E49CF90F-CCB5-46EF-8443-3FE27C815872}"/>
-              </a:ext>
-            </a:extLst>
-          </p:cNvPr>
-          <p:cNvSpPr>
-            <a:spLocks xmlns:a="http://schemas.openxmlformats.org/drawingml/2006/main" noGrp="1"/>
-          </p:cNvSpPr>
-          <p:nvPr/>
-        </p:nvSpPr>
-        <p:spPr>
-          <a:xfrm xmlns:a="http://schemas.openxmlformats.org/drawingml/2006/main">
-            <a:off x="8915400" y="1790700"/>
-            <a:ext cx="2000250" cy="438150"/>
+                <a16:creationId xmlns:a16="http://schemas.microsoft.com/office/drawing/2014/main" id="{68B2E931-C24C-4059-A215-599AB9F89CF6}"/>
+              </a:ext>
+            </a:extLst>
+          </p:cNvPr>
+          <p:cNvSpPr>
+            <a:spLocks xmlns:a="http://schemas.openxmlformats.org/drawingml/2006/main" noGrp="1"/>
+          </p:cNvSpPr>
+          <p:nvPr/>
+        </p:nvSpPr>
+        <p:spPr>
+          <a:xfrm xmlns:a="http://schemas.openxmlformats.org/drawingml/2006/main">
+            <a:off x="876300" y="2781300"/>
+            <a:ext cx="1524000" cy="228600"/>
           </a:xfrm>
           <a:prstGeom xmlns:a="http://schemas.openxmlformats.org/drawingml/2006/main" prst="rect">
             <a:avLst/>
@@ -10925,25 +11277,25 @@
           <a:lstStyle xmlns:a="http://schemas.openxmlformats.org/drawingml/2006/main"/>
           <a:p xmlns:a="http://schemas.openxmlformats.org/drawingml/2006/main">
             <a:pPr algn="l">
-              <a:defRPr sz="2550" b="1">
-                <a:solidFill>
-                  <a:srgbClr val="D9901F"/>
-                </a:solidFill>
-                <a:latin typeface="Aptos Display"/>
-                <a:ea typeface="Aptos Display"/>
-                <a:cs typeface="Aptos Display"/>
-              </a:defRPr>
-            </a:pPr>
-            <a:r>
-              <a:rPr sz="2550" b="1">
-                <a:solidFill>
-                  <a:srgbClr val="D9901F"/>
-                </a:solidFill>
-                <a:latin typeface="Aptos Display"/>
-                <a:ea typeface="Aptos Display"/>
-                <a:cs typeface="Aptos Display"/>
-              </a:rPr>
-              <a:t>1.000</a:t>
+              <a:defRPr sz="1350" b="1">
+                <a:solidFill>
+                  <a:srgbClr val="17202A"/>
+                </a:solidFill>
+                <a:latin typeface="Aptos"/>
+                <a:ea typeface="Aptos"/>
+                <a:cs typeface="Aptos"/>
+              </a:defRPr>
+            </a:pPr>
+            <a:r>
+              <a:rPr sz="1350" b="1">
+                <a:solidFill>
+                  <a:srgbClr val="17202A"/>
+                </a:solidFill>
+                <a:latin typeface="Aptos"/>
+                <a:ea typeface="Aptos"/>
+                <a:cs typeface="Aptos"/>
+              </a:rPr>
+              <a:t>Seuil 0,55</a:t>
             </a:r>
           </a:p>
         </p:txBody>
@@ -10953,19 +11305,19 @@
           <p:cNvPr id="11" name="">
             <a:extLst xmlns:a="http://schemas.openxmlformats.org/drawingml/2006/main">
               <a:ext uri="{FF2B5EF4-FFF2-40B4-BE49-F238E27FC236}">
-                <a16:creationId xmlns:a16="http://schemas.microsoft.com/office/drawing/2014/main" id="{6C019250-62D7-40D0-8200-233E0331567E}"/>
-              </a:ext>
-            </a:extLst>
-          </p:cNvPr>
-          <p:cNvSpPr>
-            <a:spLocks xmlns:a="http://schemas.openxmlformats.org/drawingml/2006/main" noGrp="1"/>
-          </p:cNvSpPr>
-          <p:nvPr/>
-        </p:nvSpPr>
-        <p:spPr>
-          <a:xfrm xmlns:a="http://schemas.openxmlformats.org/drawingml/2006/main">
-            <a:off x="8915400" y="2343150"/>
-            <a:ext cx="2000250" cy="419100"/>
+                <a16:creationId xmlns:a16="http://schemas.microsoft.com/office/drawing/2014/main" id="{ED8695E3-271A-4DD5-82C1-43BB73C4D12D}"/>
+              </a:ext>
+            </a:extLst>
+          </p:cNvPr>
+          <p:cNvSpPr>
+            <a:spLocks xmlns:a="http://schemas.openxmlformats.org/drawingml/2006/main" noGrp="1"/>
+          </p:cNvSpPr>
+          <p:nvPr/>
+        </p:nvSpPr>
+        <p:spPr>
+          <a:xfrm xmlns:a="http://schemas.openxmlformats.org/drawingml/2006/main">
+            <a:off x="876300" y="3124200"/>
+            <a:ext cx="1047750" cy="190500"/>
           </a:xfrm>
           <a:prstGeom xmlns:a="http://schemas.openxmlformats.org/drawingml/2006/main" prst="rect">
             <a:avLst/>
@@ -10989,7 +11341,7 @@
           <a:lstStyle xmlns:a="http://schemas.openxmlformats.org/drawingml/2006/main"/>
           <a:p xmlns:a="http://schemas.openxmlformats.org/drawingml/2006/main">
             <a:pPr algn="l">
-              <a:defRPr sz="1050" b="0">
+              <a:defRPr sz="1125" b="0">
                 <a:solidFill>
                   <a:srgbClr val="718096"/>
                 </a:solidFill>
@@ -10999,7 +11351,7 @@
               </a:defRPr>
             </a:pPr>
             <a:r>
-              <a:rPr sz="1050" b="0">
+              <a:rPr sz="1125" b="0">
                 <a:solidFill>
                   <a:srgbClr val="718096"/>
                 </a:solidFill>
@@ -11007,7 +11359,7 @@
                 <a:ea typeface="Aptos"/>
                 <a:cs typeface="Aptos"/>
               </a:rPr>
-              <a:t>détection alerte agressive</a:t>
+              <a:t>Early 0,2</a:t>
             </a:r>
           </a:p>
         </p:txBody>
@@ -11017,19 +11369,19 @@
           <p:cNvPr id="12" name="">
             <a:extLst xmlns:a="http://schemas.openxmlformats.org/drawingml/2006/main">
               <a:ext uri="{FF2B5EF4-FFF2-40B4-BE49-F238E27FC236}">
-                <a16:creationId xmlns:a16="http://schemas.microsoft.com/office/drawing/2014/main" id="{4D44863E-B56A-4D22-B8DA-44E5B993AE42}"/>
-              </a:ext>
-            </a:extLst>
-          </p:cNvPr>
-          <p:cNvSpPr>
-            <a:spLocks xmlns:a="http://schemas.openxmlformats.org/drawingml/2006/main" noGrp="1"/>
-          </p:cNvSpPr>
-          <p:nvPr/>
-        </p:nvSpPr>
-        <p:spPr>
-          <a:xfrm xmlns:a="http://schemas.openxmlformats.org/drawingml/2006/main">
-            <a:off x="6724650" y="2933700"/>
-            <a:ext cx="2857500" cy="438150"/>
+                <a16:creationId xmlns:a16="http://schemas.microsoft.com/office/drawing/2014/main" id="{63A7C79F-D4AD-438B-9680-A81729A47884}"/>
+              </a:ext>
+            </a:extLst>
+          </p:cNvPr>
+          <p:cNvSpPr>
+            <a:spLocks xmlns:a="http://schemas.openxmlformats.org/drawingml/2006/main" noGrp="1"/>
+          </p:cNvSpPr>
+          <p:nvPr/>
+        </p:nvSpPr>
+        <p:spPr>
+          <a:xfrm xmlns:a="http://schemas.openxmlformats.org/drawingml/2006/main">
+            <a:off x="914400" y="3333750"/>
+            <a:ext cx="876300" cy="323850"/>
           </a:xfrm>
           <a:prstGeom xmlns:a="http://schemas.openxmlformats.org/drawingml/2006/main" prst="rect">
             <a:avLst/>
@@ -11053,25 +11405,25 @@
           <a:lstStyle xmlns:a="http://schemas.openxmlformats.org/drawingml/2006/main"/>
           <a:p xmlns:a="http://schemas.openxmlformats.org/drawingml/2006/main">
             <a:pPr algn="l">
-              <a:defRPr sz="2550" b="1">
-                <a:solidFill>
-                  <a:srgbClr val="B23A48"/>
-                </a:solidFill>
-                <a:latin typeface="Aptos Display"/>
-                <a:ea typeface="Aptos Display"/>
-                <a:cs typeface="Aptos Display"/>
-              </a:defRPr>
-            </a:pPr>
-            <a:r>
-              <a:rPr sz="2550" b="1">
-                <a:solidFill>
-                  <a:srgbClr val="B23A48"/>
-                </a:solidFill>
-                <a:latin typeface="Aptos Display"/>
-                <a:ea typeface="Aptos Display"/>
-                <a:cs typeface="Aptos Display"/>
-              </a:rPr>
-              <a:t>0.903</a:t>
+              <a:defRPr sz="2100" b="1">
+                <a:solidFill>
+                  <a:srgbClr val="1F4E79"/>
+                </a:solidFill>
+                <a:latin typeface="Aptos"/>
+                <a:ea typeface="Aptos"/>
+                <a:cs typeface="Aptos"/>
+              </a:defRPr>
+            </a:pPr>
+            <a:r>
+              <a:rPr sz="2100" b="1">
+                <a:solidFill>
+                  <a:srgbClr val="1F4E79"/>
+                </a:solidFill>
+                <a:latin typeface="Aptos"/>
+                <a:ea typeface="Aptos"/>
+                <a:cs typeface="Aptos"/>
+              </a:rPr>
+              <a:t>0.850</a:t>
             </a:r>
           </a:p>
         </p:txBody>
@@ -11081,19 +11433,19 @@
           <p:cNvPr id="13" name="">
             <a:extLst xmlns:a="http://schemas.openxmlformats.org/drawingml/2006/main">
               <a:ext uri="{FF2B5EF4-FFF2-40B4-BE49-F238E27FC236}">
-                <a16:creationId xmlns:a16="http://schemas.microsoft.com/office/drawing/2014/main" id="{05985190-DA46-4A6F-92E0-B7B48AC1B221}"/>
-              </a:ext>
-            </a:extLst>
-          </p:cNvPr>
-          <p:cNvSpPr>
-            <a:spLocks xmlns:a="http://schemas.openxmlformats.org/drawingml/2006/main" noGrp="1"/>
-          </p:cNvSpPr>
-          <p:nvPr/>
-        </p:nvSpPr>
-        <p:spPr>
-          <a:xfrm xmlns:a="http://schemas.openxmlformats.org/drawingml/2006/main">
-            <a:off x="6724650" y="3486150"/>
-            <a:ext cx="2857500" cy="419100"/>
+                <a16:creationId xmlns:a16="http://schemas.microsoft.com/office/drawing/2014/main" id="{5B093D35-568E-4800-BF41-FA5E9AFE97D8}"/>
+              </a:ext>
+            </a:extLst>
+          </p:cNvPr>
+          <p:cNvSpPr>
+            <a:spLocks xmlns:a="http://schemas.openxmlformats.org/drawingml/2006/main" noGrp="1"/>
+          </p:cNvSpPr>
+          <p:nvPr/>
+        </p:nvSpPr>
+        <p:spPr>
+          <a:xfrm xmlns:a="http://schemas.openxmlformats.org/drawingml/2006/main">
+            <a:off x="2152650" y="3124200"/>
+            <a:ext cx="1047750" cy="190500"/>
           </a:xfrm>
           <a:prstGeom xmlns:a="http://schemas.openxmlformats.org/drawingml/2006/main" prst="rect">
             <a:avLst/>
@@ -11117,7 +11469,7 @@
           <a:lstStyle xmlns:a="http://schemas.openxmlformats.org/drawingml/2006/main"/>
           <a:p xmlns:a="http://schemas.openxmlformats.org/drawingml/2006/main">
             <a:pPr algn="l">
-              <a:defRPr sz="1050" b="0">
+              <a:defRPr sz="1125" b="0">
                 <a:solidFill>
                   <a:srgbClr val="718096"/>
                 </a:solidFill>
@@ -11127,7 +11479,7 @@
               </a:defRPr>
             </a:pPr>
             <a:r>
-              <a:rPr sz="1050" b="0">
+              <a:rPr sz="1125" b="0">
                 <a:solidFill>
                   <a:srgbClr val="718096"/>
                 </a:solidFill>
@@ -11135,7 +11487,7 @@
                 <a:ea typeface="Aptos"/>
                 <a:cs typeface="Aptos"/>
               </a:rPr>
-              <a:t>fiabilité arrêt strict &lt;=0,3 s</a:t>
+              <a:t>Early 0,3</a:t>
             </a:r>
           </a:p>
         </p:txBody>
@@ -11145,52 +11497,19 @@
           <p:cNvPr id="14" name="">
             <a:extLst xmlns:a="http://schemas.openxmlformats.org/drawingml/2006/main">
               <a:ext uri="{FF2B5EF4-FFF2-40B4-BE49-F238E27FC236}">
-                <a16:creationId xmlns:a16="http://schemas.microsoft.com/office/drawing/2014/main" id="{86A022C0-533E-4006-BD94-363EDA6C8917}"/>
-              </a:ext>
-            </a:extLst>
-          </p:cNvPr>
-          <p:cNvSpPr>
-            <a:spLocks xmlns:a="http://schemas.openxmlformats.org/drawingml/2006/main" noGrp="1"/>
-          </p:cNvSpPr>
-          <p:nvPr/>
-        </p:nvSpPr>
-        <p:spPr>
-          <a:xfrm xmlns:a="http://schemas.openxmlformats.org/drawingml/2006/main">
-            <a:off x="6724650" y="4324350"/>
-            <a:ext cx="4000500" cy="971550"/>
-          </a:xfrm>
-          <a:prstGeom xmlns:a="http://schemas.openxmlformats.org/drawingml/2006/main" prst="rect">
-            <a:avLst/>
-          </a:prstGeom>
-          <a:solidFill xmlns:a="http://schemas.openxmlformats.org/drawingml/2006/main">
-            <a:srgbClr val="EAF2F8"/>
-          </a:solidFill>
-          <a:ln xmlns:a="http://schemas.openxmlformats.org/drawingml/2006/main" w="9525">
-            <a:solidFill>
-              <a:srgbClr val="1F4E79"/>
-            </a:solidFill>
-            <a:prstDash val="solid"/>
-          </a:ln>
-        </p:spPr>
-      </p:sp>
-      <p:sp>
-        <p:nvSpPr>
-          <p:cNvPr id="15" name="">
-            <a:extLst xmlns:a="http://schemas.openxmlformats.org/drawingml/2006/main">
-              <a:ext uri="{FF2B5EF4-FFF2-40B4-BE49-F238E27FC236}">
-                <a16:creationId xmlns:a16="http://schemas.microsoft.com/office/drawing/2014/main" id="{A9ED9B82-936C-496B-9A8B-69A7061595F1}"/>
-              </a:ext>
-            </a:extLst>
-          </p:cNvPr>
-          <p:cNvSpPr>
-            <a:spLocks xmlns:a="http://schemas.openxmlformats.org/drawingml/2006/main" noGrp="1"/>
-          </p:cNvSpPr>
-          <p:nvPr/>
-        </p:nvSpPr>
-        <p:spPr>
-          <a:xfrm xmlns:a="http://schemas.openxmlformats.org/drawingml/2006/main">
-            <a:off x="6896100" y="4457700"/>
-            <a:ext cx="3657600" cy="742950"/>
+                <a16:creationId xmlns:a16="http://schemas.microsoft.com/office/drawing/2014/main" id="{FF4F0397-ACF0-435A-B37F-20EF1581B17A}"/>
+              </a:ext>
+            </a:extLst>
+          </p:cNvPr>
+          <p:cNvSpPr>
+            <a:spLocks xmlns:a="http://schemas.openxmlformats.org/drawingml/2006/main" noGrp="1"/>
+          </p:cNvSpPr>
+          <p:nvPr/>
+        </p:nvSpPr>
+        <p:spPr>
+          <a:xfrm xmlns:a="http://schemas.openxmlformats.org/drawingml/2006/main">
+            <a:off x="2190750" y="3333750"/>
+            <a:ext cx="876300" cy="323850"/>
           </a:xfrm>
           <a:prstGeom xmlns:a="http://schemas.openxmlformats.org/drawingml/2006/main" prst="rect">
             <a:avLst/>
@@ -11214,8 +11533,650 @@
           <a:lstStyle xmlns:a="http://schemas.openxmlformats.org/drawingml/2006/main"/>
           <a:p xmlns:a="http://schemas.openxmlformats.org/drawingml/2006/main">
             <a:pPr algn="l">
+              <a:defRPr sz="2100" b="1">
+                <a:solidFill>
+                  <a:srgbClr val="1F4E79"/>
+                </a:solidFill>
+                <a:latin typeface="Aptos"/>
+                <a:ea typeface="Aptos"/>
+                <a:cs typeface="Aptos"/>
+              </a:defRPr>
+            </a:pPr>
+            <a:r>
+              <a:rPr sz="2100" b="1">
+                <a:solidFill>
+                  <a:srgbClr val="1F4E79"/>
+                </a:solidFill>
+                <a:latin typeface="Aptos"/>
+                <a:ea typeface="Aptos"/>
+                <a:cs typeface="Aptos"/>
+              </a:rPr>
+              <a:t>0.642</a:t>
+            </a:r>
+          </a:p>
+        </p:txBody>
+      </p:sp>
+      <p:sp>
+        <p:nvSpPr>
+          <p:cNvPr id="15" name="">
+            <a:extLst xmlns:a="http://schemas.openxmlformats.org/drawingml/2006/main">
+              <a:ext uri="{FF2B5EF4-FFF2-40B4-BE49-F238E27FC236}">
+                <a16:creationId xmlns:a16="http://schemas.microsoft.com/office/drawing/2014/main" id="{507BAF93-0313-4E6B-B79F-91AE4F6C640A}"/>
+              </a:ext>
+            </a:extLst>
+          </p:cNvPr>
+          <p:cNvSpPr>
+            <a:spLocks xmlns:a="http://schemas.openxmlformats.org/drawingml/2006/main" noGrp="1"/>
+          </p:cNvSpPr>
+          <p:nvPr/>
+        </p:nvSpPr>
+        <p:spPr>
+          <a:xfrm xmlns:a="http://schemas.openxmlformats.org/drawingml/2006/main">
+            <a:off x="3390900" y="3124200"/>
+            <a:ext cx="1047750" cy="190500"/>
+          </a:xfrm>
+          <a:prstGeom xmlns:a="http://schemas.openxmlformats.org/drawingml/2006/main" prst="rect">
+            <a:avLst/>
+          </a:prstGeom>
+          <a:solidFill xmlns:a="http://schemas.openxmlformats.org/drawingml/2006/main">
+            <a:srgbClr val="000000">
+              <a:alpha val="0"/>
+            </a:srgbClr>
+          </a:solidFill>
+          <a:ln xmlns:a="http://schemas.openxmlformats.org/drawingml/2006/main" w="0">
+            <a:solidFill>
+              <a:srgbClr val="000000">
+                <a:alpha val="0"/>
+              </a:srgbClr>
+            </a:solidFill>
+            <a:prstDash val="solid"/>
+          </a:ln>
+        </p:spPr>
+        <p:txBody>
+          <a:bodyPr xmlns:a="http://schemas.openxmlformats.org/drawingml/2006/main" lIns="0" tIns="0" rIns="0" bIns="0" anchor="t"/>
+          <a:lstStyle xmlns:a="http://schemas.openxmlformats.org/drawingml/2006/main"/>
+          <a:p xmlns:a="http://schemas.openxmlformats.org/drawingml/2006/main">
+            <a:pPr algn="l">
+              <a:defRPr sz="1125" b="0">
+                <a:solidFill>
+                  <a:srgbClr val="718096"/>
+                </a:solidFill>
+                <a:latin typeface="Aptos"/>
+                <a:ea typeface="Aptos"/>
+                <a:cs typeface="Aptos"/>
+              </a:defRPr>
+            </a:pPr>
+            <a:r>
+              <a:rPr sz="1125" b="0">
+                <a:solidFill>
+                  <a:srgbClr val="718096"/>
+                </a:solidFill>
+                <a:latin typeface="Aptos"/>
+                <a:ea typeface="Aptos"/>
+                <a:cs typeface="Aptos"/>
+              </a:rPr>
+              <a:t>Précision</a:t>
+            </a:r>
+          </a:p>
+        </p:txBody>
+      </p:sp>
+      <p:sp>
+        <p:nvSpPr>
+          <p:cNvPr id="16" name="">
+            <a:extLst xmlns:a="http://schemas.openxmlformats.org/drawingml/2006/main">
+              <a:ext uri="{FF2B5EF4-FFF2-40B4-BE49-F238E27FC236}">
+                <a16:creationId xmlns:a16="http://schemas.microsoft.com/office/drawing/2014/main" id="{2EB3D117-CD83-420E-BFC7-9A49414FBD97}"/>
+              </a:ext>
+            </a:extLst>
+          </p:cNvPr>
+          <p:cNvSpPr>
+            <a:spLocks xmlns:a="http://schemas.openxmlformats.org/drawingml/2006/main" noGrp="1"/>
+          </p:cNvSpPr>
+          <p:nvPr/>
+        </p:nvSpPr>
+        <p:spPr>
+          <a:xfrm xmlns:a="http://schemas.openxmlformats.org/drawingml/2006/main">
+            <a:off x="3429000" y="3333750"/>
+            <a:ext cx="876300" cy="323850"/>
+          </a:xfrm>
+          <a:prstGeom xmlns:a="http://schemas.openxmlformats.org/drawingml/2006/main" prst="rect">
+            <a:avLst/>
+          </a:prstGeom>
+          <a:solidFill xmlns:a="http://schemas.openxmlformats.org/drawingml/2006/main">
+            <a:srgbClr val="000000">
+              <a:alpha val="0"/>
+            </a:srgbClr>
+          </a:solidFill>
+          <a:ln xmlns:a="http://schemas.openxmlformats.org/drawingml/2006/main" w="0">
+            <a:solidFill>
+              <a:srgbClr val="000000">
+                <a:alpha val="0"/>
+              </a:srgbClr>
+            </a:solidFill>
+            <a:prstDash val="solid"/>
+          </a:ln>
+        </p:spPr>
+        <p:txBody>
+          <a:bodyPr xmlns:a="http://schemas.openxmlformats.org/drawingml/2006/main" lIns="0" tIns="0" rIns="0" bIns="0" anchor="t"/>
+          <a:lstStyle xmlns:a="http://schemas.openxmlformats.org/drawingml/2006/main"/>
+          <a:p xmlns:a="http://schemas.openxmlformats.org/drawingml/2006/main">
+            <a:pPr algn="l">
+              <a:defRPr sz="2100" b="1">
+                <a:solidFill>
+                  <a:srgbClr val="1F4E79"/>
+                </a:solidFill>
+                <a:latin typeface="Aptos"/>
+                <a:ea typeface="Aptos"/>
+                <a:cs typeface="Aptos"/>
+              </a:defRPr>
+            </a:pPr>
+            <a:r>
+              <a:rPr sz="2100" b="1">
+                <a:solidFill>
+                  <a:srgbClr val="1F4E79"/>
+                </a:solidFill>
+                <a:latin typeface="Aptos"/>
+                <a:ea typeface="Aptos"/>
+                <a:cs typeface="Aptos"/>
+              </a:rPr>
+              <a:t>0.859</a:t>
+            </a:r>
+          </a:p>
+        </p:txBody>
+      </p:sp>
+      <p:sp>
+        <p:nvSpPr>
+          <p:cNvPr id="17" name="">
+            <a:extLst xmlns:a="http://schemas.openxmlformats.org/drawingml/2006/main">
+              <a:ext uri="{FF2B5EF4-FFF2-40B4-BE49-F238E27FC236}">
+                <a16:creationId xmlns:a16="http://schemas.microsoft.com/office/drawing/2014/main" id="{7D54BC8D-25AD-4FEA-9D10-FA17D74B104F}"/>
+              </a:ext>
+            </a:extLst>
+          </p:cNvPr>
+          <p:cNvSpPr>
+            <a:spLocks xmlns:a="http://schemas.openxmlformats.org/drawingml/2006/main" noGrp="1"/>
+          </p:cNvSpPr>
+          <p:nvPr/>
+        </p:nvSpPr>
+        <p:spPr>
+          <a:xfrm xmlns:a="http://schemas.openxmlformats.org/drawingml/2006/main">
+            <a:off x="4629150" y="3124200"/>
+            <a:ext cx="666750" cy="190500"/>
+          </a:xfrm>
+          <a:prstGeom xmlns:a="http://schemas.openxmlformats.org/drawingml/2006/main" prst="rect">
+            <a:avLst/>
+          </a:prstGeom>
+          <a:solidFill xmlns:a="http://schemas.openxmlformats.org/drawingml/2006/main">
+            <a:srgbClr val="000000">
+              <a:alpha val="0"/>
+            </a:srgbClr>
+          </a:solidFill>
+          <a:ln xmlns:a="http://schemas.openxmlformats.org/drawingml/2006/main" w="0">
+            <a:solidFill>
+              <a:srgbClr val="000000">
+                <a:alpha val="0"/>
+              </a:srgbClr>
+            </a:solidFill>
+            <a:prstDash val="solid"/>
+          </a:ln>
+        </p:spPr>
+        <p:txBody>
+          <a:bodyPr xmlns:a="http://schemas.openxmlformats.org/drawingml/2006/main" lIns="0" tIns="0" rIns="0" bIns="0" anchor="t"/>
+          <a:lstStyle xmlns:a="http://schemas.openxmlformats.org/drawingml/2006/main"/>
+          <a:p xmlns:a="http://schemas.openxmlformats.org/drawingml/2006/main">
+            <a:pPr algn="l">
+              <a:defRPr sz="1125" b="0">
+                <a:solidFill>
+                  <a:srgbClr val="718096"/>
+                </a:solidFill>
+                <a:latin typeface="Aptos"/>
+                <a:ea typeface="Aptos"/>
+                <a:cs typeface="Aptos"/>
+              </a:defRPr>
+            </a:pPr>
+            <a:r>
+              <a:rPr sz="1125" b="0">
+                <a:solidFill>
+                  <a:srgbClr val="718096"/>
+                </a:solidFill>
+                <a:latin typeface="Aptos"/>
+                <a:ea typeface="Aptos"/>
+                <a:cs typeface="Aptos"/>
+              </a:rPr>
+              <a:t>FA/min</a:t>
+            </a:r>
+          </a:p>
+        </p:txBody>
+      </p:sp>
+      <p:sp>
+        <p:nvSpPr>
+          <p:cNvPr id="18" name="">
+            <a:extLst xmlns:a="http://schemas.openxmlformats.org/drawingml/2006/main">
+              <a:ext uri="{FF2B5EF4-FFF2-40B4-BE49-F238E27FC236}">
+                <a16:creationId xmlns:a16="http://schemas.microsoft.com/office/drawing/2014/main" id="{84FE5B12-200D-4EBD-9CA4-300A632E05C9}"/>
+              </a:ext>
+            </a:extLst>
+          </p:cNvPr>
+          <p:cNvSpPr>
+            <a:spLocks xmlns:a="http://schemas.openxmlformats.org/drawingml/2006/main" noGrp="1"/>
+          </p:cNvSpPr>
+          <p:nvPr/>
+        </p:nvSpPr>
+        <p:spPr>
+          <a:xfrm xmlns:a="http://schemas.openxmlformats.org/drawingml/2006/main">
+            <a:off x="4629150" y="3333750"/>
+            <a:ext cx="876300" cy="323850"/>
+          </a:xfrm>
+          <a:prstGeom xmlns:a="http://schemas.openxmlformats.org/drawingml/2006/main" prst="rect">
+            <a:avLst/>
+          </a:prstGeom>
+          <a:solidFill xmlns:a="http://schemas.openxmlformats.org/drawingml/2006/main">
+            <a:srgbClr val="000000">
+              <a:alpha val="0"/>
+            </a:srgbClr>
+          </a:solidFill>
+          <a:ln xmlns:a="http://schemas.openxmlformats.org/drawingml/2006/main" w="0">
+            <a:solidFill>
+              <a:srgbClr val="000000">
+                <a:alpha val="0"/>
+              </a:srgbClr>
+            </a:solidFill>
+            <a:prstDash val="solid"/>
+          </a:ln>
+        </p:spPr>
+        <p:txBody>
+          <a:bodyPr xmlns:a="http://schemas.openxmlformats.org/drawingml/2006/main" lIns="0" tIns="0" rIns="0" bIns="0" anchor="t"/>
+          <a:lstStyle xmlns:a="http://schemas.openxmlformats.org/drawingml/2006/main"/>
+          <a:p xmlns:a="http://schemas.openxmlformats.org/drawingml/2006/main">
+            <a:pPr algn="l">
+              <a:defRPr sz="2100" b="1">
+                <a:solidFill>
+                  <a:srgbClr val="1F4E79"/>
+                </a:solidFill>
+                <a:latin typeface="Aptos"/>
+                <a:ea typeface="Aptos"/>
+                <a:cs typeface="Aptos"/>
+              </a:defRPr>
+            </a:pPr>
+            <a:r>
+              <a:rPr sz="2100" b="1">
+                <a:solidFill>
+                  <a:srgbClr val="1F4E79"/>
+                </a:solidFill>
+                <a:latin typeface="Aptos"/>
+                <a:ea typeface="Aptos"/>
+                <a:cs typeface="Aptos"/>
+              </a:rPr>
+              <a:t>1.574</a:t>
+            </a:r>
+          </a:p>
+        </p:txBody>
+      </p:sp>
+      <p:sp>
+        <p:nvSpPr>
+          <p:cNvPr id="19" name="">
+            <a:extLst xmlns:a="http://schemas.openxmlformats.org/drawingml/2006/main">
+              <a:ext uri="{FF2B5EF4-FFF2-40B4-BE49-F238E27FC236}">
+                <a16:creationId xmlns:a16="http://schemas.microsoft.com/office/drawing/2014/main" id="{DC6240F9-6CA9-44D2-B532-DCBE69FCCAB2}"/>
+              </a:ext>
+            </a:extLst>
+          </p:cNvPr>
+          <p:cNvSpPr>
+            <a:spLocks xmlns:a="http://schemas.openxmlformats.org/drawingml/2006/main" noGrp="1"/>
+          </p:cNvSpPr>
+          <p:nvPr/>
+        </p:nvSpPr>
+        <p:spPr>
+          <a:xfrm xmlns:a="http://schemas.openxmlformats.org/drawingml/2006/main">
+            <a:off x="876300" y="4000500"/>
+            <a:ext cx="4495800" cy="628650"/>
+          </a:xfrm>
+          <a:prstGeom xmlns:a="http://schemas.openxmlformats.org/drawingml/2006/main" prst="rect">
+            <a:avLst/>
+          </a:prstGeom>
+          <a:solidFill xmlns:a="http://schemas.openxmlformats.org/drawingml/2006/main">
+            <a:srgbClr val="000000">
+              <a:alpha val="0"/>
+            </a:srgbClr>
+          </a:solidFill>
+          <a:ln xmlns:a="http://schemas.openxmlformats.org/drawingml/2006/main" w="0">
+            <a:solidFill>
+              <a:srgbClr val="000000">
+                <a:alpha val="0"/>
+              </a:srgbClr>
+            </a:solidFill>
+            <a:prstDash val="solid"/>
+          </a:ln>
+        </p:spPr>
+        <p:txBody>
+          <a:bodyPr xmlns:a="http://schemas.openxmlformats.org/drawingml/2006/main" lIns="0" tIns="0" rIns="0" bIns="0" anchor="t"/>
+          <a:lstStyle xmlns:a="http://schemas.openxmlformats.org/drawingml/2006/main"/>
+          <a:p xmlns:a="http://schemas.openxmlformats.org/drawingml/2006/main">
+            <a:pPr algn="l">
+              <a:defRPr sz="1350" b="0">
+                <a:solidFill>
+                  <a:srgbClr val="17202A"/>
+                </a:solidFill>
+                <a:latin typeface="Aptos"/>
+                <a:ea typeface="Aptos"/>
+                <a:cs typeface="Aptos"/>
+              </a:defRPr>
+            </a:pPr>
+            <a:r>
+              <a:rPr sz="1350" b="0">
+                <a:solidFill>
+                  <a:srgbClr val="17202A"/>
+                </a:solidFill>
+                <a:latin typeface="Aptos"/>
+                <a:ea typeface="Aptos"/>
+                <a:cs typeface="Aptos"/>
+              </a:rPr>
+              <a:t>Seuil 0,35 plus agressif: Early 0,3 = 0.683, mais précision = 0.661 et FA/min = 6.015.</a:t>
+            </a:r>
+          </a:p>
+        </p:txBody>
+      </p:sp>
+      <p:sp>
+        <p:nvSpPr>
+          <p:cNvPr id="20" name="">
+            <a:extLst xmlns:a="http://schemas.openxmlformats.org/drawingml/2006/main">
+              <a:ext uri="{FF2B5EF4-FFF2-40B4-BE49-F238E27FC236}">
+                <a16:creationId xmlns:a16="http://schemas.microsoft.com/office/drawing/2014/main" id="{C0754914-8E32-4669-AD0F-6AB233E724A3}"/>
+              </a:ext>
+            </a:extLst>
+          </p:cNvPr>
+          <p:cNvSpPr>
+            <a:spLocks xmlns:a="http://schemas.openxmlformats.org/drawingml/2006/main" noGrp="1"/>
+          </p:cNvSpPr>
+          <p:nvPr/>
+        </p:nvSpPr>
+        <p:spPr>
+          <a:xfrm xmlns:a="http://schemas.openxmlformats.org/drawingml/2006/main">
+            <a:off x="876300" y="4762500"/>
+            <a:ext cx="4495800" cy="400050"/>
+          </a:xfrm>
+          <a:prstGeom xmlns:a="http://schemas.openxmlformats.org/drawingml/2006/main" prst="rect">
+            <a:avLst/>
+          </a:prstGeom>
+          <a:solidFill xmlns:a="http://schemas.openxmlformats.org/drawingml/2006/main">
+            <a:srgbClr val="EAF2F8"/>
+          </a:solidFill>
+          <a:ln xmlns:a="http://schemas.openxmlformats.org/drawingml/2006/main" w="9525">
+            <a:solidFill>
+              <a:srgbClr val="1F4E79"/>
+            </a:solidFill>
+            <a:prstDash val="solid"/>
+          </a:ln>
+        </p:spPr>
+      </p:sp>
+      <p:sp>
+        <p:nvSpPr>
+          <p:cNvPr id="21" name="">
+            <a:extLst xmlns:a="http://schemas.openxmlformats.org/drawingml/2006/main">
+              <a:ext uri="{FF2B5EF4-FFF2-40B4-BE49-F238E27FC236}">
+                <a16:creationId xmlns:a16="http://schemas.microsoft.com/office/drawing/2014/main" id="{42F8EE58-B6A1-4B71-8A16-06BDE531E1CD}"/>
+              </a:ext>
+            </a:extLst>
+          </p:cNvPr>
+          <p:cNvSpPr>
+            <a:spLocks xmlns:a="http://schemas.openxmlformats.org/drawingml/2006/main" noGrp="1"/>
+          </p:cNvSpPr>
+          <p:nvPr/>
+        </p:nvSpPr>
+        <p:spPr>
+          <a:xfrm xmlns:a="http://schemas.openxmlformats.org/drawingml/2006/main">
+            <a:off x="1047750" y="4895850"/>
+            <a:ext cx="4152900" cy="171450"/>
+          </a:xfrm>
+          <a:prstGeom xmlns:a="http://schemas.openxmlformats.org/drawingml/2006/main" prst="rect">
+            <a:avLst/>
+          </a:prstGeom>
+          <a:solidFill xmlns:a="http://schemas.openxmlformats.org/drawingml/2006/main">
+            <a:srgbClr val="000000">
+              <a:alpha val="0"/>
+            </a:srgbClr>
+          </a:solidFill>
+          <a:ln xmlns:a="http://schemas.openxmlformats.org/drawingml/2006/main" w="0">
+            <a:solidFill>
+              <a:srgbClr val="000000">
+                <a:alpha val="0"/>
+              </a:srgbClr>
+            </a:solidFill>
+            <a:prstDash val="solid"/>
+          </a:ln>
+        </p:spPr>
+        <p:txBody>
+          <a:bodyPr xmlns:a="http://schemas.openxmlformats.org/drawingml/2006/main" lIns="0" tIns="0" rIns="0" bIns="0" anchor="t"/>
+          <a:lstStyle xmlns:a="http://schemas.openxmlformats.org/drawingml/2006/main"/>
+          <a:p xmlns:a="http://schemas.openxmlformats.org/drawingml/2006/main">
+            <a:pPr algn="l">
+              <a:defRPr sz="1125" b="0">
+                <a:solidFill>
+                  <a:srgbClr val="17202A"/>
+                </a:solidFill>
+                <a:latin typeface="Aptos"/>
+                <a:ea typeface="Aptos"/>
+                <a:cs typeface="Aptos"/>
+              </a:defRPr>
+            </a:pPr>
+            <a:r>
+              <a:rPr sz="1125" b="0">
+                <a:solidFill>
+                  <a:srgbClr val="17202A"/>
+                </a:solidFill>
+                <a:latin typeface="Aptos"/>
+                <a:ea typeface="Aptos"/>
+                <a:cs typeface="Aptos"/>
+              </a:rPr>
+              <a:t>Pour l'alerte opérateur, le seuil 0,55 garde une avance utile à 0,2-0,3 s tout en limitant le bruit continu.</a:t>
+            </a:r>
+          </a:p>
+        </p:txBody>
+      </p:sp>
+      <p:sp>
+        <p:nvSpPr>
+          <p:cNvPr id="22" name="">
+            <a:extLst xmlns:a="http://schemas.openxmlformats.org/drawingml/2006/main">
+              <a:ext uri="{FF2B5EF4-FFF2-40B4-BE49-F238E27FC236}">
+                <a16:creationId xmlns:a16="http://schemas.microsoft.com/office/drawing/2014/main" id="{0EE23981-F9F5-417F-8E97-27C50F5F6F3F}"/>
+              </a:ext>
+            </a:extLst>
+          </p:cNvPr>
+          <p:cNvSpPr>
+            <a:spLocks xmlns:a="http://schemas.openxmlformats.org/drawingml/2006/main" noGrp="1"/>
+          </p:cNvSpPr>
+          <p:nvPr/>
+        </p:nvSpPr>
+        <p:spPr>
+          <a:xfrm xmlns:a="http://schemas.openxmlformats.org/drawingml/2006/main">
+            <a:off x="6286500" y="1695450"/>
+            <a:ext cx="5295900" cy="3638550"/>
+          </a:xfrm>
+          <a:prstGeom xmlns:a="http://schemas.openxmlformats.org/drawingml/2006/main" prst="rect">
+            <a:avLst/>
+          </a:prstGeom>
+          <a:solidFill xmlns:a="http://schemas.openxmlformats.org/drawingml/2006/main">
+            <a:srgbClr val="FFFFFF"/>
+          </a:solidFill>
+          <a:ln xmlns:a="http://schemas.openxmlformats.org/drawingml/2006/main" w="19050">
+            <a:solidFill>
+              <a:srgbClr val="B23A48"/>
+            </a:solidFill>
+            <a:prstDash val="solid"/>
+          </a:ln>
+        </p:spPr>
+      </p:sp>
+      <p:sp>
+        <p:nvSpPr>
+          <p:cNvPr id="23" name="">
+            <a:extLst xmlns:a="http://schemas.openxmlformats.org/drawingml/2006/main">
+              <a:ext uri="{FF2B5EF4-FFF2-40B4-BE49-F238E27FC236}">
+                <a16:creationId xmlns:a16="http://schemas.microsoft.com/office/drawing/2014/main" id="{2914D728-9B68-4239-A43D-192E3B0E6B9F}"/>
+              </a:ext>
+            </a:extLst>
+          </p:cNvPr>
+          <p:cNvSpPr>
+            <a:spLocks xmlns:a="http://schemas.openxmlformats.org/drawingml/2006/main" noGrp="1"/>
+          </p:cNvSpPr>
+          <p:nvPr/>
+        </p:nvSpPr>
+        <p:spPr>
+          <a:xfrm xmlns:a="http://schemas.openxmlformats.org/drawingml/2006/main">
+            <a:off x="6553200" y="1943100"/>
+            <a:ext cx="2857500" cy="323850"/>
+          </a:xfrm>
+          <a:prstGeom xmlns:a="http://schemas.openxmlformats.org/drawingml/2006/main" prst="rect">
+            <a:avLst/>
+          </a:prstGeom>
+          <a:solidFill xmlns:a="http://schemas.openxmlformats.org/drawingml/2006/main">
+            <a:srgbClr val="000000">
+              <a:alpha val="0"/>
+            </a:srgbClr>
+          </a:solidFill>
+          <a:ln xmlns:a="http://schemas.openxmlformats.org/drawingml/2006/main" w="0">
+            <a:solidFill>
+              <a:srgbClr val="000000">
+                <a:alpha val="0"/>
+              </a:srgbClr>
+            </a:solidFill>
+            <a:prstDash val="solid"/>
+          </a:ln>
+        </p:spPr>
+        <p:txBody>
+          <a:bodyPr xmlns:a="http://schemas.openxmlformats.org/drawingml/2006/main" lIns="0" tIns="0" rIns="0" bIns="0" anchor="t"/>
+          <a:lstStyle xmlns:a="http://schemas.openxmlformats.org/drawingml/2006/main"/>
+          <a:p xmlns:a="http://schemas.openxmlformats.org/drawingml/2006/main">
+            <a:pPr algn="l">
+              <a:defRPr sz="2100" b="1">
+                <a:solidFill>
+                  <a:srgbClr val="B23A48"/>
+                </a:solidFill>
+                <a:latin typeface="Aptos"/>
+                <a:ea typeface="Aptos"/>
+                <a:cs typeface="Aptos"/>
+              </a:defRPr>
+            </a:pPr>
+            <a:r>
+              <a:rPr sz="2100" b="1">
+                <a:solidFill>
+                  <a:srgbClr val="B23A48"/>
+                </a:solidFill>
+                <a:latin typeface="Aptos"/>
+                <a:ea typeface="Aptos"/>
+                <a:cs typeface="Aptos"/>
+              </a:rPr>
+              <a:t>Stop court horizon GRU</a:t>
+            </a:r>
+          </a:p>
+        </p:txBody>
+      </p:sp>
+      <p:sp>
+        <p:nvSpPr>
+          <p:cNvPr id="24" name="">
+            <a:extLst xmlns:a="http://schemas.openxmlformats.org/drawingml/2006/main">
+              <a:ext uri="{FF2B5EF4-FFF2-40B4-BE49-F238E27FC236}">
+                <a16:creationId xmlns:a16="http://schemas.microsoft.com/office/drawing/2014/main" id="{0605783C-B2B9-4037-A1DF-BFBC26BEF09A}"/>
+              </a:ext>
+            </a:extLst>
+          </p:cNvPr>
+          <p:cNvSpPr>
+            <a:spLocks xmlns:a="http://schemas.openxmlformats.org/drawingml/2006/main" noGrp="1"/>
+          </p:cNvSpPr>
+          <p:nvPr/>
+        </p:nvSpPr>
+        <p:spPr>
+          <a:xfrm xmlns:a="http://schemas.openxmlformats.org/drawingml/2006/main">
+            <a:off x="6553200" y="2324100"/>
+            <a:ext cx="2667000" cy="228600"/>
+          </a:xfrm>
+          <a:prstGeom xmlns:a="http://schemas.openxmlformats.org/drawingml/2006/main" prst="rect">
+            <a:avLst/>
+          </a:prstGeom>
+          <a:solidFill xmlns:a="http://schemas.openxmlformats.org/drawingml/2006/main">
+            <a:srgbClr val="000000">
+              <a:alpha val="0"/>
+            </a:srgbClr>
+          </a:solidFill>
+          <a:ln xmlns:a="http://schemas.openxmlformats.org/drawingml/2006/main" w="0">
+            <a:solidFill>
+              <a:srgbClr val="000000">
+                <a:alpha val="0"/>
+              </a:srgbClr>
+            </a:solidFill>
+            <a:prstDash val="solid"/>
+          </a:ln>
+        </p:spPr>
+        <p:txBody>
+          <a:bodyPr xmlns:a="http://schemas.openxmlformats.org/drawingml/2006/main" lIns="0" tIns="0" rIns="0" bIns="0" anchor="t"/>
+          <a:lstStyle xmlns:a="http://schemas.openxmlformats.org/drawingml/2006/main"/>
+          <a:p xmlns:a="http://schemas.openxmlformats.org/drawingml/2006/main">
+            <a:pPr algn="l">
               <a:defRPr sz="1200" b="0">
                 <a:solidFill>
+                  <a:srgbClr val="718096"/>
+                </a:solidFill>
+                <a:latin typeface="Aptos Mono"/>
+                <a:ea typeface="Aptos Mono"/>
+                <a:cs typeface="Aptos Mono"/>
+              </a:defRPr>
+            </a:pPr>
+            <a:r>
+              <a:rPr sz="1200" b="0">
+                <a:solidFill>
+                  <a:srgbClr val="718096"/>
+                </a:solidFill>
+                <a:latin typeface="Aptos Mono"/>
+                <a:ea typeface="Aptos Mono"/>
+                <a:cs typeface="Aptos Mono"/>
+              </a:rPr>
+              <a:t>Score: score_by_02</a:t>
+            </a:r>
+          </a:p>
+        </p:txBody>
+      </p:sp>
+      <p:sp>
+        <p:nvSpPr>
+          <p:cNvPr id="25" name="">
+            <a:extLst xmlns:a="http://schemas.openxmlformats.org/drawingml/2006/main">
+              <a:ext uri="{FF2B5EF4-FFF2-40B4-BE49-F238E27FC236}">
+                <a16:creationId xmlns:a16="http://schemas.microsoft.com/office/drawing/2014/main" id="{3B6C6E9C-A1DB-4701-BC21-48C4D6FB9CDF}"/>
+              </a:ext>
+            </a:extLst>
+          </p:cNvPr>
+          <p:cNvSpPr>
+            <a:spLocks xmlns:a="http://schemas.openxmlformats.org/drawingml/2006/main" noGrp="1"/>
+          </p:cNvSpPr>
+          <p:nvPr/>
+        </p:nvSpPr>
+        <p:spPr>
+          <a:xfrm xmlns:a="http://schemas.openxmlformats.org/drawingml/2006/main">
+            <a:off x="6553200" y="2781300"/>
+            <a:ext cx="1524000" cy="228600"/>
+          </a:xfrm>
+          <a:prstGeom xmlns:a="http://schemas.openxmlformats.org/drawingml/2006/main" prst="rect">
+            <a:avLst/>
+          </a:prstGeom>
+          <a:solidFill xmlns:a="http://schemas.openxmlformats.org/drawingml/2006/main">
+            <a:srgbClr val="000000">
+              <a:alpha val="0"/>
+            </a:srgbClr>
+          </a:solidFill>
+          <a:ln xmlns:a="http://schemas.openxmlformats.org/drawingml/2006/main" w="0">
+            <a:solidFill>
+              <a:srgbClr val="000000">
+                <a:alpha val="0"/>
+              </a:srgbClr>
+            </a:solidFill>
+            <a:prstDash val="solid"/>
+          </a:ln>
+        </p:spPr>
+        <p:txBody>
+          <a:bodyPr xmlns:a="http://schemas.openxmlformats.org/drawingml/2006/main" lIns="0" tIns="0" rIns="0" bIns="0" anchor="t"/>
+          <a:lstStyle xmlns:a="http://schemas.openxmlformats.org/drawingml/2006/main"/>
+          <a:p xmlns:a="http://schemas.openxmlformats.org/drawingml/2006/main">
+            <a:pPr algn="l">
+              <a:defRPr sz="1350" b="1">
+                <a:solidFill>
                   <a:srgbClr val="17202A"/>
                 </a:solidFill>
                 <a:latin typeface="Aptos"/>
@@ -11224,7 +12185,7 @@
               </a:defRPr>
             </a:pPr>
             <a:r>
-              <a:rPr sz="1200" b="0">
+              <a:rPr sz="1350" b="1">
                 <a:solidFill>
                   <a:srgbClr val="17202A"/>
                 </a:solidFill>
@@ -11232,7 +12193,552 @@
                 <a:ea typeface="Aptos"/>
                 <a:cs typeface="Aptos"/>
               </a:rPr>
-              <a:t>Phrase clé: l'alerte peut être plus précoce et plus bruitée; l'arrêt automatique doit être plus strict et proche de l'entrée physique.</a:t>
+              <a:t>Seuil 0,95 strict</a:t>
+            </a:r>
+          </a:p>
+        </p:txBody>
+      </p:sp>
+      <p:sp>
+        <p:nvSpPr>
+          <p:cNvPr id="26" name="">
+            <a:extLst xmlns:a="http://schemas.openxmlformats.org/drawingml/2006/main">
+              <a:ext uri="{FF2B5EF4-FFF2-40B4-BE49-F238E27FC236}">
+                <a16:creationId xmlns:a16="http://schemas.microsoft.com/office/drawing/2014/main" id="{B99C349A-49E9-4BC4-B0AE-CF6989D0D61A}"/>
+              </a:ext>
+            </a:extLst>
+          </p:cNvPr>
+          <p:cNvSpPr>
+            <a:spLocks xmlns:a="http://schemas.openxmlformats.org/drawingml/2006/main" noGrp="1"/>
+          </p:cNvSpPr>
+          <p:nvPr/>
+        </p:nvSpPr>
+        <p:spPr>
+          <a:xfrm xmlns:a="http://schemas.openxmlformats.org/drawingml/2006/main">
+            <a:off x="6553200" y="3124200"/>
+            <a:ext cx="1047750" cy="190500"/>
+          </a:xfrm>
+          <a:prstGeom xmlns:a="http://schemas.openxmlformats.org/drawingml/2006/main" prst="rect">
+            <a:avLst/>
+          </a:prstGeom>
+          <a:solidFill xmlns:a="http://schemas.openxmlformats.org/drawingml/2006/main">
+            <a:srgbClr val="000000">
+              <a:alpha val="0"/>
+            </a:srgbClr>
+          </a:solidFill>
+          <a:ln xmlns:a="http://schemas.openxmlformats.org/drawingml/2006/main" w="0">
+            <a:solidFill>
+              <a:srgbClr val="000000">
+                <a:alpha val="0"/>
+              </a:srgbClr>
+            </a:solidFill>
+            <a:prstDash val="solid"/>
+          </a:ln>
+        </p:spPr>
+        <p:txBody>
+          <a:bodyPr xmlns:a="http://schemas.openxmlformats.org/drawingml/2006/main" lIns="0" tIns="0" rIns="0" bIns="0" anchor="t"/>
+          <a:lstStyle xmlns:a="http://schemas.openxmlformats.org/drawingml/2006/main"/>
+          <a:p xmlns:a="http://schemas.openxmlformats.org/drawingml/2006/main">
+            <a:pPr algn="l">
+              <a:defRPr sz="1125" b="0">
+                <a:solidFill>
+                  <a:srgbClr val="718096"/>
+                </a:solidFill>
+                <a:latin typeface="Aptos"/>
+                <a:ea typeface="Aptos"/>
+                <a:cs typeface="Aptos"/>
+              </a:defRPr>
+            </a:pPr>
+            <a:r>
+              <a:rPr sz="1125" b="0">
+                <a:solidFill>
+                  <a:srgbClr val="718096"/>
+                </a:solidFill>
+                <a:latin typeface="Aptos"/>
+                <a:ea typeface="Aptos"/>
+                <a:cs typeface="Aptos"/>
+              </a:rPr>
+              <a:t>P(&lt;=0,2 s)</a:t>
+            </a:r>
+          </a:p>
+        </p:txBody>
+      </p:sp>
+      <p:sp>
+        <p:nvSpPr>
+          <p:cNvPr id="27" name="">
+            <a:extLst xmlns:a="http://schemas.openxmlformats.org/drawingml/2006/main">
+              <a:ext uri="{FF2B5EF4-FFF2-40B4-BE49-F238E27FC236}">
+                <a16:creationId xmlns:a16="http://schemas.microsoft.com/office/drawing/2014/main" id="{204FEEA1-BBA6-4600-8681-7371497093E3}"/>
+              </a:ext>
+            </a:extLst>
+          </p:cNvPr>
+          <p:cNvSpPr>
+            <a:spLocks xmlns:a="http://schemas.openxmlformats.org/drawingml/2006/main" noGrp="1"/>
+          </p:cNvSpPr>
+          <p:nvPr/>
+        </p:nvSpPr>
+        <p:spPr>
+          <a:xfrm xmlns:a="http://schemas.openxmlformats.org/drawingml/2006/main">
+            <a:off x="6591300" y="3333750"/>
+            <a:ext cx="876300" cy="323850"/>
+          </a:xfrm>
+          <a:prstGeom xmlns:a="http://schemas.openxmlformats.org/drawingml/2006/main" prst="rect">
+            <a:avLst/>
+          </a:prstGeom>
+          <a:solidFill xmlns:a="http://schemas.openxmlformats.org/drawingml/2006/main">
+            <a:srgbClr val="000000">
+              <a:alpha val="0"/>
+            </a:srgbClr>
+          </a:solidFill>
+          <a:ln xmlns:a="http://schemas.openxmlformats.org/drawingml/2006/main" w="0">
+            <a:solidFill>
+              <a:srgbClr val="000000">
+                <a:alpha val="0"/>
+              </a:srgbClr>
+            </a:solidFill>
+            <a:prstDash val="solid"/>
+          </a:ln>
+        </p:spPr>
+        <p:txBody>
+          <a:bodyPr xmlns:a="http://schemas.openxmlformats.org/drawingml/2006/main" lIns="0" tIns="0" rIns="0" bIns="0" anchor="t"/>
+          <a:lstStyle xmlns:a="http://schemas.openxmlformats.org/drawingml/2006/main"/>
+          <a:p xmlns:a="http://schemas.openxmlformats.org/drawingml/2006/main">
+            <a:pPr algn="l">
+              <a:defRPr sz="2100" b="1">
+                <a:solidFill>
+                  <a:srgbClr val="B23A48"/>
+                </a:solidFill>
+                <a:latin typeface="Aptos"/>
+                <a:ea typeface="Aptos"/>
+                <a:cs typeface="Aptos"/>
+              </a:defRPr>
+            </a:pPr>
+            <a:r>
+              <a:rPr sz="2100" b="1">
+                <a:solidFill>
+                  <a:srgbClr val="B23A48"/>
+                </a:solidFill>
+                <a:latin typeface="Aptos"/>
+                <a:ea typeface="Aptos"/>
+                <a:cs typeface="Aptos"/>
+              </a:rPr>
+              <a:t>0.708</a:t>
+            </a:r>
+          </a:p>
+        </p:txBody>
+      </p:sp>
+      <p:sp>
+        <p:nvSpPr>
+          <p:cNvPr id="28" name="">
+            <a:extLst xmlns:a="http://schemas.openxmlformats.org/drawingml/2006/main">
+              <a:ext uri="{FF2B5EF4-FFF2-40B4-BE49-F238E27FC236}">
+                <a16:creationId xmlns:a16="http://schemas.microsoft.com/office/drawing/2014/main" id="{1FEAEF99-AED4-465B-AE7B-CDB9B01208E1}"/>
+              </a:ext>
+            </a:extLst>
+          </p:cNvPr>
+          <p:cNvSpPr>
+            <a:spLocks xmlns:a="http://schemas.openxmlformats.org/drawingml/2006/main" noGrp="1"/>
+          </p:cNvSpPr>
+          <p:nvPr/>
+        </p:nvSpPr>
+        <p:spPr>
+          <a:xfrm xmlns:a="http://schemas.openxmlformats.org/drawingml/2006/main">
+            <a:off x="7810500" y="3124200"/>
+            <a:ext cx="1047750" cy="190500"/>
+          </a:xfrm>
+          <a:prstGeom xmlns:a="http://schemas.openxmlformats.org/drawingml/2006/main" prst="rect">
+            <a:avLst/>
+          </a:prstGeom>
+          <a:solidFill xmlns:a="http://schemas.openxmlformats.org/drawingml/2006/main">
+            <a:srgbClr val="000000">
+              <a:alpha val="0"/>
+            </a:srgbClr>
+          </a:solidFill>
+          <a:ln xmlns:a="http://schemas.openxmlformats.org/drawingml/2006/main" w="0">
+            <a:solidFill>
+              <a:srgbClr val="000000">
+                <a:alpha val="0"/>
+              </a:srgbClr>
+            </a:solidFill>
+            <a:prstDash val="solid"/>
+          </a:ln>
+        </p:spPr>
+        <p:txBody>
+          <a:bodyPr xmlns:a="http://schemas.openxmlformats.org/drawingml/2006/main" lIns="0" tIns="0" rIns="0" bIns="0" anchor="t"/>
+          <a:lstStyle xmlns:a="http://schemas.openxmlformats.org/drawingml/2006/main"/>
+          <a:p xmlns:a="http://schemas.openxmlformats.org/drawingml/2006/main">
+            <a:pPr algn="l">
+              <a:defRPr sz="1125" b="0">
+                <a:solidFill>
+                  <a:srgbClr val="718096"/>
+                </a:solidFill>
+                <a:latin typeface="Aptos"/>
+                <a:ea typeface="Aptos"/>
+                <a:cs typeface="Aptos"/>
+              </a:defRPr>
+            </a:pPr>
+            <a:r>
+              <a:rPr sz="1125" b="0">
+                <a:solidFill>
+                  <a:srgbClr val="718096"/>
+                </a:solidFill>
+                <a:latin typeface="Aptos"/>
+                <a:ea typeface="Aptos"/>
+                <a:cs typeface="Aptos"/>
+              </a:rPr>
+              <a:t>P(&lt;=0,3 s)</a:t>
+            </a:r>
+          </a:p>
+        </p:txBody>
+      </p:sp>
+      <p:sp>
+        <p:nvSpPr>
+          <p:cNvPr id="29" name="">
+            <a:extLst xmlns:a="http://schemas.openxmlformats.org/drawingml/2006/main">
+              <a:ext uri="{FF2B5EF4-FFF2-40B4-BE49-F238E27FC236}">
+                <a16:creationId xmlns:a16="http://schemas.microsoft.com/office/drawing/2014/main" id="{9A63CFD6-EFE4-4F3A-9B84-77FFE1C414B2}"/>
+              </a:ext>
+            </a:extLst>
+          </p:cNvPr>
+          <p:cNvSpPr>
+            <a:spLocks xmlns:a="http://schemas.openxmlformats.org/drawingml/2006/main" noGrp="1"/>
+          </p:cNvSpPr>
+          <p:nvPr/>
+        </p:nvSpPr>
+        <p:spPr>
+          <a:xfrm xmlns:a="http://schemas.openxmlformats.org/drawingml/2006/main">
+            <a:off x="7848600" y="3333750"/>
+            <a:ext cx="876300" cy="323850"/>
+          </a:xfrm>
+          <a:prstGeom xmlns:a="http://schemas.openxmlformats.org/drawingml/2006/main" prst="rect">
+            <a:avLst/>
+          </a:prstGeom>
+          <a:solidFill xmlns:a="http://schemas.openxmlformats.org/drawingml/2006/main">
+            <a:srgbClr val="000000">
+              <a:alpha val="0"/>
+            </a:srgbClr>
+          </a:solidFill>
+          <a:ln xmlns:a="http://schemas.openxmlformats.org/drawingml/2006/main" w="0">
+            <a:solidFill>
+              <a:srgbClr val="000000">
+                <a:alpha val="0"/>
+              </a:srgbClr>
+            </a:solidFill>
+            <a:prstDash val="solid"/>
+          </a:ln>
+        </p:spPr>
+        <p:txBody>
+          <a:bodyPr xmlns:a="http://schemas.openxmlformats.org/drawingml/2006/main" lIns="0" tIns="0" rIns="0" bIns="0" anchor="t"/>
+          <a:lstStyle xmlns:a="http://schemas.openxmlformats.org/drawingml/2006/main"/>
+          <a:p xmlns:a="http://schemas.openxmlformats.org/drawingml/2006/main">
+            <a:pPr algn="l">
+              <a:defRPr sz="2100" b="1">
+                <a:solidFill>
+                  <a:srgbClr val="B23A48"/>
+                </a:solidFill>
+                <a:latin typeface="Aptos"/>
+                <a:ea typeface="Aptos"/>
+                <a:cs typeface="Aptos"/>
+              </a:defRPr>
+            </a:pPr>
+            <a:r>
+              <a:rPr sz="2100" b="1">
+                <a:solidFill>
+                  <a:srgbClr val="B23A48"/>
+                </a:solidFill>
+                <a:latin typeface="Aptos"/>
+                <a:ea typeface="Aptos"/>
+                <a:cs typeface="Aptos"/>
+              </a:rPr>
+              <a:t>0.903</a:t>
+            </a:r>
+          </a:p>
+        </p:txBody>
+      </p:sp>
+      <p:sp>
+        <p:nvSpPr>
+          <p:cNvPr id="30" name="">
+            <a:extLst xmlns:a="http://schemas.openxmlformats.org/drawingml/2006/main">
+              <a:ext uri="{FF2B5EF4-FFF2-40B4-BE49-F238E27FC236}">
+                <a16:creationId xmlns:a16="http://schemas.microsoft.com/office/drawing/2014/main" id="{694E1662-B366-416C-8404-CC35435F2296}"/>
+              </a:ext>
+            </a:extLst>
+          </p:cNvPr>
+          <p:cNvSpPr>
+            <a:spLocks xmlns:a="http://schemas.openxmlformats.org/drawingml/2006/main" noGrp="1"/>
+          </p:cNvSpPr>
+          <p:nvPr/>
+        </p:nvSpPr>
+        <p:spPr>
+          <a:xfrm xmlns:a="http://schemas.openxmlformats.org/drawingml/2006/main">
+            <a:off x="9067800" y="3124200"/>
+            <a:ext cx="1047750" cy="190500"/>
+          </a:xfrm>
+          <a:prstGeom xmlns:a="http://schemas.openxmlformats.org/drawingml/2006/main" prst="rect">
+            <a:avLst/>
+          </a:prstGeom>
+          <a:solidFill xmlns:a="http://schemas.openxmlformats.org/drawingml/2006/main">
+            <a:srgbClr val="000000">
+              <a:alpha val="0"/>
+            </a:srgbClr>
+          </a:solidFill>
+          <a:ln xmlns:a="http://schemas.openxmlformats.org/drawingml/2006/main" w="0">
+            <a:solidFill>
+              <a:srgbClr val="000000">
+                <a:alpha val="0"/>
+              </a:srgbClr>
+            </a:solidFill>
+            <a:prstDash val="solid"/>
+          </a:ln>
+        </p:spPr>
+        <p:txBody>
+          <a:bodyPr xmlns:a="http://schemas.openxmlformats.org/drawingml/2006/main" lIns="0" tIns="0" rIns="0" bIns="0" anchor="t"/>
+          <a:lstStyle xmlns:a="http://schemas.openxmlformats.org/drawingml/2006/main"/>
+          <a:p xmlns:a="http://schemas.openxmlformats.org/drawingml/2006/main">
+            <a:pPr algn="l">
+              <a:defRPr sz="1125" b="0">
+                <a:solidFill>
+                  <a:srgbClr val="718096"/>
+                </a:solidFill>
+                <a:latin typeface="Aptos"/>
+                <a:ea typeface="Aptos"/>
+                <a:cs typeface="Aptos"/>
+              </a:defRPr>
+            </a:pPr>
+            <a:r>
+              <a:rPr sz="1125" b="0">
+                <a:solidFill>
+                  <a:srgbClr val="718096"/>
+                </a:solidFill>
+                <a:latin typeface="Aptos"/>
+                <a:ea typeface="Aptos"/>
+                <a:cs typeface="Aptos"/>
+              </a:rPr>
+              <a:t>Temps moyen</a:t>
+            </a:r>
+          </a:p>
+        </p:txBody>
+      </p:sp>
+      <p:sp>
+        <p:nvSpPr>
+          <p:cNvPr id="31" name="">
+            <a:extLst xmlns:a="http://schemas.openxmlformats.org/drawingml/2006/main">
+              <a:ext uri="{FF2B5EF4-FFF2-40B4-BE49-F238E27FC236}">
+                <a16:creationId xmlns:a16="http://schemas.microsoft.com/office/drawing/2014/main" id="{75668D43-4596-4E28-859E-1563710BE6DF}"/>
+              </a:ext>
+            </a:extLst>
+          </p:cNvPr>
+          <p:cNvSpPr>
+            <a:spLocks xmlns:a="http://schemas.openxmlformats.org/drawingml/2006/main" noGrp="1"/>
+          </p:cNvSpPr>
+          <p:nvPr/>
+        </p:nvSpPr>
+        <p:spPr>
+          <a:xfrm xmlns:a="http://schemas.openxmlformats.org/drawingml/2006/main">
+            <a:off x="9067800" y="3333750"/>
+            <a:ext cx="1047750" cy="323850"/>
+          </a:xfrm>
+          <a:prstGeom xmlns:a="http://schemas.openxmlformats.org/drawingml/2006/main" prst="rect">
+            <a:avLst/>
+          </a:prstGeom>
+          <a:solidFill xmlns:a="http://schemas.openxmlformats.org/drawingml/2006/main">
+            <a:srgbClr val="000000">
+              <a:alpha val="0"/>
+            </a:srgbClr>
+          </a:solidFill>
+          <a:ln xmlns:a="http://schemas.openxmlformats.org/drawingml/2006/main" w="0">
+            <a:solidFill>
+              <a:srgbClr val="000000">
+                <a:alpha val="0"/>
+              </a:srgbClr>
+            </a:solidFill>
+            <a:prstDash val="solid"/>
+          </a:ln>
+        </p:spPr>
+        <p:txBody>
+          <a:bodyPr xmlns:a="http://schemas.openxmlformats.org/drawingml/2006/main" lIns="0" tIns="0" rIns="0" bIns="0" anchor="t"/>
+          <a:lstStyle xmlns:a="http://schemas.openxmlformats.org/drawingml/2006/main"/>
+          <a:p xmlns:a="http://schemas.openxmlformats.org/drawingml/2006/main">
+            <a:pPr algn="l">
+              <a:defRPr sz="2100" b="1">
+                <a:solidFill>
+                  <a:srgbClr val="B23A48"/>
+                </a:solidFill>
+                <a:latin typeface="Aptos"/>
+                <a:ea typeface="Aptos"/>
+                <a:cs typeface="Aptos"/>
+              </a:defRPr>
+            </a:pPr>
+            <a:r>
+              <a:rPr sz="2100" b="1">
+                <a:solidFill>
+                  <a:srgbClr val="B23A48"/>
+                </a:solidFill>
+                <a:latin typeface="Aptos"/>
+                <a:ea typeface="Aptos"/>
+                <a:cs typeface="Aptos"/>
+              </a:rPr>
+              <a:t>0.133 s</a:t>
+            </a:r>
+          </a:p>
+        </p:txBody>
+      </p:sp>
+      <p:sp>
+        <p:nvSpPr>
+          <p:cNvPr id="32" name="">
+            <a:extLst xmlns:a="http://schemas.openxmlformats.org/drawingml/2006/main">
+              <a:ext uri="{FF2B5EF4-FFF2-40B4-BE49-F238E27FC236}">
+                <a16:creationId xmlns:a16="http://schemas.microsoft.com/office/drawing/2014/main" id="{2D8A2894-C538-4839-A206-58564D8EF63B}"/>
+              </a:ext>
+            </a:extLst>
+          </p:cNvPr>
+          <p:cNvSpPr>
+            <a:spLocks xmlns:a="http://schemas.openxmlformats.org/drawingml/2006/main" noGrp="1"/>
+          </p:cNvSpPr>
+          <p:nvPr/>
+        </p:nvSpPr>
+        <p:spPr>
+          <a:xfrm xmlns:a="http://schemas.openxmlformats.org/drawingml/2006/main">
+            <a:off x="6553200" y="4000500"/>
+            <a:ext cx="4648200" cy="628650"/>
+          </a:xfrm>
+          <a:prstGeom xmlns:a="http://schemas.openxmlformats.org/drawingml/2006/main" prst="rect">
+            <a:avLst/>
+          </a:prstGeom>
+          <a:solidFill xmlns:a="http://schemas.openxmlformats.org/drawingml/2006/main">
+            <a:srgbClr val="000000">
+              <a:alpha val="0"/>
+            </a:srgbClr>
+          </a:solidFill>
+          <a:ln xmlns:a="http://schemas.openxmlformats.org/drawingml/2006/main" w="0">
+            <a:solidFill>
+              <a:srgbClr val="000000">
+                <a:alpha val="0"/>
+              </a:srgbClr>
+            </a:solidFill>
+            <a:prstDash val="solid"/>
+          </a:ln>
+        </p:spPr>
+        <p:txBody>
+          <a:bodyPr xmlns:a="http://schemas.openxmlformats.org/drawingml/2006/main" lIns="0" tIns="0" rIns="0" bIns="0" anchor="t"/>
+          <a:lstStyle xmlns:a="http://schemas.openxmlformats.org/drawingml/2006/main"/>
+          <a:p xmlns:a="http://schemas.openxmlformats.org/drawingml/2006/main">
+            <a:pPr algn="l">
+              <a:defRPr sz="1350" b="0">
+                <a:solidFill>
+                  <a:srgbClr val="17202A"/>
+                </a:solidFill>
+                <a:latin typeface="Aptos"/>
+                <a:ea typeface="Aptos"/>
+                <a:cs typeface="Aptos"/>
+              </a:defRPr>
+            </a:pPr>
+            <a:r>
+              <a:rPr sz="1350" b="0">
+                <a:solidFill>
+                  <a:srgbClr val="17202A"/>
+                </a:solidFill>
+                <a:latin typeface="Aptos"/>
+                <a:ea typeface="Aptos"/>
+                <a:cs typeface="Aptos"/>
+              </a:rPr>
+              <a:t>Seuil 0,90 plus couvrant: P(&lt;=0,2 s) = 0.502, P(&lt;=0,3 s) = 0.741, temps moyen = 0.221 s.</a:t>
+            </a:r>
+          </a:p>
+        </p:txBody>
+      </p:sp>
+      <p:sp>
+        <p:nvSpPr>
+          <p:cNvPr id="33" name="">
+            <a:extLst xmlns:a="http://schemas.openxmlformats.org/drawingml/2006/main">
+              <a:ext uri="{FF2B5EF4-FFF2-40B4-BE49-F238E27FC236}">
+                <a16:creationId xmlns:a16="http://schemas.microsoft.com/office/drawing/2014/main" id="{ADA4B244-EC1B-4BD0-A845-2F00E26F81B8}"/>
+              </a:ext>
+            </a:extLst>
+          </p:cNvPr>
+          <p:cNvSpPr>
+            <a:spLocks xmlns:a="http://schemas.openxmlformats.org/drawingml/2006/main" noGrp="1"/>
+          </p:cNvSpPr>
+          <p:nvPr/>
+        </p:nvSpPr>
+        <p:spPr>
+          <a:xfrm xmlns:a="http://schemas.openxmlformats.org/drawingml/2006/main">
+            <a:off x="6553200" y="4762500"/>
+            <a:ext cx="4648200" cy="400050"/>
+          </a:xfrm>
+          <a:prstGeom xmlns:a="http://schemas.openxmlformats.org/drawingml/2006/main" prst="rect">
+            <a:avLst/>
+          </a:prstGeom>
+          <a:solidFill xmlns:a="http://schemas.openxmlformats.org/drawingml/2006/main">
+            <a:srgbClr val="F8E7EA"/>
+          </a:solidFill>
+          <a:ln xmlns:a="http://schemas.openxmlformats.org/drawingml/2006/main" w="9525">
+            <a:solidFill>
+              <a:srgbClr val="B23A48"/>
+            </a:solidFill>
+            <a:prstDash val="solid"/>
+          </a:ln>
+        </p:spPr>
+      </p:sp>
+      <p:sp>
+        <p:nvSpPr>
+          <p:cNvPr id="34" name="">
+            <a:extLst xmlns:a="http://schemas.openxmlformats.org/drawingml/2006/main">
+              <a:ext uri="{FF2B5EF4-FFF2-40B4-BE49-F238E27FC236}">
+                <a16:creationId xmlns:a16="http://schemas.microsoft.com/office/drawing/2014/main" id="{F675BC0D-DD84-422D-9052-9E38971EB281}"/>
+              </a:ext>
+            </a:extLst>
+          </p:cNvPr>
+          <p:cNvSpPr>
+            <a:spLocks xmlns:a="http://schemas.openxmlformats.org/drawingml/2006/main" noGrp="1"/>
+          </p:cNvSpPr>
+          <p:nvPr/>
+        </p:nvSpPr>
+        <p:spPr>
+          <a:xfrm xmlns:a="http://schemas.openxmlformats.org/drawingml/2006/main">
+            <a:off x="6724650" y="4895850"/>
+            <a:ext cx="4305300" cy="171450"/>
+          </a:xfrm>
+          <a:prstGeom xmlns:a="http://schemas.openxmlformats.org/drawingml/2006/main" prst="rect">
+            <a:avLst/>
+          </a:prstGeom>
+          <a:solidFill xmlns:a="http://schemas.openxmlformats.org/drawingml/2006/main">
+            <a:srgbClr val="000000">
+              <a:alpha val="0"/>
+            </a:srgbClr>
+          </a:solidFill>
+          <a:ln xmlns:a="http://schemas.openxmlformats.org/drawingml/2006/main" w="0">
+            <a:solidFill>
+              <a:srgbClr val="000000">
+                <a:alpha val="0"/>
+              </a:srgbClr>
+            </a:solidFill>
+            <a:prstDash val="solid"/>
+          </a:ln>
+        </p:spPr>
+        <p:txBody>
+          <a:bodyPr xmlns:a="http://schemas.openxmlformats.org/drawingml/2006/main" lIns="0" tIns="0" rIns="0" bIns="0" anchor="t"/>
+          <a:lstStyle xmlns:a="http://schemas.openxmlformats.org/drawingml/2006/main"/>
+          <a:p xmlns:a="http://schemas.openxmlformats.org/drawingml/2006/main">
+            <a:pPr algn="l">
+              <a:defRPr sz="1125" b="0">
+                <a:solidFill>
+                  <a:srgbClr val="17202A"/>
+                </a:solidFill>
+                <a:latin typeface="Aptos"/>
+                <a:ea typeface="Aptos"/>
+                <a:cs typeface="Aptos"/>
+              </a:defRPr>
+            </a:pPr>
+            <a:r>
+              <a:rPr sz="1125" b="0">
+                <a:solidFill>
+                  <a:srgbClr val="17202A"/>
+                </a:solidFill>
+                <a:latin typeface="Aptos"/>
+                <a:ea typeface="Aptos"/>
+                <a:cs typeface="Aptos"/>
+              </a:rPr>
+              <a:t>Pour le stop, le seuil 0,95 reste le point le plus crédible quand l'on veut agir seulement à l'approche immédiate de l'entrée.</a:t>
             </a:r>
           </a:p>
         </p:txBody>
@@ -11240,7 +12746,7 @@
     </p:spTree>
     <p:extLst>
       <p:ext uri="{BB962C8B-B14F-4D97-AF65-F5344CB8AC3E}">
-        <p14:creationId xmlns:p14="http://schemas.microsoft.com/office/powerpoint/2010/main" val="145951776"/>
+        <p14:creationId xmlns:p14="http://schemas.microsoft.com/office/powerpoint/2010/main" val="1033305989"/>
       </p:ext>
     </p:extLst>
   </p:cSld>
@@ -11264,7 +12770,7 @@
           <p:cNvPr id="1" name="">
             <a:extLst xmlns:a="http://schemas.openxmlformats.org/drawingml/2006/main">
               <a:ext uri="{FF2B5EF4-FFF2-40B4-BE49-F238E27FC236}">
-                <a16:creationId xmlns:a16="http://schemas.microsoft.com/office/drawing/2014/main" id="{F62567EF-5C57-4380-B546-CD0B99BB420B}"/>
+                <a16:creationId xmlns:a16="http://schemas.microsoft.com/office/drawing/2014/main" id="{02BD5157-21C7-47A4-9C7F-6676680F559D}"/>
               </a:ext>
             </a:extLst>
           </p:cNvPr>
@@ -11299,7 +12805,7 @@
           <p:cNvPr id="2" name="">
             <a:extLst xmlns:a="http://schemas.openxmlformats.org/drawingml/2006/main">
               <a:ext uri="{FF2B5EF4-FFF2-40B4-BE49-F238E27FC236}">
-                <a16:creationId xmlns:a16="http://schemas.microsoft.com/office/drawing/2014/main" id="{271489DF-D382-4E34-8ABC-60AE7AA1D0D7}"/>
+                <a16:creationId xmlns:a16="http://schemas.microsoft.com/office/drawing/2014/main" id="{963935A2-954B-4D46-B4A4-7E1C613C0772}"/>
               </a:ext>
             </a:extLst>
           </p:cNvPr>
@@ -11353,7 +12859,7 @@
                 <a:ea typeface="Aptos"/>
                 <a:cs typeface="Aptos"/>
               </a:rPr>
-              <a:t>Artefact à montrer: attention_blouse_examples.png</a:t>
+              <a:t>Artefact � montrer: attention_blouse_examples.png</a:t>
             </a:r>
           </a:p>
         </p:txBody>
@@ -11363,7 +12869,7 @@
           <p:cNvPr id="3" name="">
             <a:extLst xmlns:a="http://schemas.openxmlformats.org/drawingml/2006/main">
               <a:ext uri="{FF2B5EF4-FFF2-40B4-BE49-F238E27FC236}">
-                <a16:creationId xmlns:a16="http://schemas.microsoft.com/office/drawing/2014/main" id="{0F27FB63-A4FE-45EE-8324-60760C852A63}"/>
+                <a16:creationId xmlns:a16="http://schemas.microsoft.com/office/drawing/2014/main" id="{DE01313D-187D-4193-A0E3-5F135786C07E}"/>
               </a:ext>
             </a:extLst>
           </p:cNvPr>
@@ -11427,7 +12933,7 @@
           <p:cNvPr id="4" name="">
             <a:extLst xmlns:a="http://schemas.openxmlformats.org/drawingml/2006/main">
               <a:ext uri="{FF2B5EF4-FFF2-40B4-BE49-F238E27FC236}">
-                <a16:creationId xmlns:a16="http://schemas.microsoft.com/office/drawing/2014/main" id="{21A8DC9D-4115-4585-8EAB-6B3FF2CCBDC9}"/>
+                <a16:creationId xmlns:a16="http://schemas.microsoft.com/office/drawing/2014/main" id="{B7033E77-54A4-4ACD-806B-32F108F54362}"/>
               </a:ext>
             </a:extLst>
           </p:cNvPr>
@@ -11462,7 +12968,7 @@
           <p:cNvPr id="5" name="">
             <a:extLst xmlns:a="http://schemas.openxmlformats.org/drawingml/2006/main">
               <a:ext uri="{FF2B5EF4-FFF2-40B4-BE49-F238E27FC236}">
-                <a16:creationId xmlns:a16="http://schemas.microsoft.com/office/drawing/2014/main" id="{A17C645E-7A3B-48D8-A271-348B356085C9}"/>
+                <a16:creationId xmlns:a16="http://schemas.microsoft.com/office/drawing/2014/main" id="{E92AE431-B991-4F04-91D5-E01E6127EC4D}"/>
               </a:ext>
             </a:extLst>
           </p:cNvPr>
@@ -11526,7 +13032,7 @@
           <p:cNvPr id="6" name="">
             <a:extLst xmlns:a="http://schemas.openxmlformats.org/drawingml/2006/main">
               <a:ext uri="{FF2B5EF4-FFF2-40B4-BE49-F238E27FC236}">
-                <a16:creationId xmlns:a16="http://schemas.microsoft.com/office/drawing/2014/main" id="{0488BE36-252E-492C-8498-DA4B4A42BC06}"/>
+                <a16:creationId xmlns:a16="http://schemas.microsoft.com/office/drawing/2014/main" id="{314F18B0-285E-473D-850F-5CF41D1AD1A7}"/>
               </a:ext>
             </a:extLst>
           </p:cNvPr>
@@ -11580,7 +13086,7 @@
                 <a:ea typeface="Aptos Display"/>
                 <a:cs typeface="Aptos Display"/>
               </a:rPr>
-              <a:t>Attention et blouse modifient la sensibilité d'alerte, pas le danger physique.</a:t>
+              <a:t>Attention et blouse modifient la sensibilit� d'alerte, pas le danger physique.</a:t>
             </a:r>
           </a:p>
         </p:txBody>
@@ -11594,7 +13100,7 @@
           <p:nvPr/>
         </p:nvPicPr>
         <p:blipFill>
-          <a:blip xmlns:r="http://schemas.openxmlformats.org/officeDocument/2006/relationships" xmlns:a="http://schemas.openxmlformats.org/drawingml/2006/main" r:embed="R9e0836835ab447d4"/>
+          <a:blip xmlns:r="http://schemas.openxmlformats.org/officeDocument/2006/relationships" xmlns:a="http://schemas.openxmlformats.org/drawingml/2006/main" r:embed="R87709055af034292"/>
           <a:stretch xmlns:a="http://schemas.openxmlformats.org/drawingml/2006/main"/>
         </p:blipFill>
         <p:spPr>
@@ -11612,7 +13118,7 @@
           <p:cNvPr id="8" name="">
             <a:extLst xmlns:a="http://schemas.openxmlformats.org/drawingml/2006/main">
               <a:ext uri="{FF2B5EF4-FFF2-40B4-BE49-F238E27FC236}">
-                <a16:creationId xmlns:a16="http://schemas.microsoft.com/office/drawing/2014/main" id="{ED78F036-45B4-4F2F-80F1-2A44C8566ABE}"/>
+                <a16:creationId xmlns:a16="http://schemas.microsoft.com/office/drawing/2014/main" id="{8A6D58E2-16E5-462E-BCF1-FA44EE92BE0F}"/>
               </a:ext>
             </a:extLst>
           </p:cNvPr>
@@ -11645,7 +13151,7 @@
           <p:cNvPr id="9" name="">
             <a:extLst xmlns:a="http://schemas.openxmlformats.org/drawingml/2006/main">
               <a:ext uri="{FF2B5EF4-FFF2-40B4-BE49-F238E27FC236}">
-                <a16:creationId xmlns:a16="http://schemas.microsoft.com/office/drawing/2014/main" id="{DF0CC4D2-2FA3-4E02-BDA6-D73894CBB0DB}"/>
+                <a16:creationId xmlns:a16="http://schemas.microsoft.com/office/drawing/2014/main" id="{258D3542-D95F-4451-A005-D3E42032453D}"/>
               </a:ext>
             </a:extLst>
           </p:cNvPr>
@@ -11783,7 +13289,7 @@
           <p:cNvPr id="10" name="">
             <a:extLst xmlns:a="http://schemas.openxmlformats.org/drawingml/2006/main">
               <a:ext uri="{FF2B5EF4-FFF2-40B4-BE49-F238E27FC236}">
-                <a16:creationId xmlns:a16="http://schemas.microsoft.com/office/drawing/2014/main" id="{FE9751C1-E0EE-4980-AED4-4FBE1031EF8C}"/>
+                <a16:creationId xmlns:a16="http://schemas.microsoft.com/office/drawing/2014/main" id="{52ED7C03-07D1-48B9-9DDD-F106DBC6962F}"/>
               </a:ext>
             </a:extLst>
           </p:cNvPr>
@@ -11837,7 +13343,7 @@
                 <a:ea typeface="Aptos"/>
                 <a:cs typeface="Aptos"/>
               </a:rPr>
-              <a:t>C'est un choix de politique: si le risque physique est déjà non nul, une attention distraite ou une blouse non conforme peut baisser le seuil d'alerte.</a:t>
+              <a:t>C'est un choix de politique: si le risque physique est d�j� non nul, une attention distraite ou une blouse non conforme peut baisser le seuil d'alerte.</a:t>
             </a:r>
           </a:p>
         </p:txBody>
@@ -11845,7 +13351,7 @@
     </p:spTree>
     <p:extLst>
       <p:ext uri="{BB962C8B-B14F-4D97-AF65-F5344CB8AC3E}">
-        <p14:creationId xmlns:p14="http://schemas.microsoft.com/office/powerpoint/2010/main" val="1142474256"/>
+        <p14:creationId xmlns:p14="http://schemas.microsoft.com/office/powerpoint/2010/main" val="2089683249"/>
       </p:ext>
     </p:extLst>
   </p:cSld>

</xml_diff>